<commit_message>
Add Aman Verma to presentation team
</commit_message>
<xml_diff>
--- a/docs/presentation/RideX-Ideathon-Presentation.pptx
+++ b/docs/presentation/RideX-Ideathon-Presentation.pptx
@@ -2,24 +2,24 @@
 <file path=ppt/presentation.xml><?xml version="1.0" encoding="utf-8"?>
 <p:presentation xmlns:p="http://schemas.openxmlformats.org/presentationml/2006/main">
   <p:sldMasterIdLst>
-    <p:sldMasterId xmlns:r="http://schemas.openxmlformats.org/officeDocument/2006/relationships" id="2147483648" r:id="Rb1922a03094e4c90"/>
+    <p:sldMasterId xmlns:r="http://schemas.openxmlformats.org/officeDocument/2006/relationships" id="2147483648" r:id="R75b04baa955c4d38"/>
   </p:sldMasterIdLst>
   <p:notesMasterIdLst>
-    <p:notesMasterId xmlns:r="http://schemas.openxmlformats.org/officeDocument/2006/relationships" r:id="R085a8376e0384cf2"/>
+    <p:notesMasterId xmlns:r="http://schemas.openxmlformats.org/officeDocument/2006/relationships" r:id="R931a19c84f0744a3"/>
   </p:notesMasterIdLst>
   <p:sldIdLst>
-    <p:sldId xmlns:r="http://schemas.openxmlformats.org/officeDocument/2006/relationships" id="256" r:id="R2912cbec8e5f4983"/>
-    <p:sldId xmlns:r="http://schemas.openxmlformats.org/officeDocument/2006/relationships" id="257" r:id="R8ba2ceb6d6a74b0d"/>
-    <p:sldId xmlns:r="http://schemas.openxmlformats.org/officeDocument/2006/relationships" id="258" r:id="R381d7167e00a45b7"/>
-    <p:sldId xmlns:r="http://schemas.openxmlformats.org/officeDocument/2006/relationships" id="259" r:id="R190b1969cf5b45da"/>
-    <p:sldId xmlns:r="http://schemas.openxmlformats.org/officeDocument/2006/relationships" id="260" r:id="R940d3dece590414c"/>
-    <p:sldId xmlns:r="http://schemas.openxmlformats.org/officeDocument/2006/relationships" id="261" r:id="R4e09dbab97814487"/>
-    <p:sldId xmlns:r="http://schemas.openxmlformats.org/officeDocument/2006/relationships" id="262" r:id="R6b9500f00f9f462e"/>
-    <p:sldId xmlns:r="http://schemas.openxmlformats.org/officeDocument/2006/relationships" id="263" r:id="Rcafa3c5cdc9a470f"/>
-    <p:sldId xmlns:r="http://schemas.openxmlformats.org/officeDocument/2006/relationships" id="264" r:id="R771288c76b974072"/>
-    <p:sldId xmlns:r="http://schemas.openxmlformats.org/officeDocument/2006/relationships" id="265" r:id="R8136e298544f480e"/>
-    <p:sldId xmlns:r="http://schemas.openxmlformats.org/officeDocument/2006/relationships" id="266" r:id="R63844fba94e549db"/>
-    <p:sldId xmlns:r="http://schemas.openxmlformats.org/officeDocument/2006/relationships" id="267" r:id="R566a64fa31634b17"/>
+    <p:sldId xmlns:r="http://schemas.openxmlformats.org/officeDocument/2006/relationships" id="256" r:id="R84ce84ed2a0e47ca"/>
+    <p:sldId xmlns:r="http://schemas.openxmlformats.org/officeDocument/2006/relationships" id="257" r:id="R38d48fcc666e4eb2"/>
+    <p:sldId xmlns:r="http://schemas.openxmlformats.org/officeDocument/2006/relationships" id="258" r:id="R06427f8b4b2c4bf5"/>
+    <p:sldId xmlns:r="http://schemas.openxmlformats.org/officeDocument/2006/relationships" id="259" r:id="Rb455e3390a444772"/>
+    <p:sldId xmlns:r="http://schemas.openxmlformats.org/officeDocument/2006/relationships" id="260" r:id="R76d5f440d7894cbb"/>
+    <p:sldId xmlns:r="http://schemas.openxmlformats.org/officeDocument/2006/relationships" id="261" r:id="R9e1f34a415a34381"/>
+    <p:sldId xmlns:r="http://schemas.openxmlformats.org/officeDocument/2006/relationships" id="262" r:id="R23f1b9271d234aed"/>
+    <p:sldId xmlns:r="http://schemas.openxmlformats.org/officeDocument/2006/relationships" id="263" r:id="R590692307e3d465c"/>
+    <p:sldId xmlns:r="http://schemas.openxmlformats.org/officeDocument/2006/relationships" id="264" r:id="R40752932c8fc4948"/>
+    <p:sldId xmlns:r="http://schemas.openxmlformats.org/officeDocument/2006/relationships" id="265" r:id="Ra9d3c964f69e4030"/>
+    <p:sldId xmlns:r="http://schemas.openxmlformats.org/officeDocument/2006/relationships" id="266" r:id="R37996e5843244d9e"/>
+    <p:sldId xmlns:r="http://schemas.openxmlformats.org/officeDocument/2006/relationships" id="267" r:id="R4f1bcb14f2204225"/>
   </p:sldIdLst>
   <p:sldSz cx="12192000" cy="6858000"/>
   <p:notesSz cx="6858000" cy="9144000"/>
@@ -1330,7 +1330,7 @@
           <p:cNvPr id="3" name="Title">
             <a:extLst xmlns:a="http://schemas.openxmlformats.org/drawingml/2006/main">
               <a:ext uri="{FF2B5EF4-FFF2-40B4-BE49-F238E27FC236}">
-                <a16:creationId xmlns:a16="http://schemas.microsoft.com/office/drawing/2014/main" id="{CD542507-4297-4D66-94B5-65116E5CDDF4}"/>
+                <a16:creationId xmlns:a16="http://schemas.microsoft.com/office/drawing/2014/main" id="{4CE3C5F9-554A-4D9B-8BB3-3863B121B78A}"/>
               </a:ext>
             </a:extLst>
           </p:cNvPr>
@@ -1487,7 +1487,7 @@
           <p:cNvPr id="2" name="Subtitle">
             <a:extLst xmlns:a="http://schemas.openxmlformats.org/drawingml/2006/main">
               <a:ext uri="{FF2B5EF4-FFF2-40B4-BE49-F238E27FC236}">
-                <a16:creationId xmlns:a16="http://schemas.microsoft.com/office/drawing/2014/main" id="{AD0737CE-CEB6-492A-A5DD-F92931D9F498}"/>
+                <a16:creationId xmlns:a16="http://schemas.microsoft.com/office/drawing/2014/main" id="{0AA266E9-1FFC-4BEF-9301-0999CC9FB211}"/>
               </a:ext>
             </a:extLst>
           </p:cNvPr>
@@ -1661,7 +1661,7 @@
           <p:cNvPr id="2" name="Section title">
             <a:extLst xmlns:a="http://schemas.openxmlformats.org/drawingml/2006/main">
               <a:ext uri="{FF2B5EF4-FFF2-40B4-BE49-F238E27FC236}">
-                <a16:creationId xmlns:a16="http://schemas.microsoft.com/office/drawing/2014/main" id="{5DD65E26-34C5-4B64-8C00-37B574CD3567}"/>
+                <a16:creationId xmlns:a16="http://schemas.microsoft.com/office/drawing/2014/main" id="{6738671D-4B4C-4043-97EC-275301DEC579}"/>
               </a:ext>
             </a:extLst>
           </p:cNvPr>
@@ -1835,7 +1835,7 @@
           <p:cNvPr id="3" name="Title">
             <a:extLst xmlns:a="http://schemas.openxmlformats.org/drawingml/2006/main">
               <a:ext uri="{FF2B5EF4-FFF2-40B4-BE49-F238E27FC236}">
-                <a16:creationId xmlns:a16="http://schemas.microsoft.com/office/drawing/2014/main" id="{9667DB08-6C5B-4E9E-B6C5-0D76936E90AB}"/>
+                <a16:creationId xmlns:a16="http://schemas.microsoft.com/office/drawing/2014/main" id="{CD1F93DA-BFF4-4C4E-B93B-B41FDB8839AC}"/>
               </a:ext>
             </a:extLst>
           </p:cNvPr>
@@ -1992,7 +1992,7 @@
           <p:cNvPr id="2" name="Body">
             <a:extLst xmlns:a="http://schemas.openxmlformats.org/drawingml/2006/main">
               <a:ext uri="{FF2B5EF4-FFF2-40B4-BE49-F238E27FC236}">
-                <a16:creationId xmlns:a16="http://schemas.microsoft.com/office/drawing/2014/main" id="{357EE2B7-A0F3-4E65-9B41-4D2BEC2061ED}"/>
+                <a16:creationId xmlns:a16="http://schemas.microsoft.com/office/drawing/2014/main" id="{5EF662EE-61C8-4E04-8F63-273109667FAC}"/>
               </a:ext>
             </a:extLst>
           </p:cNvPr>
@@ -2166,7 +2166,7 @@
           <p:cNvPr id="4" name="Title">
             <a:extLst xmlns:a="http://schemas.openxmlformats.org/drawingml/2006/main">
               <a:ext uri="{FF2B5EF4-FFF2-40B4-BE49-F238E27FC236}">
-                <a16:creationId xmlns:a16="http://schemas.microsoft.com/office/drawing/2014/main" id="{29981B43-9406-4D80-B23E-B98DAAF5B618}"/>
+                <a16:creationId xmlns:a16="http://schemas.microsoft.com/office/drawing/2014/main" id="{2CF7B552-FA4E-4F91-994C-85EC34E6E15C}"/>
               </a:ext>
             </a:extLst>
           </p:cNvPr>
@@ -2323,7 +2323,7 @@
           <p:cNvPr id="2" name="Left column">
             <a:extLst xmlns:a="http://schemas.openxmlformats.org/drawingml/2006/main">
               <a:ext uri="{FF2B5EF4-FFF2-40B4-BE49-F238E27FC236}">
-                <a16:creationId xmlns:a16="http://schemas.microsoft.com/office/drawing/2014/main" id="{8FACFB5E-7297-484B-87C8-075F628C9EE7}"/>
+                <a16:creationId xmlns:a16="http://schemas.microsoft.com/office/drawing/2014/main" id="{00613218-1CCB-464D-BA76-8CB0C200FE38}"/>
               </a:ext>
             </a:extLst>
           </p:cNvPr>
@@ -2480,7 +2480,7 @@
           <p:cNvPr id="3" name="Right column">
             <a:extLst xmlns:a="http://schemas.openxmlformats.org/drawingml/2006/main">
               <a:ext uri="{FF2B5EF4-FFF2-40B4-BE49-F238E27FC236}">
-                <a16:creationId xmlns:a16="http://schemas.microsoft.com/office/drawing/2014/main" id="{10A3778A-DB3C-4B0E-A3E0-60B20FE20269}"/>
+                <a16:creationId xmlns:a16="http://schemas.microsoft.com/office/drawing/2014/main" id="{9D24E85C-F908-45E1-8197-B7340C4EE5B4}"/>
               </a:ext>
             </a:extLst>
           </p:cNvPr>
@@ -2654,7 +2654,7 @@
           <p:cNvPr id="3" name="Title">
             <a:extLst xmlns:a="http://schemas.openxmlformats.org/drawingml/2006/main">
               <a:ext uri="{FF2B5EF4-FFF2-40B4-BE49-F238E27FC236}">
-                <a16:creationId xmlns:a16="http://schemas.microsoft.com/office/drawing/2014/main" id="{5B8AB94D-3270-4A11-B49C-EAF07E86A291}"/>
+                <a16:creationId xmlns:a16="http://schemas.microsoft.com/office/drawing/2014/main" id="{E3AEBE91-80B5-4878-AA0B-D484C67F1663}"/>
               </a:ext>
             </a:extLst>
           </p:cNvPr>
@@ -2811,7 +2811,7 @@
           <p:cNvPr id="2" name="Left column">
             <a:extLst xmlns:a="http://schemas.openxmlformats.org/drawingml/2006/main">
               <a:ext uri="{FF2B5EF4-FFF2-40B4-BE49-F238E27FC236}">
-                <a16:creationId xmlns:a16="http://schemas.microsoft.com/office/drawing/2014/main" id="{B6784503-5A00-4C16-BC5A-DD0165432414}"/>
+                <a16:creationId xmlns:a16="http://schemas.microsoft.com/office/drawing/2014/main" id="{FA14D913-C050-43DF-8471-DC7041299E97}"/>
               </a:ext>
             </a:extLst>
           </p:cNvPr>
@@ -3006,12 +3006,12 @@
   </p:cSld>
   <p:clrMap bg1="lt1" tx1="dk1" bg2="lt2" tx2="dk2" accent1="accent1" accent2="accent2" accent3="accent3" accent4="accent4" accent5="accent5" accent6="accent6" hlink="hlink" folHlink="folHlink"/>
   <p:sldLayoutIdLst>
-    <p:sldLayoutId xmlns:r="http://schemas.openxmlformats.org/officeDocument/2006/relationships" id="2147483649" r:id="R46ea77d031bb4b7b"/>
-    <p:sldLayoutId xmlns:r="http://schemas.openxmlformats.org/officeDocument/2006/relationships" id="2147483650" r:id="R5e7b1d8d97c7430f"/>
-    <p:sldLayoutId xmlns:r="http://schemas.openxmlformats.org/officeDocument/2006/relationships" id="2147483651" r:id="Rbf7749aee38545cf"/>
-    <p:sldLayoutId xmlns:r="http://schemas.openxmlformats.org/officeDocument/2006/relationships" id="2147483652" r:id="R3e3fcdf6752d4fad"/>
-    <p:sldLayoutId xmlns:r="http://schemas.openxmlformats.org/officeDocument/2006/relationships" id="2147483653" r:id="Rdb4e9cc452d74b64"/>
-    <p:sldLayoutId xmlns:r="http://schemas.openxmlformats.org/officeDocument/2006/relationships" id="2147483654" r:id="Rb671d488003f479d"/>
+    <p:sldLayoutId xmlns:r="http://schemas.openxmlformats.org/officeDocument/2006/relationships" id="2147483649" r:id="R4d0684a4369c4723"/>
+    <p:sldLayoutId xmlns:r="http://schemas.openxmlformats.org/officeDocument/2006/relationships" id="2147483650" r:id="R17cd5a6d3c294aca"/>
+    <p:sldLayoutId xmlns:r="http://schemas.openxmlformats.org/officeDocument/2006/relationships" id="2147483651" r:id="R5cee28230db44dd6"/>
+    <p:sldLayoutId xmlns:r="http://schemas.openxmlformats.org/officeDocument/2006/relationships" id="2147483652" r:id="Rc1340c2726d4442b"/>
+    <p:sldLayoutId xmlns:r="http://schemas.openxmlformats.org/officeDocument/2006/relationships" id="2147483653" r:id="R2c636234b5804761"/>
+    <p:sldLayoutId xmlns:r="http://schemas.openxmlformats.org/officeDocument/2006/relationships" id="2147483654" r:id="R5bc13a92f41e49b3"/>
   </p:sldLayoutIdLst>
   <p:txStyles>
     <p:titleStyle>
@@ -3562,7 +3562,7 @@
           <p:cNvPr id="7" name="">
             <a:extLst xmlns:a="http://schemas.openxmlformats.org/drawingml/2006/main">
               <a:ext uri="{FF2B5EF4-FFF2-40B4-BE49-F238E27FC236}">
-                <a16:creationId xmlns:a16="http://schemas.microsoft.com/office/drawing/2014/main" id="{A2BAA5E2-AFDF-43F9-A75D-90889EA7A389}"/>
+                <a16:creationId xmlns:a16="http://schemas.microsoft.com/office/drawing/2014/main" id="{FB422768-15FA-4A2F-8981-69A4941E7650}"/>
               </a:ext>
             </a:extLst>
           </p:cNvPr>
@@ -3628,7 +3628,7 @@
           <p:cNvPr id="2" name="">
             <a:extLst xmlns:a="http://schemas.openxmlformats.org/drawingml/2006/main">
               <a:ext uri="{FF2B5EF4-FFF2-40B4-BE49-F238E27FC236}">
-                <a16:creationId xmlns:a16="http://schemas.microsoft.com/office/drawing/2014/main" id="{BCD939D5-0B0C-46EA-8517-B3919DFAD4CB}"/>
+                <a16:creationId xmlns:a16="http://schemas.microsoft.com/office/drawing/2014/main" id="{1808DF11-EA40-48E8-9376-B702442F7294}"/>
               </a:ext>
             </a:extLst>
           </p:cNvPr>
@@ -3694,7 +3694,7 @@
           <p:cNvPr id="3" name="">
             <a:extLst xmlns:a="http://schemas.openxmlformats.org/drawingml/2006/main">
               <a:ext uri="{FF2B5EF4-FFF2-40B4-BE49-F238E27FC236}">
-                <a16:creationId xmlns:a16="http://schemas.microsoft.com/office/drawing/2014/main" id="{B0D4C862-CA3D-4179-9B58-07EB1CB0D9C3}"/>
+                <a16:creationId xmlns:a16="http://schemas.microsoft.com/office/drawing/2014/main" id="{C0BEA5F2-0A79-4FA2-9964-F862EBE4390A}"/>
               </a:ext>
             </a:extLst>
           </p:cNvPr>
@@ -3760,7 +3760,7 @@
           <p:cNvPr id="4" name="">
             <a:extLst xmlns:a="http://schemas.openxmlformats.org/drawingml/2006/main">
               <a:ext uri="{FF2B5EF4-FFF2-40B4-BE49-F238E27FC236}">
-                <a16:creationId xmlns:a16="http://schemas.microsoft.com/office/drawing/2014/main" id="{18D91A33-4F0B-4E67-BF20-B22CFA7E2E45}"/>
+                <a16:creationId xmlns:a16="http://schemas.microsoft.com/office/drawing/2014/main" id="{34DF4802-F43A-4CC2-AA3D-7051D1B9252D}"/>
               </a:ext>
             </a:extLst>
           </p:cNvPr>
@@ -3849,7 +3849,7 @@
           <p:cNvPr id="5" name="">
             <a:extLst xmlns:a="http://schemas.openxmlformats.org/drawingml/2006/main">
               <a:ext uri="{FF2B5EF4-FFF2-40B4-BE49-F238E27FC236}">
-                <a16:creationId xmlns:a16="http://schemas.microsoft.com/office/drawing/2014/main" id="{C645980D-2ADE-412A-9154-50080D536AB2}"/>
+                <a16:creationId xmlns:a16="http://schemas.microsoft.com/office/drawing/2014/main" id="{8DFBE67A-DC5D-43F6-B71F-801E14FD3F4A}"/>
               </a:ext>
             </a:extLst>
           </p:cNvPr>
@@ -3938,7 +3938,7 @@
           <p:cNvPr id="6" name="">
             <a:extLst xmlns:a="http://schemas.openxmlformats.org/drawingml/2006/main">
               <a:ext uri="{FF2B5EF4-FFF2-40B4-BE49-F238E27FC236}">
-                <a16:creationId xmlns:a16="http://schemas.microsoft.com/office/drawing/2014/main" id="{04307F09-CB37-4EAB-8D01-37CDDE1633F7}"/>
+                <a16:creationId xmlns:a16="http://schemas.microsoft.com/office/drawing/2014/main" id="{8DA645CA-E437-428B-8B56-4AF75C14A805}"/>
               </a:ext>
             </a:extLst>
           </p:cNvPr>
@@ -3948,7 +3948,7 @@
           <p:nvPr/>
         </p:nvPicPr>
         <p:blipFill>
-          <a:blip xmlns:r="http://schemas.openxmlformats.org/officeDocument/2006/relationships" xmlns:a="http://schemas.openxmlformats.org/drawingml/2006/main" r:embed="Rf57a6e9582de4e1b"/>
+          <a:blip xmlns:r="http://schemas.openxmlformats.org/officeDocument/2006/relationships" xmlns:a="http://schemas.openxmlformats.org/drawingml/2006/main" r:embed="Raa6c7deebf7a4212"/>
           <a:stretch xmlns:a="http://schemas.openxmlformats.org/drawingml/2006/main"/>
         </p:blipFill>
         <p:spPr>
@@ -3964,7 +3964,7 @@
     </p:spTree>
     <p:extLst>
       <p:ext uri="{BB962C8B-B14F-4D97-AF65-F5344CB8AC3E}">
-        <p14:creationId xmlns:p14="http://schemas.microsoft.com/office/powerpoint/2010/main" val="1278670144"/>
+        <p14:creationId xmlns:p14="http://schemas.microsoft.com/office/powerpoint/2010/main" val="995620915"/>
       </p:ext>
     </p:extLst>
   </p:cSld>
@@ -3995,7 +3995,7 @@
           <p:cNvPr id="9" name="">
             <a:extLst xmlns:a="http://schemas.openxmlformats.org/drawingml/2006/main">
               <a:ext uri="{FF2B5EF4-FFF2-40B4-BE49-F238E27FC236}">
-                <a16:creationId xmlns:a16="http://schemas.microsoft.com/office/drawing/2014/main" id="{8F9FB4C9-F791-4090-B82D-AC105735D4C9}"/>
+                <a16:creationId xmlns:a16="http://schemas.microsoft.com/office/drawing/2014/main" id="{41A643B9-E546-4ECB-A33E-E3C2DF99BAE2}"/>
               </a:ext>
             </a:extLst>
           </p:cNvPr>
@@ -4061,7 +4061,7 @@
           <p:cNvPr id="2" name="">
             <a:extLst xmlns:a="http://schemas.openxmlformats.org/drawingml/2006/main">
               <a:ext uri="{FF2B5EF4-FFF2-40B4-BE49-F238E27FC236}">
-                <a16:creationId xmlns:a16="http://schemas.microsoft.com/office/drawing/2014/main" id="{8E165DB1-D8C1-4ABF-9713-CDDF0F0E75AE}"/>
+                <a16:creationId xmlns:a16="http://schemas.microsoft.com/office/drawing/2014/main" id="{8671DCAA-814C-43A2-A75F-F430434FE100}"/>
               </a:ext>
             </a:extLst>
           </p:cNvPr>
@@ -4127,7 +4127,7 @@
           <p:cNvPr id="3" name="">
             <a:extLst xmlns:a="http://schemas.openxmlformats.org/drawingml/2006/main">
               <a:ext uri="{FF2B5EF4-FFF2-40B4-BE49-F238E27FC236}">
-                <a16:creationId xmlns:a16="http://schemas.microsoft.com/office/drawing/2014/main" id="{587ACE1E-6E5B-4E2D-90C2-E26304CF2499}"/>
+                <a16:creationId xmlns:a16="http://schemas.microsoft.com/office/drawing/2014/main" id="{BBB152F4-BDEB-40D4-A850-C25F9C7B9F2F}"/>
               </a:ext>
             </a:extLst>
           </p:cNvPr>
@@ -4193,7 +4193,7 @@
           <p:cNvPr id="4" name="">
             <a:extLst xmlns:a="http://schemas.openxmlformats.org/drawingml/2006/main">
               <a:ext uri="{FF2B5EF4-FFF2-40B4-BE49-F238E27FC236}">
-                <a16:creationId xmlns:a16="http://schemas.microsoft.com/office/drawing/2014/main" id="{316121FA-11D8-4F11-A317-52FA5EA03A3A}"/>
+                <a16:creationId xmlns:a16="http://schemas.microsoft.com/office/drawing/2014/main" id="{8B61133D-CF53-4C72-BE6E-5D9C5F5C4CCC}"/>
               </a:ext>
             </a:extLst>
           </p:cNvPr>
@@ -4259,7 +4259,7 @@
           <p:cNvPr id="5" name="">
             <a:extLst xmlns:a="http://schemas.openxmlformats.org/drawingml/2006/main">
               <a:ext uri="{FF2B5EF4-FFF2-40B4-BE49-F238E27FC236}">
-                <a16:creationId xmlns:a16="http://schemas.microsoft.com/office/drawing/2014/main" id="{060AA4E6-3EB4-40E2-B385-6A90B8DA1168}"/>
+                <a16:creationId xmlns:a16="http://schemas.microsoft.com/office/drawing/2014/main" id="{433DC691-D2EB-4E15-BCDC-D22DEFFE1D00}"/>
               </a:ext>
             </a:extLst>
           </p:cNvPr>
@@ -4417,7 +4417,7 @@
           <p:cNvPr id="6" name="">
             <a:extLst xmlns:a="http://schemas.openxmlformats.org/drawingml/2006/main">
               <a:ext uri="{FF2B5EF4-FFF2-40B4-BE49-F238E27FC236}">
-                <a16:creationId xmlns:a16="http://schemas.microsoft.com/office/drawing/2014/main" id="{31580D5B-773F-4358-B57B-D7FEB2691358}"/>
+                <a16:creationId xmlns:a16="http://schemas.microsoft.com/office/drawing/2014/main" id="{741A3744-140D-46CD-8123-02F22D05350C}"/>
               </a:ext>
             </a:extLst>
           </p:cNvPr>
@@ -4483,7 +4483,7 @@
           <p:cNvPr id="7" name="">
             <a:extLst xmlns:a="http://schemas.openxmlformats.org/drawingml/2006/main">
               <a:ext uri="{FF2B5EF4-FFF2-40B4-BE49-F238E27FC236}">
-                <a16:creationId xmlns:a16="http://schemas.microsoft.com/office/drawing/2014/main" id="{FA1052A5-0A44-4F8A-B67D-659154906230}"/>
+                <a16:creationId xmlns:a16="http://schemas.microsoft.com/office/drawing/2014/main" id="{53B65E20-CA8E-424A-8FEC-79EB536A98B8}"/>
               </a:ext>
             </a:extLst>
           </p:cNvPr>
@@ -4641,7 +4641,7 @@
           <p:cNvPr id="8" name="">
             <a:extLst xmlns:a="http://schemas.openxmlformats.org/drawingml/2006/main">
               <a:ext uri="{FF2B5EF4-FFF2-40B4-BE49-F238E27FC236}">
-                <a16:creationId xmlns:a16="http://schemas.microsoft.com/office/drawing/2014/main" id="{9CFBC245-A461-46C0-8BC0-E95D4810D5B7}"/>
+                <a16:creationId xmlns:a16="http://schemas.microsoft.com/office/drawing/2014/main" id="{39BF71CB-6574-4E66-A079-A2AB0C54A3B7}"/>
               </a:ext>
             </a:extLst>
           </p:cNvPr>
@@ -4705,7 +4705,7 @@
     </p:spTree>
     <p:extLst>
       <p:ext uri="{BB962C8B-B14F-4D97-AF65-F5344CB8AC3E}">
-        <p14:creationId xmlns:p14="http://schemas.microsoft.com/office/powerpoint/2010/main" val="1865414387"/>
+        <p14:creationId xmlns:p14="http://schemas.microsoft.com/office/powerpoint/2010/main" val="763658201"/>
       </p:ext>
     </p:extLst>
   </p:cSld>
@@ -4733,10 +4733,10 @@
       </p:grpSpPr>
       <p:sp>
         <p:nvSpPr>
-          <p:cNvPr id="8" name="">
-            <a:extLst xmlns:a="http://schemas.openxmlformats.org/drawingml/2006/main">
-              <a:ext uri="{FF2B5EF4-FFF2-40B4-BE49-F238E27FC236}">
-                <a16:creationId xmlns:a16="http://schemas.microsoft.com/office/drawing/2014/main" id="{1ACDF07E-B300-4A9C-886E-319D0C57D750}"/>
+          <p:cNvPr id="9" name="">
+            <a:extLst xmlns:a="http://schemas.openxmlformats.org/drawingml/2006/main">
+              <a:ext uri="{FF2B5EF4-FFF2-40B4-BE49-F238E27FC236}">
+                <a16:creationId xmlns:a16="http://schemas.microsoft.com/office/drawing/2014/main" id="{6EBECC1B-15E1-4907-8414-1FF39C4E627D}"/>
               </a:ext>
             </a:extLst>
           </p:cNvPr>
@@ -4802,7 +4802,7 @@
           <p:cNvPr id="2" name="">
             <a:extLst xmlns:a="http://schemas.openxmlformats.org/drawingml/2006/main">
               <a:ext uri="{FF2B5EF4-FFF2-40B4-BE49-F238E27FC236}">
-                <a16:creationId xmlns:a16="http://schemas.microsoft.com/office/drawing/2014/main" id="{25F83624-9425-4279-91A6-8A474BEDAA8C}"/>
+                <a16:creationId xmlns:a16="http://schemas.microsoft.com/office/drawing/2014/main" id="{76D8B45A-B8D0-4694-876A-AC64F5AE8FD0}"/>
               </a:ext>
             </a:extLst>
           </p:cNvPr>
@@ -4868,7 +4868,7 @@
           <p:cNvPr id="3" name="">
             <a:extLst xmlns:a="http://schemas.openxmlformats.org/drawingml/2006/main">
               <a:ext uri="{FF2B5EF4-FFF2-40B4-BE49-F238E27FC236}">
-                <a16:creationId xmlns:a16="http://schemas.microsoft.com/office/drawing/2014/main" id="{65C38CAA-4AFD-4E44-931F-0274CE0632DB}"/>
+                <a16:creationId xmlns:a16="http://schemas.microsoft.com/office/drawing/2014/main" id="{831878BF-EC5C-422C-B51C-97755C85EA9E}"/>
               </a:ext>
             </a:extLst>
           </p:cNvPr>
@@ -4934,7 +4934,7 @@
           <p:cNvPr id="4" name="">
             <a:extLst xmlns:a="http://schemas.openxmlformats.org/drawingml/2006/main">
               <a:ext uri="{FF2B5EF4-FFF2-40B4-BE49-F238E27FC236}">
-                <a16:creationId xmlns:a16="http://schemas.microsoft.com/office/drawing/2014/main" id="{4D6DEE8B-0706-4FF3-8DB4-D4657245AE6B}"/>
+                <a16:creationId xmlns:a16="http://schemas.microsoft.com/office/drawing/2014/main" id="{2B32739C-5197-4269-9F27-48280990150F}"/>
               </a:ext>
             </a:extLst>
           </p:cNvPr>
@@ -5000,7 +5000,7 @@
           <p:cNvPr id="5" name="">
             <a:extLst xmlns:a="http://schemas.openxmlformats.org/drawingml/2006/main">
               <a:ext uri="{FF2B5EF4-FFF2-40B4-BE49-F238E27FC236}">
-                <a16:creationId xmlns:a16="http://schemas.microsoft.com/office/drawing/2014/main" id="{158E4BC0-ABCF-4B44-A2C1-F56919C0750B}"/>
+                <a16:creationId xmlns:a16="http://schemas.microsoft.com/office/drawing/2014/main" id="{9D07EF46-C19F-4537-BB09-19D0A9E1115A}"/>
               </a:ext>
             </a:extLst>
           </p:cNvPr>
@@ -5140,7 +5140,7 @@
           <p:cNvPr id="6" name="">
             <a:extLst xmlns:a="http://schemas.openxmlformats.org/drawingml/2006/main">
               <a:ext uri="{FF2B5EF4-FFF2-40B4-BE49-F238E27FC236}">
-                <a16:creationId xmlns:a16="http://schemas.microsoft.com/office/drawing/2014/main" id="{EF875F73-D8CF-4186-8BA2-032F03D6D803}"/>
+                <a16:creationId xmlns:a16="http://schemas.microsoft.com/office/drawing/2014/main" id="{99484195-C616-470C-887C-8E617E81796B}"/>
               </a:ext>
             </a:extLst>
           </p:cNvPr>
@@ -5280,7 +5280,73 @@
           <p:cNvPr id="7" name="">
             <a:extLst xmlns:a="http://schemas.openxmlformats.org/drawingml/2006/main">
               <a:ext uri="{FF2B5EF4-FFF2-40B4-BE49-F238E27FC236}">
-                <a16:creationId xmlns:a16="http://schemas.microsoft.com/office/drawing/2014/main" id="{903EEABB-9E29-4F89-A466-EEBE837BC052}"/>
+                <a16:creationId xmlns:a16="http://schemas.microsoft.com/office/drawing/2014/main" id="{EC767183-BCD3-4069-9F66-261B6E9B64B8}"/>
+              </a:ext>
+            </a:extLst>
+          </p:cNvPr>
+          <p:cNvSpPr>
+            <a:spLocks xmlns:a="http://schemas.openxmlformats.org/drawingml/2006/main" noGrp="1"/>
+          </p:cNvSpPr>
+          <p:nvPr/>
+        </p:nvSpPr>
+        <p:spPr>
+          <a:xfrm xmlns:a="http://schemas.openxmlformats.org/drawingml/2006/main">
+            <a:off x="619125" y="4857750"/>
+            <a:ext cx="10858500" cy="428625"/>
+          </a:xfrm>
+          <a:prstGeom xmlns:a="http://schemas.openxmlformats.org/drawingml/2006/main" prst="rect">
+            <a:avLst/>
+          </a:prstGeom>
+          <a:noFill xmlns:a="http://schemas.openxmlformats.org/drawingml/2006/main"/>
+          <a:ln xmlns:a="http://schemas.openxmlformats.org/drawingml/2006/main" w="0">
+            <a:noFill/>
+          </a:ln>
+        </p:spPr>
+        <p:txBody>
+          <a:bodyPr xmlns:a="http://schemas.openxmlformats.org/drawingml/2006/main"/>
+          <a:lstStyle xmlns:a="http://schemas.openxmlformats.org/drawingml/2006/main">
+            <a:defPPr>
+              <a:defRPr sz="2100" b="0">
+                <a:solidFill>
+                  <a:srgbClr val="08243D"/>
+                </a:solidFill>
+                <a:latin typeface="Arial"/>
+                <a:ea typeface="Arial"/>
+                <a:cs typeface="Arial"/>
+              </a:defRPr>
+            </a:defPPr>
+          </a:lstStyle>
+          <a:p xmlns:a="http://schemas.openxmlformats.org/drawingml/2006/main">
+            <a:pPr>
+              <a:defRPr sz="2100" b="0">
+                <a:solidFill>
+                  <a:srgbClr val="08243D"/>
+                </a:solidFill>
+                <a:latin typeface="Arial"/>
+                <a:ea typeface="Arial"/>
+                <a:cs typeface="Arial"/>
+              </a:defRPr>
+            </a:pPr>
+            <a:r>
+              <a:rPr sz="2100" b="0">
+                <a:solidFill>
+                  <a:srgbClr val="08243D"/>
+                </a:solidFill>
+                <a:latin typeface="Arial"/>
+                <a:ea typeface="Arial"/>
+                <a:cs typeface="Arial"/>
+              </a:rPr>
+              <a:t>Aman Verma   (Aman-verma-crypto)</a:t>
+            </a:r>
+          </a:p>
+        </p:txBody>
+      </p:sp>
+      <p:sp>
+        <p:nvSpPr>
+          <p:cNvPr id="8" name="">
+            <a:extLst xmlns:a="http://schemas.openxmlformats.org/drawingml/2006/main">
+              <a:ext uri="{FF2B5EF4-FFF2-40B4-BE49-F238E27FC236}">
+                <a16:creationId xmlns:a16="http://schemas.microsoft.com/office/drawing/2014/main" id="{EFCC2794-EEBD-43ED-8038-8D838289C4F2}"/>
               </a:ext>
             </a:extLst>
           </p:cNvPr>
@@ -5336,7 +5402,7 @@
                 <a:ea typeface="Arial"/>
                 <a:cs typeface="Arial"/>
               </a:rPr>
-              <a:t>Two member names and individual contributions await team confirmation.</a:t>
+              <a:t>One member name and individual contributions await team confirmation.</a:t>
             </a:r>
           </a:p>
         </p:txBody>
@@ -5344,7 +5410,7 @@
     </p:spTree>
     <p:extLst>
       <p:ext uri="{BB962C8B-B14F-4D97-AF65-F5344CB8AC3E}">
-        <p14:creationId xmlns:p14="http://schemas.microsoft.com/office/powerpoint/2010/main" val="1477519920"/>
+        <p14:creationId xmlns:p14="http://schemas.microsoft.com/office/powerpoint/2010/main" val="1462825445"/>
       </p:ext>
     </p:extLst>
   </p:cSld>
@@ -5375,7 +5441,7 @@
           <p:cNvPr id="9" name="">
             <a:extLst xmlns:a="http://schemas.openxmlformats.org/drawingml/2006/main">
               <a:ext uri="{FF2B5EF4-FFF2-40B4-BE49-F238E27FC236}">
-                <a16:creationId xmlns:a16="http://schemas.microsoft.com/office/drawing/2014/main" id="{1B00E698-8833-442E-B21D-8DF906B579F1}"/>
+                <a16:creationId xmlns:a16="http://schemas.microsoft.com/office/drawing/2014/main" id="{E68CDCAC-9FD4-4642-BBBD-CF2196FD7336}"/>
               </a:ext>
             </a:extLst>
           </p:cNvPr>
@@ -5441,7 +5507,7 @@
           <p:cNvPr id="2" name="">
             <a:extLst xmlns:a="http://schemas.openxmlformats.org/drawingml/2006/main">
               <a:ext uri="{FF2B5EF4-FFF2-40B4-BE49-F238E27FC236}">
-                <a16:creationId xmlns:a16="http://schemas.microsoft.com/office/drawing/2014/main" id="{76380FFF-EA89-4121-B50F-C81097ED8C74}"/>
+                <a16:creationId xmlns:a16="http://schemas.microsoft.com/office/drawing/2014/main" id="{CEB7C5F3-1C9C-44F9-B0A2-0C154E25BF4D}"/>
               </a:ext>
             </a:extLst>
           </p:cNvPr>
@@ -5507,7 +5573,7 @@
           <p:cNvPr id="3" name="">
             <a:extLst xmlns:a="http://schemas.openxmlformats.org/drawingml/2006/main">
               <a:ext uri="{FF2B5EF4-FFF2-40B4-BE49-F238E27FC236}">
-                <a16:creationId xmlns:a16="http://schemas.microsoft.com/office/drawing/2014/main" id="{A7FBF5C7-F873-40C2-883F-6AF265541BCB}"/>
+                <a16:creationId xmlns:a16="http://schemas.microsoft.com/office/drawing/2014/main" id="{92F5AFD7-749A-4CDB-9880-88B11CE23313}"/>
               </a:ext>
             </a:extLst>
           </p:cNvPr>
@@ -5573,7 +5639,7 @@
           <p:cNvPr id="4" name="">
             <a:extLst xmlns:a="http://schemas.openxmlformats.org/drawingml/2006/main">
               <a:ext uri="{FF2B5EF4-FFF2-40B4-BE49-F238E27FC236}">
-                <a16:creationId xmlns:a16="http://schemas.microsoft.com/office/drawing/2014/main" id="{B437CB70-2C30-4B1B-B2D9-15CDA4F8D724}"/>
+                <a16:creationId xmlns:a16="http://schemas.microsoft.com/office/drawing/2014/main" id="{9CDC87C5-6968-4F33-A49C-C9FFABCF0108}"/>
               </a:ext>
             </a:extLst>
           </p:cNvPr>
@@ -5639,7 +5705,7 @@
           <p:cNvPr id="5" name="">
             <a:extLst xmlns:a="http://schemas.openxmlformats.org/drawingml/2006/main">
               <a:ext uri="{FF2B5EF4-FFF2-40B4-BE49-F238E27FC236}">
-                <a16:creationId xmlns:a16="http://schemas.microsoft.com/office/drawing/2014/main" id="{AE9B34C1-F3F8-4882-A60F-6BD08D8370B7}"/>
+                <a16:creationId xmlns:a16="http://schemas.microsoft.com/office/drawing/2014/main" id="{3C7FF0C9-F120-4C65-ADE3-1CD03DD8E863}"/>
               </a:ext>
             </a:extLst>
           </p:cNvPr>
@@ -5705,7 +5771,7 @@
           <p:cNvPr id="6" name="">
             <a:extLst xmlns:a="http://schemas.openxmlformats.org/drawingml/2006/main">
               <a:ext uri="{FF2B5EF4-FFF2-40B4-BE49-F238E27FC236}">
-                <a16:creationId xmlns:a16="http://schemas.microsoft.com/office/drawing/2014/main" id="{7D45ECB4-2A9A-4037-91FA-52099D5A6377}"/>
+                <a16:creationId xmlns:a16="http://schemas.microsoft.com/office/drawing/2014/main" id="{B6DFA24E-C9BC-4FF4-98E3-107E90262595}"/>
               </a:ext>
             </a:extLst>
           </p:cNvPr>
@@ -5771,7 +5837,7 @@
           <p:cNvPr id="7" name="">
             <a:extLst xmlns:a="http://schemas.openxmlformats.org/drawingml/2006/main">
               <a:ext uri="{FF2B5EF4-FFF2-40B4-BE49-F238E27FC236}">
-                <a16:creationId xmlns:a16="http://schemas.microsoft.com/office/drawing/2014/main" id="{3D4EDCA8-233B-4039-9694-68069817DCF1}"/>
+                <a16:creationId xmlns:a16="http://schemas.microsoft.com/office/drawing/2014/main" id="{DF2C5EC1-982E-42C4-8734-919D295B7079}"/>
               </a:ext>
             </a:extLst>
           </p:cNvPr>
@@ -5837,7 +5903,7 @@
           <p:cNvPr id="8" name="">
             <a:extLst xmlns:a="http://schemas.openxmlformats.org/drawingml/2006/main">
               <a:ext uri="{FF2B5EF4-FFF2-40B4-BE49-F238E27FC236}">
-                <a16:creationId xmlns:a16="http://schemas.microsoft.com/office/drawing/2014/main" id="{441D7B5B-A1DB-4AED-B67F-BCFB505780E1}"/>
+                <a16:creationId xmlns:a16="http://schemas.microsoft.com/office/drawing/2014/main" id="{532CBA0B-44FE-4075-B32A-C0C50AB890FE}"/>
               </a:ext>
             </a:extLst>
           </p:cNvPr>
@@ -5924,7 +5990,7 @@
     </p:spTree>
     <p:extLst>
       <p:ext uri="{BB962C8B-B14F-4D97-AF65-F5344CB8AC3E}">
-        <p14:creationId xmlns:p14="http://schemas.microsoft.com/office/powerpoint/2010/main" val="428078685"/>
+        <p14:creationId xmlns:p14="http://schemas.microsoft.com/office/powerpoint/2010/main" val="301960406"/>
       </p:ext>
     </p:extLst>
   </p:cSld>
@@ -5955,7 +6021,7 @@
           <p:cNvPr id="16" name="">
             <a:extLst xmlns:a="http://schemas.openxmlformats.org/drawingml/2006/main">
               <a:ext uri="{FF2B5EF4-FFF2-40B4-BE49-F238E27FC236}">
-                <a16:creationId xmlns:a16="http://schemas.microsoft.com/office/drawing/2014/main" id="{EF6EE3E5-5D88-4EDD-833B-952C8953E28C}"/>
+                <a16:creationId xmlns:a16="http://schemas.microsoft.com/office/drawing/2014/main" id="{DCE33F0C-096B-4395-AA98-A108CA368BD7}"/>
               </a:ext>
             </a:extLst>
           </p:cNvPr>
@@ -6021,7 +6087,7 @@
           <p:cNvPr id="2" name="">
             <a:extLst xmlns:a="http://schemas.openxmlformats.org/drawingml/2006/main">
               <a:ext uri="{FF2B5EF4-FFF2-40B4-BE49-F238E27FC236}">
-                <a16:creationId xmlns:a16="http://schemas.microsoft.com/office/drawing/2014/main" id="{554A1F50-425D-43B4-BD0C-8AB195FBA25F}"/>
+                <a16:creationId xmlns:a16="http://schemas.microsoft.com/office/drawing/2014/main" id="{EBF65B97-767F-4895-9280-4E9730EEBC07}"/>
               </a:ext>
             </a:extLst>
           </p:cNvPr>
@@ -6087,7 +6153,7 @@
           <p:cNvPr id="3" name="">
             <a:extLst xmlns:a="http://schemas.openxmlformats.org/drawingml/2006/main">
               <a:ext uri="{FF2B5EF4-FFF2-40B4-BE49-F238E27FC236}">
-                <a16:creationId xmlns:a16="http://schemas.microsoft.com/office/drawing/2014/main" id="{6BD4DFF0-39AA-4978-B251-6AC35EAB2347}"/>
+                <a16:creationId xmlns:a16="http://schemas.microsoft.com/office/drawing/2014/main" id="{A0EBE9FF-A49B-452A-A594-50E1A9B76F01}"/>
               </a:ext>
             </a:extLst>
           </p:cNvPr>
@@ -6153,7 +6219,7 @@
           <p:cNvPr id="4" name="">
             <a:extLst xmlns:a="http://schemas.openxmlformats.org/drawingml/2006/main">
               <a:ext uri="{FF2B5EF4-FFF2-40B4-BE49-F238E27FC236}">
-                <a16:creationId xmlns:a16="http://schemas.microsoft.com/office/drawing/2014/main" id="{FE34DE0C-CAC2-4F96-A2CE-C6512795C9EA}"/>
+                <a16:creationId xmlns:a16="http://schemas.microsoft.com/office/drawing/2014/main" id="{020DEF10-E08C-4BB8-BDD8-93096A841D7C}"/>
               </a:ext>
             </a:extLst>
           </p:cNvPr>
@@ -6219,7 +6285,7 @@
           <p:cNvPr id="5" name="">
             <a:extLst xmlns:a="http://schemas.openxmlformats.org/drawingml/2006/main">
               <a:ext uri="{FF2B5EF4-FFF2-40B4-BE49-F238E27FC236}">
-                <a16:creationId xmlns:a16="http://schemas.microsoft.com/office/drawing/2014/main" id="{A98661DD-6DFB-4EA7-AE40-4E02904DFA2C}"/>
+                <a16:creationId xmlns:a16="http://schemas.microsoft.com/office/drawing/2014/main" id="{45A6961A-6824-44D1-A668-323B72368981}"/>
               </a:ext>
             </a:extLst>
           </p:cNvPr>
@@ -6285,7 +6351,7 @@
           <p:cNvPr id="6" name="">
             <a:extLst xmlns:a="http://schemas.openxmlformats.org/drawingml/2006/main">
               <a:ext uri="{FF2B5EF4-FFF2-40B4-BE49-F238E27FC236}">
-                <a16:creationId xmlns:a16="http://schemas.microsoft.com/office/drawing/2014/main" id="{02D1FAAB-A4FC-4275-91CA-26D9B4B20315}"/>
+                <a16:creationId xmlns:a16="http://schemas.microsoft.com/office/drawing/2014/main" id="{A4442589-5D2C-4AEB-9CE4-4176345CEDA5}"/>
               </a:ext>
             </a:extLst>
           </p:cNvPr>
@@ -6351,7 +6417,7 @@
           <p:cNvPr id="7" name="">
             <a:extLst xmlns:a="http://schemas.openxmlformats.org/drawingml/2006/main">
               <a:ext uri="{FF2B5EF4-FFF2-40B4-BE49-F238E27FC236}">
-                <a16:creationId xmlns:a16="http://schemas.microsoft.com/office/drawing/2014/main" id="{570B62F4-2D4E-4EF9-9565-77F651C8AFF5}"/>
+                <a16:creationId xmlns:a16="http://schemas.microsoft.com/office/drawing/2014/main" id="{29905BD3-B4B3-4564-9A82-3939019F071D}"/>
               </a:ext>
             </a:extLst>
           </p:cNvPr>
@@ -6417,7 +6483,7 @@
           <p:cNvPr id="8" name="">
             <a:extLst xmlns:a="http://schemas.openxmlformats.org/drawingml/2006/main">
               <a:ext uri="{FF2B5EF4-FFF2-40B4-BE49-F238E27FC236}">
-                <a16:creationId xmlns:a16="http://schemas.microsoft.com/office/drawing/2014/main" id="{F343173F-7CC0-406B-A44C-50DC91B3CB5A}"/>
+                <a16:creationId xmlns:a16="http://schemas.microsoft.com/office/drawing/2014/main" id="{3BC2DBDD-3788-4030-BD92-F6F4AC542937}"/>
               </a:ext>
             </a:extLst>
           </p:cNvPr>
@@ -6483,7 +6549,7 @@
           <p:cNvPr id="9" name="">
             <a:extLst xmlns:a="http://schemas.openxmlformats.org/drawingml/2006/main">
               <a:ext uri="{FF2B5EF4-FFF2-40B4-BE49-F238E27FC236}">
-                <a16:creationId xmlns:a16="http://schemas.microsoft.com/office/drawing/2014/main" id="{BEF4CDDC-A4C0-4B9B-AB25-B1DE066DECE2}"/>
+                <a16:creationId xmlns:a16="http://schemas.microsoft.com/office/drawing/2014/main" id="{1357CA02-856D-4E55-B2E8-D43C4BB154BB}"/>
               </a:ext>
             </a:extLst>
           </p:cNvPr>
@@ -6549,7 +6615,7 @@
           <p:cNvPr id="10" name="">
             <a:extLst xmlns:a="http://schemas.openxmlformats.org/drawingml/2006/main">
               <a:ext uri="{FF2B5EF4-FFF2-40B4-BE49-F238E27FC236}">
-                <a16:creationId xmlns:a16="http://schemas.microsoft.com/office/drawing/2014/main" id="{CC56DE31-37EC-4F3E-A4FE-83B96156F7E0}"/>
+                <a16:creationId xmlns:a16="http://schemas.microsoft.com/office/drawing/2014/main" id="{564F669A-DFC5-4BC1-BF76-7289041DC985}"/>
               </a:ext>
             </a:extLst>
           </p:cNvPr>
@@ -6615,7 +6681,7 @@
           <p:cNvPr id="11" name="">
             <a:extLst xmlns:a="http://schemas.openxmlformats.org/drawingml/2006/main">
               <a:ext uri="{FF2B5EF4-FFF2-40B4-BE49-F238E27FC236}">
-                <a16:creationId xmlns:a16="http://schemas.microsoft.com/office/drawing/2014/main" id="{612F744D-DF40-4570-BA25-9186F832FADA}"/>
+                <a16:creationId xmlns:a16="http://schemas.microsoft.com/office/drawing/2014/main" id="{96FA9ACE-8574-43A5-B270-66799593E2D8}"/>
               </a:ext>
             </a:extLst>
           </p:cNvPr>
@@ -6681,7 +6747,7 @@
           <p:cNvPr id="12" name="">
             <a:extLst xmlns:a="http://schemas.openxmlformats.org/drawingml/2006/main">
               <a:ext uri="{FF2B5EF4-FFF2-40B4-BE49-F238E27FC236}">
-                <a16:creationId xmlns:a16="http://schemas.microsoft.com/office/drawing/2014/main" id="{7EB4C329-8CD9-446C-B3C6-6EB3B244AFDA}"/>
+                <a16:creationId xmlns:a16="http://schemas.microsoft.com/office/drawing/2014/main" id="{7EA0FF7C-385D-4F7A-9709-47A0080E39C9}"/>
               </a:ext>
             </a:extLst>
           </p:cNvPr>
@@ -6747,7 +6813,7 @@
           <p:cNvPr id="13" name="">
             <a:extLst xmlns:a="http://schemas.openxmlformats.org/drawingml/2006/main">
               <a:ext uri="{FF2B5EF4-FFF2-40B4-BE49-F238E27FC236}">
-                <a16:creationId xmlns:a16="http://schemas.microsoft.com/office/drawing/2014/main" id="{796ED7FD-0FA2-4B54-9294-D6A0A2844B52}"/>
+                <a16:creationId xmlns:a16="http://schemas.microsoft.com/office/drawing/2014/main" id="{45C80B96-EFC2-45E5-8B7E-FE8ADB76A432}"/>
               </a:ext>
             </a:extLst>
           </p:cNvPr>
@@ -6813,7 +6879,7 @@
           <p:cNvPr id="14" name="">
             <a:extLst xmlns:a="http://schemas.openxmlformats.org/drawingml/2006/main">
               <a:ext uri="{FF2B5EF4-FFF2-40B4-BE49-F238E27FC236}">
-                <a16:creationId xmlns:a16="http://schemas.microsoft.com/office/drawing/2014/main" id="{5A22FDA9-1636-4D22-862C-9997313DB839}"/>
+                <a16:creationId xmlns:a16="http://schemas.microsoft.com/office/drawing/2014/main" id="{DD89D07A-D8B0-43ED-AB2C-0AEDEB60C6CB}"/>
               </a:ext>
             </a:extLst>
           </p:cNvPr>
@@ -6879,7 +6945,7 @@
           <p:cNvPr id="15" name="">
             <a:extLst xmlns:a="http://schemas.openxmlformats.org/drawingml/2006/main">
               <a:ext uri="{FF2B5EF4-FFF2-40B4-BE49-F238E27FC236}">
-                <a16:creationId xmlns:a16="http://schemas.microsoft.com/office/drawing/2014/main" id="{93FEB91B-431D-458C-AAE4-EE893C9CF9AC}"/>
+                <a16:creationId xmlns:a16="http://schemas.microsoft.com/office/drawing/2014/main" id="{A6102BF5-64D5-4EB5-A957-23266AEA3F68}"/>
               </a:ext>
             </a:extLst>
           </p:cNvPr>
@@ -6943,7 +7009,7 @@
     </p:spTree>
     <p:extLst>
       <p:ext uri="{BB962C8B-B14F-4D97-AF65-F5344CB8AC3E}">
-        <p14:creationId xmlns:p14="http://schemas.microsoft.com/office/powerpoint/2010/main" val="249668250"/>
+        <p14:creationId xmlns:p14="http://schemas.microsoft.com/office/powerpoint/2010/main" val="1019107914"/>
       </p:ext>
     </p:extLst>
   </p:cSld>
@@ -6974,7 +7040,7 @@
           <p:cNvPr id="16" name="">
             <a:extLst xmlns:a="http://schemas.openxmlformats.org/drawingml/2006/main">
               <a:ext uri="{FF2B5EF4-FFF2-40B4-BE49-F238E27FC236}">
-                <a16:creationId xmlns:a16="http://schemas.microsoft.com/office/drawing/2014/main" id="{4DF6A661-DD53-47C9-A105-5DC6736A1E0B}"/>
+                <a16:creationId xmlns:a16="http://schemas.microsoft.com/office/drawing/2014/main" id="{A215FA67-AA4F-4B1C-A6E5-29F09F46BC2A}"/>
               </a:ext>
             </a:extLst>
           </p:cNvPr>
@@ -7040,7 +7106,7 @@
           <p:cNvPr id="2" name="">
             <a:extLst xmlns:a="http://schemas.openxmlformats.org/drawingml/2006/main">
               <a:ext uri="{FF2B5EF4-FFF2-40B4-BE49-F238E27FC236}">
-                <a16:creationId xmlns:a16="http://schemas.microsoft.com/office/drawing/2014/main" id="{2B393BEB-FB4A-4E48-B349-B65BF2597234}"/>
+                <a16:creationId xmlns:a16="http://schemas.microsoft.com/office/drawing/2014/main" id="{FDC92050-1B3D-44B8-9AA1-A0358815A4BF}"/>
               </a:ext>
             </a:extLst>
           </p:cNvPr>
@@ -7106,7 +7172,7 @@
           <p:cNvPr id="3" name="">
             <a:extLst xmlns:a="http://schemas.openxmlformats.org/drawingml/2006/main">
               <a:ext uri="{FF2B5EF4-FFF2-40B4-BE49-F238E27FC236}">
-                <a16:creationId xmlns:a16="http://schemas.microsoft.com/office/drawing/2014/main" id="{7045EEB9-27C9-4D6B-9B21-268A45FA9316}"/>
+                <a16:creationId xmlns:a16="http://schemas.microsoft.com/office/drawing/2014/main" id="{2A9CF531-7A99-4CCF-B0E0-68F948752569}"/>
               </a:ext>
             </a:extLst>
           </p:cNvPr>
@@ -7172,7 +7238,7 @@
           <p:cNvPr id="4" name="">
             <a:extLst xmlns:a="http://schemas.openxmlformats.org/drawingml/2006/main">
               <a:ext uri="{FF2B5EF4-FFF2-40B4-BE49-F238E27FC236}">
-                <a16:creationId xmlns:a16="http://schemas.microsoft.com/office/drawing/2014/main" id="{B70C07BC-E637-4D72-A81E-39E089B5736B}"/>
+                <a16:creationId xmlns:a16="http://schemas.microsoft.com/office/drawing/2014/main" id="{2978BB77-596B-4ECB-B956-EE899686D603}"/>
               </a:ext>
             </a:extLst>
           </p:cNvPr>
@@ -7238,7 +7304,7 @@
           <p:cNvPr id="5" name="">
             <a:extLst xmlns:a="http://schemas.openxmlformats.org/drawingml/2006/main">
               <a:ext uri="{FF2B5EF4-FFF2-40B4-BE49-F238E27FC236}">
-                <a16:creationId xmlns:a16="http://schemas.microsoft.com/office/drawing/2014/main" id="{6145FA65-C888-4902-9C67-6E880A1891DB}"/>
+                <a16:creationId xmlns:a16="http://schemas.microsoft.com/office/drawing/2014/main" id="{06A5289E-E1F0-4757-9AE4-34964E815E42}"/>
               </a:ext>
             </a:extLst>
           </p:cNvPr>
@@ -7304,7 +7370,7 @@
           <p:cNvPr id="6" name="">
             <a:extLst xmlns:a="http://schemas.openxmlformats.org/drawingml/2006/main">
               <a:ext uri="{FF2B5EF4-FFF2-40B4-BE49-F238E27FC236}">
-                <a16:creationId xmlns:a16="http://schemas.microsoft.com/office/drawing/2014/main" id="{17310A0C-2C79-4FDC-9088-84335AFF144E}"/>
+                <a16:creationId xmlns:a16="http://schemas.microsoft.com/office/drawing/2014/main" id="{D1E2C79C-DA07-457B-BA46-A642A86149BA}"/>
               </a:ext>
             </a:extLst>
           </p:cNvPr>
@@ -7370,7 +7436,7 @@
           <p:cNvPr id="7" name="">
             <a:extLst xmlns:a="http://schemas.openxmlformats.org/drawingml/2006/main">
               <a:ext uri="{FF2B5EF4-FFF2-40B4-BE49-F238E27FC236}">
-                <a16:creationId xmlns:a16="http://schemas.microsoft.com/office/drawing/2014/main" id="{56F056D4-C256-4176-B8BD-C80014F697F8}"/>
+                <a16:creationId xmlns:a16="http://schemas.microsoft.com/office/drawing/2014/main" id="{0E45C6C0-BC3A-4CC5-BC05-D21F6F3D7713}"/>
               </a:ext>
             </a:extLst>
           </p:cNvPr>
@@ -7436,7 +7502,7 @@
           <p:cNvPr id="8" name="">
             <a:extLst xmlns:a="http://schemas.openxmlformats.org/drawingml/2006/main">
               <a:ext uri="{FF2B5EF4-FFF2-40B4-BE49-F238E27FC236}">
-                <a16:creationId xmlns:a16="http://schemas.microsoft.com/office/drawing/2014/main" id="{ADA2371F-394A-4855-AECB-ACD0F4EC0044}"/>
+                <a16:creationId xmlns:a16="http://schemas.microsoft.com/office/drawing/2014/main" id="{45639437-4AE9-4512-A3E7-69C0D402808E}"/>
               </a:ext>
             </a:extLst>
           </p:cNvPr>
@@ -7502,7 +7568,7 @@
           <p:cNvPr id="9" name="">
             <a:extLst xmlns:a="http://schemas.openxmlformats.org/drawingml/2006/main">
               <a:ext uri="{FF2B5EF4-FFF2-40B4-BE49-F238E27FC236}">
-                <a16:creationId xmlns:a16="http://schemas.microsoft.com/office/drawing/2014/main" id="{15A9D794-730A-4512-925E-15F711CDAB6E}"/>
+                <a16:creationId xmlns:a16="http://schemas.microsoft.com/office/drawing/2014/main" id="{BD96ABAD-19E3-4A5C-A337-7B8AFF587914}"/>
               </a:ext>
             </a:extLst>
           </p:cNvPr>
@@ -7568,7 +7634,7 @@
           <p:cNvPr id="10" name="">
             <a:extLst xmlns:a="http://schemas.openxmlformats.org/drawingml/2006/main">
               <a:ext uri="{FF2B5EF4-FFF2-40B4-BE49-F238E27FC236}">
-                <a16:creationId xmlns:a16="http://schemas.microsoft.com/office/drawing/2014/main" id="{7F3E8E9D-02DB-49E7-989E-C3064E45A7EF}"/>
+                <a16:creationId xmlns:a16="http://schemas.microsoft.com/office/drawing/2014/main" id="{E1B46EDA-3023-4B60-A204-8177E13285A3}"/>
               </a:ext>
             </a:extLst>
           </p:cNvPr>
@@ -7634,7 +7700,7 @@
           <p:cNvPr id="11" name="">
             <a:extLst xmlns:a="http://schemas.openxmlformats.org/drawingml/2006/main">
               <a:ext uri="{FF2B5EF4-FFF2-40B4-BE49-F238E27FC236}">
-                <a16:creationId xmlns:a16="http://schemas.microsoft.com/office/drawing/2014/main" id="{8F725CA0-B8F8-47F6-85D2-BBF09CEBA0EA}"/>
+                <a16:creationId xmlns:a16="http://schemas.microsoft.com/office/drawing/2014/main" id="{1D379B88-99CD-4CA7-A475-6B5ECF1BA97B}"/>
               </a:ext>
             </a:extLst>
           </p:cNvPr>
@@ -7700,7 +7766,7 @@
           <p:cNvPr id="12" name="">
             <a:extLst xmlns:a="http://schemas.openxmlformats.org/drawingml/2006/main">
               <a:ext uri="{FF2B5EF4-FFF2-40B4-BE49-F238E27FC236}">
-                <a16:creationId xmlns:a16="http://schemas.microsoft.com/office/drawing/2014/main" id="{5268E166-D771-4BEA-A960-654F359E9B28}"/>
+                <a16:creationId xmlns:a16="http://schemas.microsoft.com/office/drawing/2014/main" id="{1A2D52E6-3330-46BC-BA7D-849ECF7F5F7C}"/>
               </a:ext>
             </a:extLst>
           </p:cNvPr>
@@ -7766,7 +7832,7 @@
           <p:cNvPr id="13" name="">
             <a:extLst xmlns:a="http://schemas.openxmlformats.org/drawingml/2006/main">
               <a:ext uri="{FF2B5EF4-FFF2-40B4-BE49-F238E27FC236}">
-                <a16:creationId xmlns:a16="http://schemas.microsoft.com/office/drawing/2014/main" id="{8C2A5AE0-7402-42FB-98DC-50A87B253ACB}"/>
+                <a16:creationId xmlns:a16="http://schemas.microsoft.com/office/drawing/2014/main" id="{866D9004-61EF-4327-A0A6-7A05750A7DF4}"/>
               </a:ext>
             </a:extLst>
           </p:cNvPr>
@@ -7832,7 +7898,7 @@
           <p:cNvPr id="14" name="">
             <a:extLst xmlns:a="http://schemas.openxmlformats.org/drawingml/2006/main">
               <a:ext uri="{FF2B5EF4-FFF2-40B4-BE49-F238E27FC236}">
-                <a16:creationId xmlns:a16="http://schemas.microsoft.com/office/drawing/2014/main" id="{62CCD64D-8BDA-4D05-8C59-6708F635985B}"/>
+                <a16:creationId xmlns:a16="http://schemas.microsoft.com/office/drawing/2014/main" id="{3E5150A9-5506-48C1-92BC-9AA1A3BAE455}"/>
               </a:ext>
             </a:extLst>
           </p:cNvPr>
@@ -7898,7 +7964,7 @@
           <p:cNvPr id="15" name="">
             <a:extLst xmlns:a="http://schemas.openxmlformats.org/drawingml/2006/main">
               <a:ext uri="{FF2B5EF4-FFF2-40B4-BE49-F238E27FC236}">
-                <a16:creationId xmlns:a16="http://schemas.microsoft.com/office/drawing/2014/main" id="{9A04F191-737F-4049-B941-F0F11EFFC573}"/>
+                <a16:creationId xmlns:a16="http://schemas.microsoft.com/office/drawing/2014/main" id="{E5BCC1E5-B520-41E7-868D-AE9A8FD34667}"/>
               </a:ext>
             </a:extLst>
           </p:cNvPr>
@@ -7962,7 +8028,7 @@
     </p:spTree>
     <p:extLst>
       <p:ext uri="{BB962C8B-B14F-4D97-AF65-F5344CB8AC3E}">
-        <p14:creationId xmlns:p14="http://schemas.microsoft.com/office/powerpoint/2010/main" val="1834400350"/>
+        <p14:creationId xmlns:p14="http://schemas.microsoft.com/office/powerpoint/2010/main" val="1068175984"/>
       </p:ext>
     </p:extLst>
   </p:cSld>
@@ -7993,7 +8059,7 @@
           <p:cNvPr id="17" name="">
             <a:extLst xmlns:a="http://schemas.openxmlformats.org/drawingml/2006/main">
               <a:ext uri="{FF2B5EF4-FFF2-40B4-BE49-F238E27FC236}">
-                <a16:creationId xmlns:a16="http://schemas.microsoft.com/office/drawing/2014/main" id="{1C896139-6DC4-4E1B-B574-269AAD32FA10}"/>
+                <a16:creationId xmlns:a16="http://schemas.microsoft.com/office/drawing/2014/main" id="{D97D6520-C461-49CE-8905-04897C66081C}"/>
               </a:ext>
             </a:extLst>
           </p:cNvPr>
@@ -8059,7 +8125,7 @@
           <p:cNvPr id="2" name="">
             <a:extLst xmlns:a="http://schemas.openxmlformats.org/drawingml/2006/main">
               <a:ext uri="{FF2B5EF4-FFF2-40B4-BE49-F238E27FC236}">
-                <a16:creationId xmlns:a16="http://schemas.microsoft.com/office/drawing/2014/main" id="{9D6A71AD-2D28-4859-A717-8E732890D0B6}"/>
+                <a16:creationId xmlns:a16="http://schemas.microsoft.com/office/drawing/2014/main" id="{2E426DBE-769E-41B1-AF87-21AF60DBDC73}"/>
               </a:ext>
             </a:extLst>
           </p:cNvPr>
@@ -8125,7 +8191,7 @@
           <p:cNvPr id="3" name="">
             <a:extLst xmlns:a="http://schemas.openxmlformats.org/drawingml/2006/main">
               <a:ext uri="{FF2B5EF4-FFF2-40B4-BE49-F238E27FC236}">
-                <a16:creationId xmlns:a16="http://schemas.microsoft.com/office/drawing/2014/main" id="{FA56F078-FD65-4893-883C-BC18CA009F41}"/>
+                <a16:creationId xmlns:a16="http://schemas.microsoft.com/office/drawing/2014/main" id="{2BAB6A5B-945F-4FF9-99B6-0109C0F9225E}"/>
               </a:ext>
             </a:extLst>
           </p:cNvPr>
@@ -8191,7 +8257,7 @@
           <p:cNvPr id="4" name="">
             <a:extLst xmlns:a="http://schemas.openxmlformats.org/drawingml/2006/main">
               <a:ext uri="{FF2B5EF4-FFF2-40B4-BE49-F238E27FC236}">
-                <a16:creationId xmlns:a16="http://schemas.microsoft.com/office/drawing/2014/main" id="{43CFB205-3D85-4008-8C7F-5B6101C4AE7D}"/>
+                <a16:creationId xmlns:a16="http://schemas.microsoft.com/office/drawing/2014/main" id="{EB475504-F4F1-4AD6-B320-3669CD5D8F2D}"/>
               </a:ext>
             </a:extLst>
           </p:cNvPr>
@@ -8257,7 +8323,7 @@
           <p:cNvPr id="5" name="">
             <a:extLst xmlns:a="http://schemas.openxmlformats.org/drawingml/2006/main">
               <a:ext uri="{FF2B5EF4-FFF2-40B4-BE49-F238E27FC236}">
-                <a16:creationId xmlns:a16="http://schemas.microsoft.com/office/drawing/2014/main" id="{4DE8C071-4473-481E-890B-0ABA3E20093C}"/>
+                <a16:creationId xmlns:a16="http://schemas.microsoft.com/office/drawing/2014/main" id="{682B3785-1C00-43D4-A119-2F613050B018}"/>
               </a:ext>
             </a:extLst>
           </p:cNvPr>
@@ -8323,7 +8389,7 @@
           <p:cNvPr id="6" name="">
             <a:extLst xmlns:a="http://schemas.openxmlformats.org/drawingml/2006/main">
               <a:ext uri="{FF2B5EF4-FFF2-40B4-BE49-F238E27FC236}">
-                <a16:creationId xmlns:a16="http://schemas.microsoft.com/office/drawing/2014/main" id="{574082FA-70E5-4966-867E-611AB774E6A4}"/>
+                <a16:creationId xmlns:a16="http://schemas.microsoft.com/office/drawing/2014/main" id="{22A51C46-05AD-4A94-A52F-692760B54FF4}"/>
               </a:ext>
             </a:extLst>
           </p:cNvPr>
@@ -8389,7 +8455,7 @@
           <p:cNvPr id="7" name="">
             <a:extLst xmlns:a="http://schemas.openxmlformats.org/drawingml/2006/main">
               <a:ext uri="{FF2B5EF4-FFF2-40B4-BE49-F238E27FC236}">
-                <a16:creationId xmlns:a16="http://schemas.microsoft.com/office/drawing/2014/main" id="{1F330C37-6081-40CC-96BE-2CDDB615D6E7}"/>
+                <a16:creationId xmlns:a16="http://schemas.microsoft.com/office/drawing/2014/main" id="{1DD23D13-A5A0-4EFF-B180-91FAD17EEDE6}"/>
               </a:ext>
             </a:extLst>
           </p:cNvPr>
@@ -8455,7 +8521,7 @@
           <p:cNvPr id="8" name="">
             <a:extLst xmlns:a="http://schemas.openxmlformats.org/drawingml/2006/main">
               <a:ext uri="{FF2B5EF4-FFF2-40B4-BE49-F238E27FC236}">
-                <a16:creationId xmlns:a16="http://schemas.microsoft.com/office/drawing/2014/main" id="{FC6A875F-A41A-4149-8E63-1D3F85182ABF}"/>
+                <a16:creationId xmlns:a16="http://schemas.microsoft.com/office/drawing/2014/main" id="{0D171F3C-9CDB-424A-93FB-69E093F6D3AD}"/>
               </a:ext>
             </a:extLst>
           </p:cNvPr>
@@ -8521,7 +8587,7 @@
           <p:cNvPr id="9" name="">
             <a:extLst xmlns:a="http://schemas.openxmlformats.org/drawingml/2006/main">
               <a:ext uri="{FF2B5EF4-FFF2-40B4-BE49-F238E27FC236}">
-                <a16:creationId xmlns:a16="http://schemas.microsoft.com/office/drawing/2014/main" id="{C0A8042F-5148-42E6-B1F2-D4EEE7708096}"/>
+                <a16:creationId xmlns:a16="http://schemas.microsoft.com/office/drawing/2014/main" id="{D9094BEB-6035-4749-9DD4-85265351B188}"/>
               </a:ext>
             </a:extLst>
           </p:cNvPr>
@@ -8587,7 +8653,7 @@
           <p:cNvPr id="10" name="">
             <a:extLst xmlns:a="http://schemas.openxmlformats.org/drawingml/2006/main">
               <a:ext uri="{FF2B5EF4-FFF2-40B4-BE49-F238E27FC236}">
-                <a16:creationId xmlns:a16="http://schemas.microsoft.com/office/drawing/2014/main" id="{6AC1F466-A8CB-4CF2-B70C-65D991EE185F}"/>
+                <a16:creationId xmlns:a16="http://schemas.microsoft.com/office/drawing/2014/main" id="{EA2BF4EA-F07E-49B2-BD02-10A54C927314}"/>
               </a:ext>
             </a:extLst>
           </p:cNvPr>
@@ -8653,7 +8719,7 @@
           <p:cNvPr id="11" name="">
             <a:extLst xmlns:a="http://schemas.openxmlformats.org/drawingml/2006/main">
               <a:ext uri="{FF2B5EF4-FFF2-40B4-BE49-F238E27FC236}">
-                <a16:creationId xmlns:a16="http://schemas.microsoft.com/office/drawing/2014/main" id="{483E6334-96B3-439A-88E4-8E9E2CD302FE}"/>
+                <a16:creationId xmlns:a16="http://schemas.microsoft.com/office/drawing/2014/main" id="{381154A0-2102-499D-B60C-652C66DCF76C}"/>
               </a:ext>
             </a:extLst>
           </p:cNvPr>
@@ -8719,7 +8785,7 @@
           <p:cNvPr id="12" name="">
             <a:extLst xmlns:a="http://schemas.openxmlformats.org/drawingml/2006/main">
               <a:ext uri="{FF2B5EF4-FFF2-40B4-BE49-F238E27FC236}">
-                <a16:creationId xmlns:a16="http://schemas.microsoft.com/office/drawing/2014/main" id="{809ADFCF-27F2-461A-AFB8-1A22C8D5C11E}"/>
+                <a16:creationId xmlns:a16="http://schemas.microsoft.com/office/drawing/2014/main" id="{BA3FC74C-7185-499B-85B3-04AA5BB8E2B2}"/>
               </a:ext>
             </a:extLst>
           </p:cNvPr>
@@ -8785,7 +8851,7 @@
           <p:cNvPr id="13" name="">
             <a:extLst xmlns:a="http://schemas.openxmlformats.org/drawingml/2006/main">
               <a:ext uri="{FF2B5EF4-FFF2-40B4-BE49-F238E27FC236}">
-                <a16:creationId xmlns:a16="http://schemas.microsoft.com/office/drawing/2014/main" id="{45AA62A4-D917-4B85-9A26-BDE21B918055}"/>
+                <a16:creationId xmlns:a16="http://schemas.microsoft.com/office/drawing/2014/main" id="{9E33017E-AAF2-4C66-B442-49B3B068EB2F}"/>
               </a:ext>
             </a:extLst>
           </p:cNvPr>
@@ -8851,7 +8917,7 @@
           <p:cNvPr id="14" name="">
             <a:extLst xmlns:a="http://schemas.openxmlformats.org/drawingml/2006/main">
               <a:ext uri="{FF2B5EF4-FFF2-40B4-BE49-F238E27FC236}">
-                <a16:creationId xmlns:a16="http://schemas.microsoft.com/office/drawing/2014/main" id="{C6234034-5EC8-4CA9-944D-6E5C2740CE09}"/>
+                <a16:creationId xmlns:a16="http://schemas.microsoft.com/office/drawing/2014/main" id="{1BA0C980-B302-4295-8A89-2DCC6A610252}"/>
               </a:ext>
             </a:extLst>
           </p:cNvPr>
@@ -8917,7 +8983,7 @@
           <p:cNvPr id="15" name="">
             <a:extLst xmlns:a="http://schemas.openxmlformats.org/drawingml/2006/main">
               <a:ext uri="{FF2B5EF4-FFF2-40B4-BE49-F238E27FC236}">
-                <a16:creationId xmlns:a16="http://schemas.microsoft.com/office/drawing/2014/main" id="{86A09B8A-225E-4FB0-AC5B-28E1DFF9860D}"/>
+                <a16:creationId xmlns:a16="http://schemas.microsoft.com/office/drawing/2014/main" id="{E921B130-FD4E-44D1-9F00-ED82035DB3CD}"/>
               </a:ext>
             </a:extLst>
           </p:cNvPr>
@@ -8983,7 +9049,7 @@
           <p:cNvPr id="16" name="">
             <a:extLst xmlns:a="http://schemas.openxmlformats.org/drawingml/2006/main">
               <a:ext uri="{FF2B5EF4-FFF2-40B4-BE49-F238E27FC236}">
-                <a16:creationId xmlns:a16="http://schemas.microsoft.com/office/drawing/2014/main" id="{13607054-39DD-4555-BD56-C13FD0CD9F88}"/>
+                <a16:creationId xmlns:a16="http://schemas.microsoft.com/office/drawing/2014/main" id="{22F65534-4A88-4031-934D-420A493062F5}"/>
               </a:ext>
             </a:extLst>
           </p:cNvPr>
@@ -9047,7 +9113,7 @@
     </p:spTree>
     <p:extLst>
       <p:ext uri="{BB962C8B-B14F-4D97-AF65-F5344CB8AC3E}">
-        <p14:creationId xmlns:p14="http://schemas.microsoft.com/office/powerpoint/2010/main" val="1455307113"/>
+        <p14:creationId xmlns:p14="http://schemas.microsoft.com/office/powerpoint/2010/main" val="664469064"/>
       </p:ext>
     </p:extLst>
   </p:cSld>
@@ -9078,7 +9144,7 @@
           <p:cNvPr id="8" name="">
             <a:extLst xmlns:a="http://schemas.openxmlformats.org/drawingml/2006/main">
               <a:ext uri="{FF2B5EF4-FFF2-40B4-BE49-F238E27FC236}">
-                <a16:creationId xmlns:a16="http://schemas.microsoft.com/office/drawing/2014/main" id="{CEEBCB23-4296-48E8-B3A2-F52C58D6FFBD}"/>
+                <a16:creationId xmlns:a16="http://schemas.microsoft.com/office/drawing/2014/main" id="{6B7FB558-E563-4111-B028-E90D26ABE405}"/>
               </a:ext>
             </a:extLst>
           </p:cNvPr>
@@ -9144,7 +9210,7 @@
           <p:cNvPr id="2" name="">
             <a:extLst xmlns:a="http://schemas.openxmlformats.org/drawingml/2006/main">
               <a:ext uri="{FF2B5EF4-FFF2-40B4-BE49-F238E27FC236}">
-                <a16:creationId xmlns:a16="http://schemas.microsoft.com/office/drawing/2014/main" id="{B6FA8A71-5B38-403B-B85D-EFE105A6A9FB}"/>
+                <a16:creationId xmlns:a16="http://schemas.microsoft.com/office/drawing/2014/main" id="{52127F8C-4ED8-4EB4-8947-427864ACC6A7}"/>
               </a:ext>
             </a:extLst>
           </p:cNvPr>
@@ -9210,7 +9276,7 @@
           <p:cNvPr id="3" name="">
             <a:extLst xmlns:a="http://schemas.openxmlformats.org/drawingml/2006/main">
               <a:ext uri="{FF2B5EF4-FFF2-40B4-BE49-F238E27FC236}">
-                <a16:creationId xmlns:a16="http://schemas.microsoft.com/office/drawing/2014/main" id="{41D381FB-843A-4C4E-9E4F-9880335DCCB7}"/>
+                <a16:creationId xmlns:a16="http://schemas.microsoft.com/office/drawing/2014/main" id="{42D513DD-5547-4E4F-B949-8340BFDF30EF}"/>
               </a:ext>
             </a:extLst>
           </p:cNvPr>
@@ -9276,7 +9342,7 @@
           <p:cNvPr id="4" name="">
             <a:extLst xmlns:a="http://schemas.openxmlformats.org/drawingml/2006/main">
               <a:ext uri="{FF2B5EF4-FFF2-40B4-BE49-F238E27FC236}">
-                <a16:creationId xmlns:a16="http://schemas.microsoft.com/office/drawing/2014/main" id="{7F0BF4D4-2D6F-4CD5-BD26-9C508CC8EACF}"/>
+                <a16:creationId xmlns:a16="http://schemas.microsoft.com/office/drawing/2014/main" id="{FF20D06B-62EB-4CE1-8BC2-ACF4E7AA64F4}"/>
               </a:ext>
             </a:extLst>
           </p:cNvPr>
@@ -9342,7 +9408,7 @@
           <p:cNvPr id="5" name="">
             <a:extLst xmlns:a="http://schemas.openxmlformats.org/drawingml/2006/main">
               <a:ext uri="{FF2B5EF4-FFF2-40B4-BE49-F238E27FC236}">
-                <a16:creationId xmlns:a16="http://schemas.microsoft.com/office/drawing/2014/main" id="{29D54B63-7E60-41D9-91C8-4A8E529C7EB7}"/>
+                <a16:creationId xmlns:a16="http://schemas.microsoft.com/office/drawing/2014/main" id="{BA5DD01B-B558-43CA-9F16-DE9C68D637CC}"/>
               </a:ext>
             </a:extLst>
           </p:cNvPr>
@@ -9500,7 +9566,7 @@
           <p:cNvPr id="6" name="">
             <a:extLst xmlns:a="http://schemas.openxmlformats.org/drawingml/2006/main">
               <a:ext uri="{FF2B5EF4-FFF2-40B4-BE49-F238E27FC236}">
-                <a16:creationId xmlns:a16="http://schemas.microsoft.com/office/drawing/2014/main" id="{0DF1279B-D7DC-40D8-A5D1-572F8D8F93E1}"/>
+                <a16:creationId xmlns:a16="http://schemas.microsoft.com/office/drawing/2014/main" id="{F76C3D3F-0993-43C5-B411-11252B61771E}"/>
               </a:ext>
             </a:extLst>
           </p:cNvPr>
@@ -9658,7 +9724,7 @@
           <p:cNvPr id="7" name="">
             <a:extLst xmlns:a="http://schemas.openxmlformats.org/drawingml/2006/main">
               <a:ext uri="{FF2B5EF4-FFF2-40B4-BE49-F238E27FC236}">
-                <a16:creationId xmlns:a16="http://schemas.microsoft.com/office/drawing/2014/main" id="{47F64EF5-8764-4E36-B3B6-820D9C8F7B96}"/>
+                <a16:creationId xmlns:a16="http://schemas.microsoft.com/office/drawing/2014/main" id="{AD6BEB43-64C4-4A29-9421-55F189ADB8F3}"/>
               </a:ext>
             </a:extLst>
           </p:cNvPr>
@@ -9722,7 +9788,7 @@
     </p:spTree>
     <p:extLst>
       <p:ext uri="{BB962C8B-B14F-4D97-AF65-F5344CB8AC3E}">
-        <p14:creationId xmlns:p14="http://schemas.microsoft.com/office/powerpoint/2010/main" val="417370181"/>
+        <p14:creationId xmlns:p14="http://schemas.microsoft.com/office/powerpoint/2010/main" val="2022003136"/>
       </p:ext>
     </p:extLst>
   </p:cSld>
@@ -9753,7 +9819,7 @@
           <p:cNvPr id="9" name="">
             <a:extLst xmlns:a="http://schemas.openxmlformats.org/drawingml/2006/main">
               <a:ext uri="{FF2B5EF4-FFF2-40B4-BE49-F238E27FC236}">
-                <a16:creationId xmlns:a16="http://schemas.microsoft.com/office/drawing/2014/main" id="{A694BB7B-7A71-4059-9F59-CAF39CF2D99C}"/>
+                <a16:creationId xmlns:a16="http://schemas.microsoft.com/office/drawing/2014/main" id="{8D5770B4-21BB-4AB4-9287-126B9A2B1400}"/>
               </a:ext>
             </a:extLst>
           </p:cNvPr>
@@ -9819,7 +9885,7 @@
           <p:cNvPr id="2" name="">
             <a:extLst xmlns:a="http://schemas.openxmlformats.org/drawingml/2006/main">
               <a:ext uri="{FF2B5EF4-FFF2-40B4-BE49-F238E27FC236}">
-                <a16:creationId xmlns:a16="http://schemas.microsoft.com/office/drawing/2014/main" id="{AA1AAC41-D587-4880-863E-CA20B128516B}"/>
+                <a16:creationId xmlns:a16="http://schemas.microsoft.com/office/drawing/2014/main" id="{DFD60C53-2380-4EF6-A094-58917808CF56}"/>
               </a:ext>
             </a:extLst>
           </p:cNvPr>
@@ -9885,7 +9951,7 @@
           <p:cNvPr id="3" name="">
             <a:extLst xmlns:a="http://schemas.openxmlformats.org/drawingml/2006/main">
               <a:ext uri="{FF2B5EF4-FFF2-40B4-BE49-F238E27FC236}">
-                <a16:creationId xmlns:a16="http://schemas.microsoft.com/office/drawing/2014/main" id="{B463F3D6-3F83-4DEC-8BCE-98AD0467EC5C}"/>
+                <a16:creationId xmlns:a16="http://schemas.microsoft.com/office/drawing/2014/main" id="{F80D9698-8A0C-46DD-BEC1-52119E0B8FCC}"/>
               </a:ext>
             </a:extLst>
           </p:cNvPr>
@@ -9951,7 +10017,7 @@
           <p:cNvPr id="4" name="">
             <a:extLst xmlns:a="http://schemas.openxmlformats.org/drawingml/2006/main">
               <a:ext uri="{FF2B5EF4-FFF2-40B4-BE49-F238E27FC236}">
-                <a16:creationId xmlns:a16="http://schemas.microsoft.com/office/drawing/2014/main" id="{E9CA64A0-E36E-490A-9AC4-0203475C7BE3}"/>
+                <a16:creationId xmlns:a16="http://schemas.microsoft.com/office/drawing/2014/main" id="{E1AAB565-FADF-48DC-8116-6CFA0CE21144}"/>
               </a:ext>
             </a:extLst>
           </p:cNvPr>
@@ -10017,7 +10083,7 @@
           <p:cNvPr id="5" name="">
             <a:extLst xmlns:a="http://schemas.openxmlformats.org/drawingml/2006/main">
               <a:ext uri="{FF2B5EF4-FFF2-40B4-BE49-F238E27FC236}">
-                <a16:creationId xmlns:a16="http://schemas.microsoft.com/office/drawing/2014/main" id="{F8F1DD00-E3D8-4F2C-BC30-F0CCFF592B40}"/>
+                <a16:creationId xmlns:a16="http://schemas.microsoft.com/office/drawing/2014/main" id="{E5220606-1823-4A28-B112-A395CB2DD4C2}"/>
               </a:ext>
             </a:extLst>
           </p:cNvPr>
@@ -10139,7 +10205,7 @@
           <p:cNvPr id="6" name="">
             <a:extLst xmlns:a="http://schemas.openxmlformats.org/drawingml/2006/main">
               <a:ext uri="{FF2B5EF4-FFF2-40B4-BE49-F238E27FC236}">
-                <a16:creationId xmlns:a16="http://schemas.microsoft.com/office/drawing/2014/main" id="{0BE322EE-CC3A-4183-84AD-86AD74F41C6A}"/>
+                <a16:creationId xmlns:a16="http://schemas.microsoft.com/office/drawing/2014/main" id="{CD17103A-D048-4852-BFF8-C006FFB8CAC0}"/>
               </a:ext>
             </a:extLst>
           </p:cNvPr>
@@ -10205,7 +10271,7 @@
           <p:cNvPr id="7" name="">
             <a:extLst xmlns:a="http://schemas.openxmlformats.org/drawingml/2006/main">
               <a:ext uri="{FF2B5EF4-FFF2-40B4-BE49-F238E27FC236}">
-                <a16:creationId xmlns:a16="http://schemas.microsoft.com/office/drawing/2014/main" id="{5953A5E1-29DE-4252-8E85-CD454F15ECFB}"/>
+                <a16:creationId xmlns:a16="http://schemas.microsoft.com/office/drawing/2014/main" id="{CFF26C08-59F5-49E7-A18D-A9ECAB4F150B}"/>
               </a:ext>
             </a:extLst>
           </p:cNvPr>
@@ -10327,7 +10393,7 @@
           <p:cNvPr id="8" name="">
             <a:extLst xmlns:a="http://schemas.openxmlformats.org/drawingml/2006/main">
               <a:ext uri="{FF2B5EF4-FFF2-40B4-BE49-F238E27FC236}">
-                <a16:creationId xmlns:a16="http://schemas.microsoft.com/office/drawing/2014/main" id="{3A0427A4-0BE2-4535-8351-D483DA4F9C8C}"/>
+                <a16:creationId xmlns:a16="http://schemas.microsoft.com/office/drawing/2014/main" id="{F9C016DE-2F29-47E4-9B66-5816DAF70178}"/>
               </a:ext>
             </a:extLst>
           </p:cNvPr>
@@ -10391,7 +10457,7 @@
     </p:spTree>
     <p:extLst>
       <p:ext uri="{BB962C8B-B14F-4D97-AF65-F5344CB8AC3E}">
-        <p14:creationId xmlns:p14="http://schemas.microsoft.com/office/powerpoint/2010/main" val="435159983"/>
+        <p14:creationId xmlns:p14="http://schemas.microsoft.com/office/powerpoint/2010/main" val="1928784474"/>
       </p:ext>
     </p:extLst>
   </p:cSld>
@@ -10422,7 +10488,7 @@
           <p:cNvPr id="10" name="">
             <a:extLst xmlns:a="http://schemas.openxmlformats.org/drawingml/2006/main">
               <a:ext uri="{FF2B5EF4-FFF2-40B4-BE49-F238E27FC236}">
-                <a16:creationId xmlns:a16="http://schemas.microsoft.com/office/drawing/2014/main" id="{9672E88E-6EF6-4D9D-8517-4EF5DC62DCE0}"/>
+                <a16:creationId xmlns:a16="http://schemas.microsoft.com/office/drawing/2014/main" id="{AA2FB47D-3351-4320-BF30-666A99658BAF}"/>
               </a:ext>
             </a:extLst>
           </p:cNvPr>
@@ -10488,7 +10554,7 @@
           <p:cNvPr id="2" name="">
             <a:extLst xmlns:a="http://schemas.openxmlformats.org/drawingml/2006/main">
               <a:ext uri="{FF2B5EF4-FFF2-40B4-BE49-F238E27FC236}">
-                <a16:creationId xmlns:a16="http://schemas.microsoft.com/office/drawing/2014/main" id="{5FA32B1B-0AD9-4935-B813-E7FE93FA2500}"/>
+                <a16:creationId xmlns:a16="http://schemas.microsoft.com/office/drawing/2014/main" id="{74C469E6-AB57-43E3-8B44-6C0D1ECDBB86}"/>
               </a:ext>
             </a:extLst>
           </p:cNvPr>
@@ -10554,7 +10620,7 @@
           <p:cNvPr id="3" name="">
             <a:extLst xmlns:a="http://schemas.openxmlformats.org/drawingml/2006/main">
               <a:ext uri="{FF2B5EF4-FFF2-40B4-BE49-F238E27FC236}">
-                <a16:creationId xmlns:a16="http://schemas.microsoft.com/office/drawing/2014/main" id="{9B86F147-7CD8-459C-B389-26FB84F9F031}"/>
+                <a16:creationId xmlns:a16="http://schemas.microsoft.com/office/drawing/2014/main" id="{37D1E1D9-4C01-452A-84A8-DEC4D740910E}"/>
               </a:ext>
             </a:extLst>
           </p:cNvPr>
@@ -10620,7 +10686,7 @@
           <p:cNvPr id="4" name="">
             <a:extLst xmlns:a="http://schemas.openxmlformats.org/drawingml/2006/main">
               <a:ext uri="{FF2B5EF4-FFF2-40B4-BE49-F238E27FC236}">
-                <a16:creationId xmlns:a16="http://schemas.microsoft.com/office/drawing/2014/main" id="{948595A7-025C-42D8-8C24-50C3BA90F6C7}"/>
+                <a16:creationId xmlns:a16="http://schemas.microsoft.com/office/drawing/2014/main" id="{4FA8D79D-BDF4-4E15-ADD9-5E55104A337C}"/>
               </a:ext>
             </a:extLst>
           </p:cNvPr>
@@ -10630,7 +10696,7 @@
           <p:nvPr/>
         </p:nvPicPr>
         <p:blipFill>
-          <a:blip xmlns:r="http://schemas.openxmlformats.org/officeDocument/2006/relationships" xmlns:a="http://schemas.openxmlformats.org/drawingml/2006/main" r:embed="Rc64babe2d50f4cf8"/>
+          <a:blip xmlns:r="http://schemas.openxmlformats.org/officeDocument/2006/relationships" xmlns:a="http://schemas.openxmlformats.org/drawingml/2006/main" r:embed="R174f2425ff224924"/>
           <a:stretch xmlns:a="http://schemas.openxmlformats.org/drawingml/2006/main"/>
         </p:blipFill>
         <p:spPr>
@@ -10648,7 +10714,7 @@
           <p:cNvPr id="5" name="">
             <a:extLst xmlns:a="http://schemas.openxmlformats.org/drawingml/2006/main">
               <a:ext uri="{FF2B5EF4-FFF2-40B4-BE49-F238E27FC236}">
-                <a16:creationId xmlns:a16="http://schemas.microsoft.com/office/drawing/2014/main" id="{0023DD13-DC0C-4625-A9C5-4C80E3AE7E29}"/>
+                <a16:creationId xmlns:a16="http://schemas.microsoft.com/office/drawing/2014/main" id="{B2463CA2-3D1B-4849-9288-3591844A6882}"/>
               </a:ext>
             </a:extLst>
           </p:cNvPr>
@@ -10714,7 +10780,7 @@
           <p:cNvPr id="6" name="">
             <a:extLst xmlns:a="http://schemas.openxmlformats.org/drawingml/2006/main">
               <a:ext uri="{FF2B5EF4-FFF2-40B4-BE49-F238E27FC236}">
-                <a16:creationId xmlns:a16="http://schemas.microsoft.com/office/drawing/2014/main" id="{4B7D61C3-7BAF-4A4E-A861-88A228A2AB29}"/>
+                <a16:creationId xmlns:a16="http://schemas.microsoft.com/office/drawing/2014/main" id="{0E7D40CD-ED48-4C20-A6FF-D107AAD894BA}"/>
               </a:ext>
             </a:extLst>
           </p:cNvPr>
@@ -10780,7 +10846,7 @@
           <p:cNvPr id="7" name="">
             <a:extLst xmlns:a="http://schemas.openxmlformats.org/drawingml/2006/main">
               <a:ext uri="{FF2B5EF4-FFF2-40B4-BE49-F238E27FC236}">
-                <a16:creationId xmlns:a16="http://schemas.microsoft.com/office/drawing/2014/main" id="{AF6C1C98-00DC-4934-BFC2-5BF6ECD76E26}"/>
+                <a16:creationId xmlns:a16="http://schemas.microsoft.com/office/drawing/2014/main" id="{E1B4DD4D-C0ED-4447-B18D-53F1DA461E04}"/>
               </a:ext>
             </a:extLst>
           </p:cNvPr>
@@ -10846,7 +10912,7 @@
           <p:cNvPr id="8" name="">
             <a:extLst xmlns:a="http://schemas.openxmlformats.org/drawingml/2006/main">
               <a:ext uri="{FF2B5EF4-FFF2-40B4-BE49-F238E27FC236}">
-                <a16:creationId xmlns:a16="http://schemas.microsoft.com/office/drawing/2014/main" id="{5E554B2C-F725-4DE9-8673-F17C13DAFDEE}"/>
+                <a16:creationId xmlns:a16="http://schemas.microsoft.com/office/drawing/2014/main" id="{FAE21944-7AB2-4C86-8D64-D3AE7100BF05}"/>
               </a:ext>
             </a:extLst>
           </p:cNvPr>
@@ -10912,7 +10978,7 @@
           <p:cNvPr id="9" name="">
             <a:extLst xmlns:a="http://schemas.openxmlformats.org/drawingml/2006/main">
               <a:ext uri="{FF2B5EF4-FFF2-40B4-BE49-F238E27FC236}">
-                <a16:creationId xmlns:a16="http://schemas.microsoft.com/office/drawing/2014/main" id="{6A3CAD40-0203-44B7-93C9-2806188C2AB6}"/>
+                <a16:creationId xmlns:a16="http://schemas.microsoft.com/office/drawing/2014/main" id="{18B2A5FE-3D69-4800-96B3-657767A99771}"/>
               </a:ext>
             </a:extLst>
           </p:cNvPr>
@@ -10976,7 +11042,7 @@
     </p:spTree>
     <p:extLst>
       <p:ext uri="{BB962C8B-B14F-4D97-AF65-F5344CB8AC3E}">
-        <p14:creationId xmlns:p14="http://schemas.microsoft.com/office/powerpoint/2010/main" val="2066680307"/>
+        <p14:creationId xmlns:p14="http://schemas.microsoft.com/office/powerpoint/2010/main" val="1591236520"/>
       </p:ext>
     </p:extLst>
   </p:cSld>
@@ -11007,7 +11073,7 @@
           <p:cNvPr id="16" name="">
             <a:extLst xmlns:a="http://schemas.openxmlformats.org/drawingml/2006/main">
               <a:ext uri="{FF2B5EF4-FFF2-40B4-BE49-F238E27FC236}">
-                <a16:creationId xmlns:a16="http://schemas.microsoft.com/office/drawing/2014/main" id="{BF809330-AADF-47C0-8A19-FE59653813E1}"/>
+                <a16:creationId xmlns:a16="http://schemas.microsoft.com/office/drawing/2014/main" id="{4597D5C5-99A3-426A-B5C7-B6219265CFC6}"/>
               </a:ext>
             </a:extLst>
           </p:cNvPr>
@@ -11073,7 +11139,7 @@
           <p:cNvPr id="2" name="">
             <a:extLst xmlns:a="http://schemas.openxmlformats.org/drawingml/2006/main">
               <a:ext uri="{FF2B5EF4-FFF2-40B4-BE49-F238E27FC236}">
-                <a16:creationId xmlns:a16="http://schemas.microsoft.com/office/drawing/2014/main" id="{A10CD7B5-D9FF-423C-8841-DD6AFD619EE7}"/>
+                <a16:creationId xmlns:a16="http://schemas.microsoft.com/office/drawing/2014/main" id="{99A01590-0A59-4C8B-A6D2-A0A9B848C1C9}"/>
               </a:ext>
             </a:extLst>
           </p:cNvPr>
@@ -11139,7 +11205,7 @@
           <p:cNvPr id="3" name="">
             <a:extLst xmlns:a="http://schemas.openxmlformats.org/drawingml/2006/main">
               <a:ext uri="{FF2B5EF4-FFF2-40B4-BE49-F238E27FC236}">
-                <a16:creationId xmlns:a16="http://schemas.microsoft.com/office/drawing/2014/main" id="{6370B415-E698-4DE3-BD55-F48DEEA9D500}"/>
+                <a16:creationId xmlns:a16="http://schemas.microsoft.com/office/drawing/2014/main" id="{83B08E0A-CF4C-4109-9F71-4447EE292C41}"/>
               </a:ext>
             </a:extLst>
           </p:cNvPr>
@@ -11205,7 +11271,7 @@
           <p:cNvPr id="4" name="">
             <a:extLst xmlns:a="http://schemas.openxmlformats.org/drawingml/2006/main">
               <a:ext uri="{FF2B5EF4-FFF2-40B4-BE49-F238E27FC236}">
-                <a16:creationId xmlns:a16="http://schemas.microsoft.com/office/drawing/2014/main" id="{4C90D8E0-8402-4556-AF03-3E9692A7612B}"/>
+                <a16:creationId xmlns:a16="http://schemas.microsoft.com/office/drawing/2014/main" id="{A2F0BA9C-7DE2-4D75-935D-870BDB451F47}"/>
               </a:ext>
             </a:extLst>
           </p:cNvPr>
@@ -11271,7 +11337,7 @@
           <p:cNvPr id="5" name="">
             <a:extLst xmlns:a="http://schemas.openxmlformats.org/drawingml/2006/main">
               <a:ext uri="{FF2B5EF4-FFF2-40B4-BE49-F238E27FC236}">
-                <a16:creationId xmlns:a16="http://schemas.microsoft.com/office/drawing/2014/main" id="{33078251-32BF-499B-AC69-E9FAAF73C8AB}"/>
+                <a16:creationId xmlns:a16="http://schemas.microsoft.com/office/drawing/2014/main" id="{2493D1BE-2144-429C-84F6-5A0FB3738C98}"/>
               </a:ext>
             </a:extLst>
           </p:cNvPr>
@@ -11337,7 +11403,7 @@
           <p:cNvPr id="6" name="">
             <a:extLst xmlns:a="http://schemas.openxmlformats.org/drawingml/2006/main">
               <a:ext uri="{FF2B5EF4-FFF2-40B4-BE49-F238E27FC236}">
-                <a16:creationId xmlns:a16="http://schemas.microsoft.com/office/drawing/2014/main" id="{FF8507DF-6C51-4DC2-81AF-3F70403B5C43}"/>
+                <a16:creationId xmlns:a16="http://schemas.microsoft.com/office/drawing/2014/main" id="{8C5068B8-D9EE-45F4-B1A2-F88135E26EEC}"/>
               </a:ext>
             </a:extLst>
           </p:cNvPr>
@@ -11403,7 +11469,7 @@
           <p:cNvPr id="7" name="">
             <a:extLst xmlns:a="http://schemas.openxmlformats.org/drawingml/2006/main">
               <a:ext uri="{FF2B5EF4-FFF2-40B4-BE49-F238E27FC236}">
-                <a16:creationId xmlns:a16="http://schemas.microsoft.com/office/drawing/2014/main" id="{5EF9F051-0E9B-462B-A793-29F6D3F3696B}"/>
+                <a16:creationId xmlns:a16="http://schemas.microsoft.com/office/drawing/2014/main" id="{CFC5AF0E-B22C-4F9A-A6F3-5A3642EF6D0B}"/>
               </a:ext>
             </a:extLst>
           </p:cNvPr>
@@ -11469,7 +11535,7 @@
           <p:cNvPr id="8" name="">
             <a:extLst xmlns:a="http://schemas.openxmlformats.org/drawingml/2006/main">
               <a:ext uri="{FF2B5EF4-FFF2-40B4-BE49-F238E27FC236}">
-                <a16:creationId xmlns:a16="http://schemas.microsoft.com/office/drawing/2014/main" id="{7FF4176E-DC57-402F-92DE-648CC9E92F2C}"/>
+                <a16:creationId xmlns:a16="http://schemas.microsoft.com/office/drawing/2014/main" id="{6B9CC6A9-F628-4ACF-BE00-BE0915AE7681}"/>
               </a:ext>
             </a:extLst>
           </p:cNvPr>
@@ -11535,7 +11601,7 @@
           <p:cNvPr id="9" name="">
             <a:extLst xmlns:a="http://schemas.openxmlformats.org/drawingml/2006/main">
               <a:ext uri="{FF2B5EF4-FFF2-40B4-BE49-F238E27FC236}">
-                <a16:creationId xmlns:a16="http://schemas.microsoft.com/office/drawing/2014/main" id="{63596091-C39E-490B-80E0-C916D91EA65B}"/>
+                <a16:creationId xmlns:a16="http://schemas.microsoft.com/office/drawing/2014/main" id="{2AFDCBC6-9D69-42FA-9487-686D734EB362}"/>
               </a:ext>
             </a:extLst>
           </p:cNvPr>
@@ -11601,7 +11667,7 @@
           <p:cNvPr id="10" name="">
             <a:extLst xmlns:a="http://schemas.openxmlformats.org/drawingml/2006/main">
               <a:ext uri="{FF2B5EF4-FFF2-40B4-BE49-F238E27FC236}">
-                <a16:creationId xmlns:a16="http://schemas.microsoft.com/office/drawing/2014/main" id="{1E2CAFB5-7ACA-465D-A4C8-FF9EDB29BC8B}"/>
+                <a16:creationId xmlns:a16="http://schemas.microsoft.com/office/drawing/2014/main" id="{B89D4C32-37F7-46CB-AC01-94D729DC8B6C}"/>
               </a:ext>
             </a:extLst>
           </p:cNvPr>
@@ -11667,7 +11733,7 @@
           <p:cNvPr id="11" name="">
             <a:extLst xmlns:a="http://schemas.openxmlformats.org/drawingml/2006/main">
               <a:ext uri="{FF2B5EF4-FFF2-40B4-BE49-F238E27FC236}">
-                <a16:creationId xmlns:a16="http://schemas.microsoft.com/office/drawing/2014/main" id="{1536D89E-0ED5-4D3A-9CA6-1B141DCB1CC2}"/>
+                <a16:creationId xmlns:a16="http://schemas.microsoft.com/office/drawing/2014/main" id="{7EA1D0CA-69EB-44BE-BB5A-1A6E107EDBAE}"/>
               </a:ext>
             </a:extLst>
           </p:cNvPr>
@@ -11733,7 +11799,7 @@
           <p:cNvPr id="12" name="">
             <a:extLst xmlns:a="http://schemas.openxmlformats.org/drawingml/2006/main">
               <a:ext uri="{FF2B5EF4-FFF2-40B4-BE49-F238E27FC236}">
-                <a16:creationId xmlns:a16="http://schemas.microsoft.com/office/drawing/2014/main" id="{BB0BD402-EB37-4617-AF9C-17810CEE5FDF}"/>
+                <a16:creationId xmlns:a16="http://schemas.microsoft.com/office/drawing/2014/main" id="{8B6F8F3E-6803-45E0-857B-DB353448DE10}"/>
               </a:ext>
             </a:extLst>
           </p:cNvPr>
@@ -11799,7 +11865,7 @@
           <p:cNvPr id="13" name="">
             <a:extLst xmlns:a="http://schemas.openxmlformats.org/drawingml/2006/main">
               <a:ext uri="{FF2B5EF4-FFF2-40B4-BE49-F238E27FC236}">
-                <a16:creationId xmlns:a16="http://schemas.microsoft.com/office/drawing/2014/main" id="{462E17B7-D178-4842-948F-504DFE3E9D78}"/>
+                <a16:creationId xmlns:a16="http://schemas.microsoft.com/office/drawing/2014/main" id="{1EA9DF49-8061-4EEB-9AB8-9DDF613F6B11}"/>
               </a:ext>
             </a:extLst>
           </p:cNvPr>
@@ -11865,7 +11931,7 @@
           <p:cNvPr id="14" name="">
             <a:extLst xmlns:a="http://schemas.openxmlformats.org/drawingml/2006/main">
               <a:ext uri="{FF2B5EF4-FFF2-40B4-BE49-F238E27FC236}">
-                <a16:creationId xmlns:a16="http://schemas.microsoft.com/office/drawing/2014/main" id="{C4C44CE4-038C-4ED4-83DB-F4F12059887D}"/>
+                <a16:creationId xmlns:a16="http://schemas.microsoft.com/office/drawing/2014/main" id="{7D855DCE-AD67-45E2-9A22-1D31921441EF}"/>
               </a:ext>
             </a:extLst>
           </p:cNvPr>
@@ -11931,7 +11997,7 @@
           <p:cNvPr id="15" name="">
             <a:extLst xmlns:a="http://schemas.openxmlformats.org/drawingml/2006/main">
               <a:ext uri="{FF2B5EF4-FFF2-40B4-BE49-F238E27FC236}">
-                <a16:creationId xmlns:a16="http://schemas.microsoft.com/office/drawing/2014/main" id="{1583E04B-929D-46CA-934D-4429CDF9DCE3}"/>
+                <a16:creationId xmlns:a16="http://schemas.microsoft.com/office/drawing/2014/main" id="{3EAED5FD-DF60-4131-A946-944C587E64CE}"/>
               </a:ext>
             </a:extLst>
           </p:cNvPr>
@@ -11995,7 +12061,7 @@
     </p:spTree>
     <p:extLst>
       <p:ext uri="{BB962C8B-B14F-4D97-AF65-F5344CB8AC3E}">
-        <p14:creationId xmlns:p14="http://schemas.microsoft.com/office/powerpoint/2010/main" val="985532336"/>
+        <p14:creationId xmlns:p14="http://schemas.microsoft.com/office/powerpoint/2010/main" val="1227914953"/>
       </p:ext>
     </p:extLst>
   </p:cSld>
@@ -12026,7 +12092,7 @@
           <p:cNvPr id="17" name="">
             <a:extLst xmlns:a="http://schemas.openxmlformats.org/drawingml/2006/main">
               <a:ext uri="{FF2B5EF4-FFF2-40B4-BE49-F238E27FC236}">
-                <a16:creationId xmlns:a16="http://schemas.microsoft.com/office/drawing/2014/main" id="{12CC59D0-58B0-48D8-A45C-28369BC1030F}"/>
+                <a16:creationId xmlns:a16="http://schemas.microsoft.com/office/drawing/2014/main" id="{7CCFF7E0-D4F1-4D9A-912E-F010087ACC0A}"/>
               </a:ext>
             </a:extLst>
           </p:cNvPr>
@@ -12092,7 +12158,7 @@
           <p:cNvPr id="2" name="">
             <a:extLst xmlns:a="http://schemas.openxmlformats.org/drawingml/2006/main">
               <a:ext uri="{FF2B5EF4-FFF2-40B4-BE49-F238E27FC236}">
-                <a16:creationId xmlns:a16="http://schemas.microsoft.com/office/drawing/2014/main" id="{9F595929-5C6F-444F-B3D6-3EBFBA360C88}"/>
+                <a16:creationId xmlns:a16="http://schemas.microsoft.com/office/drawing/2014/main" id="{73A5BEE8-89F7-4650-9A45-DF625A745733}"/>
               </a:ext>
             </a:extLst>
           </p:cNvPr>
@@ -12158,7 +12224,7 @@
           <p:cNvPr id="3" name="">
             <a:extLst xmlns:a="http://schemas.openxmlformats.org/drawingml/2006/main">
               <a:ext uri="{FF2B5EF4-FFF2-40B4-BE49-F238E27FC236}">
-                <a16:creationId xmlns:a16="http://schemas.microsoft.com/office/drawing/2014/main" id="{BBB6FA14-A825-43ED-9B85-AE30022DEBE8}"/>
+                <a16:creationId xmlns:a16="http://schemas.microsoft.com/office/drawing/2014/main" id="{D82C5F94-569B-444F-B626-59703DE07DBF}"/>
               </a:ext>
             </a:extLst>
           </p:cNvPr>
@@ -12224,7 +12290,7 @@
           <p:cNvPr id="4" name="">
             <a:extLst xmlns:a="http://schemas.openxmlformats.org/drawingml/2006/main">
               <a:ext uri="{FF2B5EF4-FFF2-40B4-BE49-F238E27FC236}">
-                <a16:creationId xmlns:a16="http://schemas.microsoft.com/office/drawing/2014/main" id="{7A840185-3E5B-425A-AD30-D1A50BF237C5}"/>
+                <a16:creationId xmlns:a16="http://schemas.microsoft.com/office/drawing/2014/main" id="{DDD3975E-C4EA-4E24-978F-68E64EEB031C}"/>
               </a:ext>
             </a:extLst>
           </p:cNvPr>
@@ -12290,7 +12356,7 @@
           <p:cNvPr id="5" name="">
             <a:extLst xmlns:a="http://schemas.openxmlformats.org/drawingml/2006/main">
               <a:ext uri="{FF2B5EF4-FFF2-40B4-BE49-F238E27FC236}">
-                <a16:creationId xmlns:a16="http://schemas.microsoft.com/office/drawing/2014/main" id="{F456EDCE-E3EB-4723-BB32-6AB2AFDE2B9D}"/>
+                <a16:creationId xmlns:a16="http://schemas.microsoft.com/office/drawing/2014/main" id="{4BE9B525-9B90-4833-A027-50500444458F}"/>
               </a:ext>
             </a:extLst>
           </p:cNvPr>
@@ -12356,7 +12422,7 @@
           <p:cNvPr id="6" name="">
             <a:extLst xmlns:a="http://schemas.openxmlformats.org/drawingml/2006/main">
               <a:ext uri="{FF2B5EF4-FFF2-40B4-BE49-F238E27FC236}">
-                <a16:creationId xmlns:a16="http://schemas.microsoft.com/office/drawing/2014/main" id="{A9B726B8-6251-4434-8997-D57A01779747}"/>
+                <a16:creationId xmlns:a16="http://schemas.microsoft.com/office/drawing/2014/main" id="{60FE6226-6EA9-4908-AE2F-C6DB90C9A325}"/>
               </a:ext>
             </a:extLst>
           </p:cNvPr>
@@ -12422,7 +12488,7 @@
           <p:cNvPr id="7" name="">
             <a:extLst xmlns:a="http://schemas.openxmlformats.org/drawingml/2006/main">
               <a:ext uri="{FF2B5EF4-FFF2-40B4-BE49-F238E27FC236}">
-                <a16:creationId xmlns:a16="http://schemas.microsoft.com/office/drawing/2014/main" id="{A6ACD29F-9BE6-482C-A924-6E8B0F731862}"/>
+                <a16:creationId xmlns:a16="http://schemas.microsoft.com/office/drawing/2014/main" id="{6FA91820-FD30-4613-AA68-2A99450028D2}"/>
               </a:ext>
             </a:extLst>
           </p:cNvPr>
@@ -12488,7 +12554,7 @@
           <p:cNvPr id="8" name="">
             <a:extLst xmlns:a="http://schemas.openxmlformats.org/drawingml/2006/main">
               <a:ext uri="{FF2B5EF4-FFF2-40B4-BE49-F238E27FC236}">
-                <a16:creationId xmlns:a16="http://schemas.microsoft.com/office/drawing/2014/main" id="{2F65E0F8-A59E-468E-A94F-51044D748D39}"/>
+                <a16:creationId xmlns:a16="http://schemas.microsoft.com/office/drawing/2014/main" id="{39BCB891-B089-4939-80A4-6F35197F3D50}"/>
               </a:ext>
             </a:extLst>
           </p:cNvPr>
@@ -12554,7 +12620,7 @@
           <p:cNvPr id="9" name="">
             <a:extLst xmlns:a="http://schemas.openxmlformats.org/drawingml/2006/main">
               <a:ext uri="{FF2B5EF4-FFF2-40B4-BE49-F238E27FC236}">
-                <a16:creationId xmlns:a16="http://schemas.microsoft.com/office/drawing/2014/main" id="{DACECB8C-A4A5-410A-B92F-15B1A698663C}"/>
+                <a16:creationId xmlns:a16="http://schemas.microsoft.com/office/drawing/2014/main" id="{155FA201-D7B4-416E-88A2-A96A9D7959ED}"/>
               </a:ext>
             </a:extLst>
           </p:cNvPr>
@@ -12620,7 +12686,7 @@
           <p:cNvPr id="10" name="">
             <a:extLst xmlns:a="http://schemas.openxmlformats.org/drawingml/2006/main">
               <a:ext uri="{FF2B5EF4-FFF2-40B4-BE49-F238E27FC236}">
-                <a16:creationId xmlns:a16="http://schemas.microsoft.com/office/drawing/2014/main" id="{83A32F16-1A69-4C86-89D9-C2C12AD7D243}"/>
+                <a16:creationId xmlns:a16="http://schemas.microsoft.com/office/drawing/2014/main" id="{C7194844-0DA8-4D00-B0E2-A84A96BD3486}"/>
               </a:ext>
             </a:extLst>
           </p:cNvPr>
@@ -12686,7 +12752,7 @@
           <p:cNvPr id="11" name="">
             <a:extLst xmlns:a="http://schemas.openxmlformats.org/drawingml/2006/main">
               <a:ext uri="{FF2B5EF4-FFF2-40B4-BE49-F238E27FC236}">
-                <a16:creationId xmlns:a16="http://schemas.microsoft.com/office/drawing/2014/main" id="{9ADDD18A-07AC-4CB5-96B9-57A1F7A9BC84}"/>
+                <a16:creationId xmlns:a16="http://schemas.microsoft.com/office/drawing/2014/main" id="{0B95B74E-DD02-474C-9F82-1BC3BEEFEFD2}"/>
               </a:ext>
             </a:extLst>
           </p:cNvPr>
@@ -12752,7 +12818,7 @@
           <p:cNvPr id="12" name="">
             <a:extLst xmlns:a="http://schemas.openxmlformats.org/drawingml/2006/main">
               <a:ext uri="{FF2B5EF4-FFF2-40B4-BE49-F238E27FC236}">
-                <a16:creationId xmlns:a16="http://schemas.microsoft.com/office/drawing/2014/main" id="{6A9E0AF9-36FD-4433-AA3B-5E7FF7980BBC}"/>
+                <a16:creationId xmlns:a16="http://schemas.microsoft.com/office/drawing/2014/main" id="{7B5A5871-8112-4ABE-A46E-77E6DF8FD887}"/>
               </a:ext>
             </a:extLst>
           </p:cNvPr>
@@ -12818,7 +12884,7 @@
           <p:cNvPr id="13" name="">
             <a:extLst xmlns:a="http://schemas.openxmlformats.org/drawingml/2006/main">
               <a:ext uri="{FF2B5EF4-FFF2-40B4-BE49-F238E27FC236}">
-                <a16:creationId xmlns:a16="http://schemas.microsoft.com/office/drawing/2014/main" id="{B00900B1-82B8-4E3F-8C8E-C48626CEF2FE}"/>
+                <a16:creationId xmlns:a16="http://schemas.microsoft.com/office/drawing/2014/main" id="{C42768E1-4E64-4CE0-8BD0-B053940EEB98}"/>
               </a:ext>
             </a:extLst>
           </p:cNvPr>
@@ -12884,7 +12950,7 @@
           <p:cNvPr id="14" name="">
             <a:extLst xmlns:a="http://schemas.openxmlformats.org/drawingml/2006/main">
               <a:ext uri="{FF2B5EF4-FFF2-40B4-BE49-F238E27FC236}">
-                <a16:creationId xmlns:a16="http://schemas.microsoft.com/office/drawing/2014/main" id="{86B984FF-00AD-406F-A36C-0C1AC7C4C1E1}"/>
+                <a16:creationId xmlns:a16="http://schemas.microsoft.com/office/drawing/2014/main" id="{092C8717-CEDD-43D0-8324-32954B506289}"/>
               </a:ext>
             </a:extLst>
           </p:cNvPr>
@@ -12950,7 +13016,7 @@
           <p:cNvPr id="15" name="">
             <a:extLst xmlns:a="http://schemas.openxmlformats.org/drawingml/2006/main">
               <a:ext uri="{FF2B5EF4-FFF2-40B4-BE49-F238E27FC236}">
-                <a16:creationId xmlns:a16="http://schemas.microsoft.com/office/drawing/2014/main" id="{DD2F6D94-06DA-47C9-8C6D-628305FABFD0}"/>
+                <a16:creationId xmlns:a16="http://schemas.microsoft.com/office/drawing/2014/main" id="{515F64F4-D1EA-463F-A07C-84F26ABCF543}"/>
               </a:ext>
             </a:extLst>
           </p:cNvPr>
@@ -13016,7 +13082,7 @@
           <p:cNvPr id="16" name="">
             <a:extLst xmlns:a="http://schemas.openxmlformats.org/drawingml/2006/main">
               <a:ext uri="{FF2B5EF4-FFF2-40B4-BE49-F238E27FC236}">
-                <a16:creationId xmlns:a16="http://schemas.microsoft.com/office/drawing/2014/main" id="{97F2153B-F71E-40C4-9B6A-267198C69642}"/>
+                <a16:creationId xmlns:a16="http://schemas.microsoft.com/office/drawing/2014/main" id="{54CA9A86-DE03-4886-AD1F-28AEA61E66E9}"/>
               </a:ext>
             </a:extLst>
           </p:cNvPr>
@@ -13080,7 +13146,7 @@
     </p:spTree>
     <p:extLst>
       <p:ext uri="{BB962C8B-B14F-4D97-AF65-F5344CB8AC3E}">
-        <p14:creationId xmlns:p14="http://schemas.microsoft.com/office/powerpoint/2010/main" val="800491739"/>
+        <p14:creationId xmlns:p14="http://schemas.microsoft.com/office/powerpoint/2010/main" val="140390463"/>
       </p:ext>
     </p:extLst>
   </p:cSld>

</xml_diff>

<commit_message>
Complete presentation team with Avishkar Rathod
</commit_message>
<xml_diff>
--- a/docs/presentation/RideX-Ideathon-Presentation.pptx
+++ b/docs/presentation/RideX-Ideathon-Presentation.pptx
@@ -2,24 +2,24 @@
 <file path=ppt/presentation.xml><?xml version="1.0" encoding="utf-8"?>
 <p:presentation xmlns:p="http://schemas.openxmlformats.org/presentationml/2006/main">
   <p:sldMasterIdLst>
-    <p:sldMasterId xmlns:r="http://schemas.openxmlformats.org/officeDocument/2006/relationships" id="2147483648" r:id="R75b04baa955c4d38"/>
+    <p:sldMasterId xmlns:r="http://schemas.openxmlformats.org/officeDocument/2006/relationships" id="2147483648" r:id="Ra2d216a2a8e54bef"/>
   </p:sldMasterIdLst>
   <p:notesMasterIdLst>
-    <p:notesMasterId xmlns:r="http://schemas.openxmlformats.org/officeDocument/2006/relationships" r:id="R931a19c84f0744a3"/>
+    <p:notesMasterId xmlns:r="http://schemas.openxmlformats.org/officeDocument/2006/relationships" r:id="Rb41a68b57b714082"/>
   </p:notesMasterIdLst>
   <p:sldIdLst>
-    <p:sldId xmlns:r="http://schemas.openxmlformats.org/officeDocument/2006/relationships" id="256" r:id="R84ce84ed2a0e47ca"/>
-    <p:sldId xmlns:r="http://schemas.openxmlformats.org/officeDocument/2006/relationships" id="257" r:id="R38d48fcc666e4eb2"/>
-    <p:sldId xmlns:r="http://schemas.openxmlformats.org/officeDocument/2006/relationships" id="258" r:id="R06427f8b4b2c4bf5"/>
-    <p:sldId xmlns:r="http://schemas.openxmlformats.org/officeDocument/2006/relationships" id="259" r:id="Rb455e3390a444772"/>
-    <p:sldId xmlns:r="http://schemas.openxmlformats.org/officeDocument/2006/relationships" id="260" r:id="R76d5f440d7894cbb"/>
-    <p:sldId xmlns:r="http://schemas.openxmlformats.org/officeDocument/2006/relationships" id="261" r:id="R9e1f34a415a34381"/>
-    <p:sldId xmlns:r="http://schemas.openxmlformats.org/officeDocument/2006/relationships" id="262" r:id="R23f1b9271d234aed"/>
-    <p:sldId xmlns:r="http://schemas.openxmlformats.org/officeDocument/2006/relationships" id="263" r:id="R590692307e3d465c"/>
-    <p:sldId xmlns:r="http://schemas.openxmlformats.org/officeDocument/2006/relationships" id="264" r:id="R40752932c8fc4948"/>
-    <p:sldId xmlns:r="http://schemas.openxmlformats.org/officeDocument/2006/relationships" id="265" r:id="Ra9d3c964f69e4030"/>
-    <p:sldId xmlns:r="http://schemas.openxmlformats.org/officeDocument/2006/relationships" id="266" r:id="R37996e5843244d9e"/>
-    <p:sldId xmlns:r="http://schemas.openxmlformats.org/officeDocument/2006/relationships" id="267" r:id="R4f1bcb14f2204225"/>
+    <p:sldId xmlns:r="http://schemas.openxmlformats.org/officeDocument/2006/relationships" id="256" r:id="R0bd6320c6fd04b52"/>
+    <p:sldId xmlns:r="http://schemas.openxmlformats.org/officeDocument/2006/relationships" id="257" r:id="Rae7e826d06ef4108"/>
+    <p:sldId xmlns:r="http://schemas.openxmlformats.org/officeDocument/2006/relationships" id="258" r:id="R748cba32d9cc49ae"/>
+    <p:sldId xmlns:r="http://schemas.openxmlformats.org/officeDocument/2006/relationships" id="259" r:id="R3d141312c603424b"/>
+    <p:sldId xmlns:r="http://schemas.openxmlformats.org/officeDocument/2006/relationships" id="260" r:id="R009803513dbb44fa"/>
+    <p:sldId xmlns:r="http://schemas.openxmlformats.org/officeDocument/2006/relationships" id="261" r:id="R76bbde7a124f49c7"/>
+    <p:sldId xmlns:r="http://schemas.openxmlformats.org/officeDocument/2006/relationships" id="262" r:id="R560045ce4e2a4615"/>
+    <p:sldId xmlns:r="http://schemas.openxmlformats.org/officeDocument/2006/relationships" id="263" r:id="R42f055b28a294bc1"/>
+    <p:sldId xmlns:r="http://schemas.openxmlformats.org/officeDocument/2006/relationships" id="264" r:id="R333263571cf74f85"/>
+    <p:sldId xmlns:r="http://schemas.openxmlformats.org/officeDocument/2006/relationships" id="265" r:id="R4bf58ea5361b4db1"/>
+    <p:sldId xmlns:r="http://schemas.openxmlformats.org/officeDocument/2006/relationships" id="266" r:id="R10cac07668994aeb"/>
+    <p:sldId xmlns:r="http://schemas.openxmlformats.org/officeDocument/2006/relationships" id="267" r:id="R35e29188c5ad4bb5"/>
   </p:sldIdLst>
   <p:sldSz cx="12192000" cy="6858000"/>
   <p:notesSz cx="6858000" cy="9144000"/>
@@ -1330,7 +1330,7 @@
           <p:cNvPr id="3" name="Title">
             <a:extLst xmlns:a="http://schemas.openxmlformats.org/drawingml/2006/main">
               <a:ext uri="{FF2B5EF4-FFF2-40B4-BE49-F238E27FC236}">
-                <a16:creationId xmlns:a16="http://schemas.microsoft.com/office/drawing/2014/main" id="{4CE3C5F9-554A-4D9B-8BB3-3863B121B78A}"/>
+                <a16:creationId xmlns:a16="http://schemas.microsoft.com/office/drawing/2014/main" id="{3BFC9AAC-1561-48D1-A581-5D82E33D96ED}"/>
               </a:ext>
             </a:extLst>
           </p:cNvPr>
@@ -1487,7 +1487,7 @@
           <p:cNvPr id="2" name="Subtitle">
             <a:extLst xmlns:a="http://schemas.openxmlformats.org/drawingml/2006/main">
               <a:ext uri="{FF2B5EF4-FFF2-40B4-BE49-F238E27FC236}">
-                <a16:creationId xmlns:a16="http://schemas.microsoft.com/office/drawing/2014/main" id="{0AA266E9-1FFC-4BEF-9301-0999CC9FB211}"/>
+                <a16:creationId xmlns:a16="http://schemas.microsoft.com/office/drawing/2014/main" id="{001787C8-7B88-40F9-9B58-B7416E49CE99}"/>
               </a:ext>
             </a:extLst>
           </p:cNvPr>
@@ -1661,7 +1661,7 @@
           <p:cNvPr id="2" name="Section title">
             <a:extLst xmlns:a="http://schemas.openxmlformats.org/drawingml/2006/main">
               <a:ext uri="{FF2B5EF4-FFF2-40B4-BE49-F238E27FC236}">
-                <a16:creationId xmlns:a16="http://schemas.microsoft.com/office/drawing/2014/main" id="{6738671D-4B4C-4043-97EC-275301DEC579}"/>
+                <a16:creationId xmlns:a16="http://schemas.microsoft.com/office/drawing/2014/main" id="{A7654312-76BF-4D41-957B-330B0A11827E}"/>
               </a:ext>
             </a:extLst>
           </p:cNvPr>
@@ -1835,7 +1835,7 @@
           <p:cNvPr id="3" name="Title">
             <a:extLst xmlns:a="http://schemas.openxmlformats.org/drawingml/2006/main">
               <a:ext uri="{FF2B5EF4-FFF2-40B4-BE49-F238E27FC236}">
-                <a16:creationId xmlns:a16="http://schemas.microsoft.com/office/drawing/2014/main" id="{CD1F93DA-BFF4-4C4E-B93B-B41FDB8839AC}"/>
+                <a16:creationId xmlns:a16="http://schemas.microsoft.com/office/drawing/2014/main" id="{03858E46-E507-4FFF-A65C-83ADEC9BA539}"/>
               </a:ext>
             </a:extLst>
           </p:cNvPr>
@@ -1992,7 +1992,7 @@
           <p:cNvPr id="2" name="Body">
             <a:extLst xmlns:a="http://schemas.openxmlformats.org/drawingml/2006/main">
               <a:ext uri="{FF2B5EF4-FFF2-40B4-BE49-F238E27FC236}">
-                <a16:creationId xmlns:a16="http://schemas.microsoft.com/office/drawing/2014/main" id="{5EF662EE-61C8-4E04-8F63-273109667FAC}"/>
+                <a16:creationId xmlns:a16="http://schemas.microsoft.com/office/drawing/2014/main" id="{DF6EB3F6-5F30-43EA-B59F-1101EBA00717}"/>
               </a:ext>
             </a:extLst>
           </p:cNvPr>
@@ -2166,7 +2166,7 @@
           <p:cNvPr id="4" name="Title">
             <a:extLst xmlns:a="http://schemas.openxmlformats.org/drawingml/2006/main">
               <a:ext uri="{FF2B5EF4-FFF2-40B4-BE49-F238E27FC236}">
-                <a16:creationId xmlns:a16="http://schemas.microsoft.com/office/drawing/2014/main" id="{2CF7B552-FA4E-4F91-994C-85EC34E6E15C}"/>
+                <a16:creationId xmlns:a16="http://schemas.microsoft.com/office/drawing/2014/main" id="{63182BE2-BF3E-4622-A6A4-A808B62F8C9C}"/>
               </a:ext>
             </a:extLst>
           </p:cNvPr>
@@ -2323,7 +2323,7 @@
           <p:cNvPr id="2" name="Left column">
             <a:extLst xmlns:a="http://schemas.openxmlformats.org/drawingml/2006/main">
               <a:ext uri="{FF2B5EF4-FFF2-40B4-BE49-F238E27FC236}">
-                <a16:creationId xmlns:a16="http://schemas.microsoft.com/office/drawing/2014/main" id="{00613218-1CCB-464D-BA76-8CB0C200FE38}"/>
+                <a16:creationId xmlns:a16="http://schemas.microsoft.com/office/drawing/2014/main" id="{7517553F-B773-4EF0-8E97-362A16F53F48}"/>
               </a:ext>
             </a:extLst>
           </p:cNvPr>
@@ -2480,7 +2480,7 @@
           <p:cNvPr id="3" name="Right column">
             <a:extLst xmlns:a="http://schemas.openxmlformats.org/drawingml/2006/main">
               <a:ext uri="{FF2B5EF4-FFF2-40B4-BE49-F238E27FC236}">
-                <a16:creationId xmlns:a16="http://schemas.microsoft.com/office/drawing/2014/main" id="{9D24E85C-F908-45E1-8197-B7340C4EE5B4}"/>
+                <a16:creationId xmlns:a16="http://schemas.microsoft.com/office/drawing/2014/main" id="{809FD3E9-5CAA-4DED-B16F-0FAC64B78475}"/>
               </a:ext>
             </a:extLst>
           </p:cNvPr>
@@ -2654,7 +2654,7 @@
           <p:cNvPr id="3" name="Title">
             <a:extLst xmlns:a="http://schemas.openxmlformats.org/drawingml/2006/main">
               <a:ext uri="{FF2B5EF4-FFF2-40B4-BE49-F238E27FC236}">
-                <a16:creationId xmlns:a16="http://schemas.microsoft.com/office/drawing/2014/main" id="{E3AEBE91-80B5-4878-AA0B-D484C67F1663}"/>
+                <a16:creationId xmlns:a16="http://schemas.microsoft.com/office/drawing/2014/main" id="{25825205-E687-4C2A-909F-35D41E393F19}"/>
               </a:ext>
             </a:extLst>
           </p:cNvPr>
@@ -2811,7 +2811,7 @@
           <p:cNvPr id="2" name="Left column">
             <a:extLst xmlns:a="http://schemas.openxmlformats.org/drawingml/2006/main">
               <a:ext uri="{FF2B5EF4-FFF2-40B4-BE49-F238E27FC236}">
-                <a16:creationId xmlns:a16="http://schemas.microsoft.com/office/drawing/2014/main" id="{FA14D913-C050-43DF-8471-DC7041299E97}"/>
+                <a16:creationId xmlns:a16="http://schemas.microsoft.com/office/drawing/2014/main" id="{A1EEB579-6693-4693-935B-32BB3678C51C}"/>
               </a:ext>
             </a:extLst>
           </p:cNvPr>
@@ -3006,12 +3006,12 @@
   </p:cSld>
   <p:clrMap bg1="lt1" tx1="dk1" bg2="lt2" tx2="dk2" accent1="accent1" accent2="accent2" accent3="accent3" accent4="accent4" accent5="accent5" accent6="accent6" hlink="hlink" folHlink="folHlink"/>
   <p:sldLayoutIdLst>
-    <p:sldLayoutId xmlns:r="http://schemas.openxmlformats.org/officeDocument/2006/relationships" id="2147483649" r:id="R4d0684a4369c4723"/>
-    <p:sldLayoutId xmlns:r="http://schemas.openxmlformats.org/officeDocument/2006/relationships" id="2147483650" r:id="R17cd5a6d3c294aca"/>
-    <p:sldLayoutId xmlns:r="http://schemas.openxmlformats.org/officeDocument/2006/relationships" id="2147483651" r:id="R5cee28230db44dd6"/>
-    <p:sldLayoutId xmlns:r="http://schemas.openxmlformats.org/officeDocument/2006/relationships" id="2147483652" r:id="Rc1340c2726d4442b"/>
-    <p:sldLayoutId xmlns:r="http://schemas.openxmlformats.org/officeDocument/2006/relationships" id="2147483653" r:id="R2c636234b5804761"/>
-    <p:sldLayoutId xmlns:r="http://schemas.openxmlformats.org/officeDocument/2006/relationships" id="2147483654" r:id="R5bc13a92f41e49b3"/>
+    <p:sldLayoutId xmlns:r="http://schemas.openxmlformats.org/officeDocument/2006/relationships" id="2147483649" r:id="R4a30619f73cd4f24"/>
+    <p:sldLayoutId xmlns:r="http://schemas.openxmlformats.org/officeDocument/2006/relationships" id="2147483650" r:id="Ref8b01ecf48b414e"/>
+    <p:sldLayoutId xmlns:r="http://schemas.openxmlformats.org/officeDocument/2006/relationships" id="2147483651" r:id="Rf4e9c8fdbe08432b"/>
+    <p:sldLayoutId xmlns:r="http://schemas.openxmlformats.org/officeDocument/2006/relationships" id="2147483652" r:id="Rfe1cabc66ac049a0"/>
+    <p:sldLayoutId xmlns:r="http://schemas.openxmlformats.org/officeDocument/2006/relationships" id="2147483653" r:id="R88a61122cf654789"/>
+    <p:sldLayoutId xmlns:r="http://schemas.openxmlformats.org/officeDocument/2006/relationships" id="2147483654" r:id="R7244b193adaf450d"/>
   </p:sldLayoutIdLst>
   <p:txStyles>
     <p:titleStyle>
@@ -3562,7 +3562,7 @@
           <p:cNvPr id="7" name="">
             <a:extLst xmlns:a="http://schemas.openxmlformats.org/drawingml/2006/main">
               <a:ext uri="{FF2B5EF4-FFF2-40B4-BE49-F238E27FC236}">
-                <a16:creationId xmlns:a16="http://schemas.microsoft.com/office/drawing/2014/main" id="{FB422768-15FA-4A2F-8981-69A4941E7650}"/>
+                <a16:creationId xmlns:a16="http://schemas.microsoft.com/office/drawing/2014/main" id="{0EAFBAD7-CB6E-4555-8C2D-FE02C151A03D}"/>
               </a:ext>
             </a:extLst>
           </p:cNvPr>
@@ -3628,7 +3628,7 @@
           <p:cNvPr id="2" name="">
             <a:extLst xmlns:a="http://schemas.openxmlformats.org/drawingml/2006/main">
               <a:ext uri="{FF2B5EF4-FFF2-40B4-BE49-F238E27FC236}">
-                <a16:creationId xmlns:a16="http://schemas.microsoft.com/office/drawing/2014/main" id="{1808DF11-EA40-48E8-9376-B702442F7294}"/>
+                <a16:creationId xmlns:a16="http://schemas.microsoft.com/office/drawing/2014/main" id="{C64CC84D-C239-4084-A9D6-551E479F74A4}"/>
               </a:ext>
             </a:extLst>
           </p:cNvPr>
@@ -3694,7 +3694,7 @@
           <p:cNvPr id="3" name="">
             <a:extLst xmlns:a="http://schemas.openxmlformats.org/drawingml/2006/main">
               <a:ext uri="{FF2B5EF4-FFF2-40B4-BE49-F238E27FC236}">
-                <a16:creationId xmlns:a16="http://schemas.microsoft.com/office/drawing/2014/main" id="{C0BEA5F2-0A79-4FA2-9964-F862EBE4390A}"/>
+                <a16:creationId xmlns:a16="http://schemas.microsoft.com/office/drawing/2014/main" id="{820494D5-CB9B-4105-A563-C9C3E6631A2B}"/>
               </a:ext>
             </a:extLst>
           </p:cNvPr>
@@ -3760,7 +3760,7 @@
           <p:cNvPr id="4" name="">
             <a:extLst xmlns:a="http://schemas.openxmlformats.org/drawingml/2006/main">
               <a:ext uri="{FF2B5EF4-FFF2-40B4-BE49-F238E27FC236}">
-                <a16:creationId xmlns:a16="http://schemas.microsoft.com/office/drawing/2014/main" id="{34DF4802-F43A-4CC2-AA3D-7051D1B9252D}"/>
+                <a16:creationId xmlns:a16="http://schemas.microsoft.com/office/drawing/2014/main" id="{63CF31D0-2258-4B13-ABC8-6CB81B31FB97}"/>
               </a:ext>
             </a:extLst>
           </p:cNvPr>
@@ -3849,7 +3849,7 @@
           <p:cNvPr id="5" name="">
             <a:extLst xmlns:a="http://schemas.openxmlformats.org/drawingml/2006/main">
               <a:ext uri="{FF2B5EF4-FFF2-40B4-BE49-F238E27FC236}">
-                <a16:creationId xmlns:a16="http://schemas.microsoft.com/office/drawing/2014/main" id="{8DFBE67A-DC5D-43F6-B71F-801E14FD3F4A}"/>
+                <a16:creationId xmlns:a16="http://schemas.microsoft.com/office/drawing/2014/main" id="{3EC56584-5930-4101-B212-DB6A95198308}"/>
               </a:ext>
             </a:extLst>
           </p:cNvPr>
@@ -3938,7 +3938,7 @@
           <p:cNvPr id="6" name="">
             <a:extLst xmlns:a="http://schemas.openxmlformats.org/drawingml/2006/main">
               <a:ext uri="{FF2B5EF4-FFF2-40B4-BE49-F238E27FC236}">
-                <a16:creationId xmlns:a16="http://schemas.microsoft.com/office/drawing/2014/main" id="{8DA645CA-E437-428B-8B56-4AF75C14A805}"/>
+                <a16:creationId xmlns:a16="http://schemas.microsoft.com/office/drawing/2014/main" id="{369D1634-E2C8-4FD0-BD0D-684DB0E73431}"/>
               </a:ext>
             </a:extLst>
           </p:cNvPr>
@@ -3948,7 +3948,7 @@
           <p:nvPr/>
         </p:nvPicPr>
         <p:blipFill>
-          <a:blip xmlns:r="http://schemas.openxmlformats.org/officeDocument/2006/relationships" xmlns:a="http://schemas.openxmlformats.org/drawingml/2006/main" r:embed="Raa6c7deebf7a4212"/>
+          <a:blip xmlns:r="http://schemas.openxmlformats.org/officeDocument/2006/relationships" xmlns:a="http://schemas.openxmlformats.org/drawingml/2006/main" r:embed="Ree0cb5f5129e4807"/>
           <a:stretch xmlns:a="http://schemas.openxmlformats.org/drawingml/2006/main"/>
         </p:blipFill>
         <p:spPr>
@@ -3964,7 +3964,7 @@
     </p:spTree>
     <p:extLst>
       <p:ext uri="{BB962C8B-B14F-4D97-AF65-F5344CB8AC3E}">
-        <p14:creationId xmlns:p14="http://schemas.microsoft.com/office/powerpoint/2010/main" val="995620915"/>
+        <p14:creationId xmlns:p14="http://schemas.microsoft.com/office/powerpoint/2010/main" val="570566497"/>
       </p:ext>
     </p:extLst>
   </p:cSld>
@@ -3995,7 +3995,7 @@
           <p:cNvPr id="9" name="">
             <a:extLst xmlns:a="http://schemas.openxmlformats.org/drawingml/2006/main">
               <a:ext uri="{FF2B5EF4-FFF2-40B4-BE49-F238E27FC236}">
-                <a16:creationId xmlns:a16="http://schemas.microsoft.com/office/drawing/2014/main" id="{41A643B9-E546-4ECB-A33E-E3C2DF99BAE2}"/>
+                <a16:creationId xmlns:a16="http://schemas.microsoft.com/office/drawing/2014/main" id="{507E0482-B38B-47BC-94EC-943C3BF19E48}"/>
               </a:ext>
             </a:extLst>
           </p:cNvPr>
@@ -4061,7 +4061,7 @@
           <p:cNvPr id="2" name="">
             <a:extLst xmlns:a="http://schemas.openxmlformats.org/drawingml/2006/main">
               <a:ext uri="{FF2B5EF4-FFF2-40B4-BE49-F238E27FC236}">
-                <a16:creationId xmlns:a16="http://schemas.microsoft.com/office/drawing/2014/main" id="{8671DCAA-814C-43A2-A75F-F430434FE100}"/>
+                <a16:creationId xmlns:a16="http://schemas.microsoft.com/office/drawing/2014/main" id="{477758DE-D24F-4637-89BC-375D2563FCC0}"/>
               </a:ext>
             </a:extLst>
           </p:cNvPr>
@@ -4127,7 +4127,7 @@
           <p:cNvPr id="3" name="">
             <a:extLst xmlns:a="http://schemas.openxmlformats.org/drawingml/2006/main">
               <a:ext uri="{FF2B5EF4-FFF2-40B4-BE49-F238E27FC236}">
-                <a16:creationId xmlns:a16="http://schemas.microsoft.com/office/drawing/2014/main" id="{BBB152F4-BDEB-40D4-A850-C25F9C7B9F2F}"/>
+                <a16:creationId xmlns:a16="http://schemas.microsoft.com/office/drawing/2014/main" id="{18C99DE9-80DA-4AE7-9BC2-882EC6627C16}"/>
               </a:ext>
             </a:extLst>
           </p:cNvPr>
@@ -4193,7 +4193,7 @@
           <p:cNvPr id="4" name="">
             <a:extLst xmlns:a="http://schemas.openxmlformats.org/drawingml/2006/main">
               <a:ext uri="{FF2B5EF4-FFF2-40B4-BE49-F238E27FC236}">
-                <a16:creationId xmlns:a16="http://schemas.microsoft.com/office/drawing/2014/main" id="{8B61133D-CF53-4C72-BE6E-5D9C5F5C4CCC}"/>
+                <a16:creationId xmlns:a16="http://schemas.microsoft.com/office/drawing/2014/main" id="{5FB60625-BF22-4788-A886-65719C5720E2}"/>
               </a:ext>
             </a:extLst>
           </p:cNvPr>
@@ -4259,7 +4259,7 @@
           <p:cNvPr id="5" name="">
             <a:extLst xmlns:a="http://schemas.openxmlformats.org/drawingml/2006/main">
               <a:ext uri="{FF2B5EF4-FFF2-40B4-BE49-F238E27FC236}">
-                <a16:creationId xmlns:a16="http://schemas.microsoft.com/office/drawing/2014/main" id="{433DC691-D2EB-4E15-BCDC-D22DEFFE1D00}"/>
+                <a16:creationId xmlns:a16="http://schemas.microsoft.com/office/drawing/2014/main" id="{75EF23D1-E751-4892-BF17-2216A0B7A1BF}"/>
               </a:ext>
             </a:extLst>
           </p:cNvPr>
@@ -4417,7 +4417,7 @@
           <p:cNvPr id="6" name="">
             <a:extLst xmlns:a="http://schemas.openxmlformats.org/drawingml/2006/main">
               <a:ext uri="{FF2B5EF4-FFF2-40B4-BE49-F238E27FC236}">
-                <a16:creationId xmlns:a16="http://schemas.microsoft.com/office/drawing/2014/main" id="{741A3744-140D-46CD-8123-02F22D05350C}"/>
+                <a16:creationId xmlns:a16="http://schemas.microsoft.com/office/drawing/2014/main" id="{B6570884-1388-45DF-9B99-AAB279F720E4}"/>
               </a:ext>
             </a:extLst>
           </p:cNvPr>
@@ -4483,7 +4483,7 @@
           <p:cNvPr id="7" name="">
             <a:extLst xmlns:a="http://schemas.openxmlformats.org/drawingml/2006/main">
               <a:ext uri="{FF2B5EF4-FFF2-40B4-BE49-F238E27FC236}">
-                <a16:creationId xmlns:a16="http://schemas.microsoft.com/office/drawing/2014/main" id="{53B65E20-CA8E-424A-8FEC-79EB536A98B8}"/>
+                <a16:creationId xmlns:a16="http://schemas.microsoft.com/office/drawing/2014/main" id="{1D4AAAB6-C202-4058-BED9-B9098FCE70FF}"/>
               </a:ext>
             </a:extLst>
           </p:cNvPr>
@@ -4641,7 +4641,7 @@
           <p:cNvPr id="8" name="">
             <a:extLst xmlns:a="http://schemas.openxmlformats.org/drawingml/2006/main">
               <a:ext uri="{FF2B5EF4-FFF2-40B4-BE49-F238E27FC236}">
-                <a16:creationId xmlns:a16="http://schemas.microsoft.com/office/drawing/2014/main" id="{39BF71CB-6574-4E66-A079-A2AB0C54A3B7}"/>
+                <a16:creationId xmlns:a16="http://schemas.microsoft.com/office/drawing/2014/main" id="{DB36F4FC-D805-4688-86F0-15F525C66C1B}"/>
               </a:ext>
             </a:extLst>
           </p:cNvPr>
@@ -4705,7 +4705,7 @@
     </p:spTree>
     <p:extLst>
       <p:ext uri="{BB962C8B-B14F-4D97-AF65-F5344CB8AC3E}">
-        <p14:creationId xmlns:p14="http://schemas.microsoft.com/office/powerpoint/2010/main" val="763658201"/>
+        <p14:creationId xmlns:p14="http://schemas.microsoft.com/office/powerpoint/2010/main" val="1741819228"/>
       </p:ext>
     </p:extLst>
   </p:cSld>
@@ -4733,10 +4733,10 @@
       </p:grpSpPr>
       <p:sp>
         <p:nvSpPr>
-          <p:cNvPr id="9" name="">
-            <a:extLst xmlns:a="http://schemas.openxmlformats.org/drawingml/2006/main">
-              <a:ext uri="{FF2B5EF4-FFF2-40B4-BE49-F238E27FC236}">
-                <a16:creationId xmlns:a16="http://schemas.microsoft.com/office/drawing/2014/main" id="{6EBECC1B-15E1-4907-8414-1FF39C4E627D}"/>
+          <p:cNvPr id="11" name="">
+            <a:extLst xmlns:a="http://schemas.openxmlformats.org/drawingml/2006/main">
+              <a:ext uri="{FF2B5EF4-FFF2-40B4-BE49-F238E27FC236}">
+                <a16:creationId xmlns:a16="http://schemas.microsoft.com/office/drawing/2014/main" id="{CC316558-F3C9-490A-B28E-CF71626952B1}"/>
               </a:ext>
             </a:extLst>
           </p:cNvPr>
@@ -4802,7 +4802,7 @@
           <p:cNvPr id="2" name="">
             <a:extLst xmlns:a="http://schemas.openxmlformats.org/drawingml/2006/main">
               <a:ext uri="{FF2B5EF4-FFF2-40B4-BE49-F238E27FC236}">
-                <a16:creationId xmlns:a16="http://schemas.microsoft.com/office/drawing/2014/main" id="{76D8B45A-B8D0-4694-876A-AC64F5AE8FD0}"/>
+                <a16:creationId xmlns:a16="http://schemas.microsoft.com/office/drawing/2014/main" id="{24E2C912-2CBD-4D09-B932-E696099C8774}"/>
               </a:ext>
             </a:extLst>
           </p:cNvPr>
@@ -4868,7 +4868,7 @@
           <p:cNvPr id="3" name="">
             <a:extLst xmlns:a="http://schemas.openxmlformats.org/drawingml/2006/main">
               <a:ext uri="{FF2B5EF4-FFF2-40B4-BE49-F238E27FC236}">
-                <a16:creationId xmlns:a16="http://schemas.microsoft.com/office/drawing/2014/main" id="{831878BF-EC5C-422C-B51C-97755C85EA9E}"/>
+                <a16:creationId xmlns:a16="http://schemas.microsoft.com/office/drawing/2014/main" id="{39CD9BF1-28E6-45F9-98C0-462D2E1042FD}"/>
               </a:ext>
             </a:extLst>
           </p:cNvPr>
@@ -4934,7 +4934,7 @@
           <p:cNvPr id="4" name="">
             <a:extLst xmlns:a="http://schemas.openxmlformats.org/drawingml/2006/main">
               <a:ext uri="{FF2B5EF4-FFF2-40B4-BE49-F238E27FC236}">
-                <a16:creationId xmlns:a16="http://schemas.microsoft.com/office/drawing/2014/main" id="{2B32739C-5197-4269-9F27-48280990150F}"/>
+                <a16:creationId xmlns:a16="http://schemas.microsoft.com/office/drawing/2014/main" id="{EB5FA4AF-E251-48E4-94D5-4C2E265AE995}"/>
               </a:ext>
             </a:extLst>
           </p:cNvPr>
@@ -5000,7 +5000,7 @@
           <p:cNvPr id="5" name="">
             <a:extLst xmlns:a="http://schemas.openxmlformats.org/drawingml/2006/main">
               <a:ext uri="{FF2B5EF4-FFF2-40B4-BE49-F238E27FC236}">
-                <a16:creationId xmlns:a16="http://schemas.microsoft.com/office/drawing/2014/main" id="{9D07EF46-C19F-4537-BB09-19D0A9E1115A}"/>
+                <a16:creationId xmlns:a16="http://schemas.microsoft.com/office/drawing/2014/main" id="{204AE57E-F5B5-407B-AD71-0A1EEDDE5196}"/>
               </a:ext>
             </a:extLst>
           </p:cNvPr>
@@ -5140,7 +5140,7 @@
           <p:cNvPr id="6" name="">
             <a:extLst xmlns:a="http://schemas.openxmlformats.org/drawingml/2006/main">
               <a:ext uri="{FF2B5EF4-FFF2-40B4-BE49-F238E27FC236}">
-                <a16:creationId xmlns:a16="http://schemas.microsoft.com/office/drawing/2014/main" id="{99484195-C616-470C-887C-8E617E81796B}"/>
+                <a16:creationId xmlns:a16="http://schemas.microsoft.com/office/drawing/2014/main" id="{62416C30-FDD4-4CC8-981F-682781C829C0}"/>
               </a:ext>
             </a:extLst>
           </p:cNvPr>
@@ -5280,7 +5280,7 @@
           <p:cNvPr id="7" name="">
             <a:extLst xmlns:a="http://schemas.openxmlformats.org/drawingml/2006/main">
               <a:ext uri="{FF2B5EF4-FFF2-40B4-BE49-F238E27FC236}">
-                <a16:creationId xmlns:a16="http://schemas.microsoft.com/office/drawing/2014/main" id="{EC767183-BCD3-4069-9F66-261B6E9B64B8}"/>
+                <a16:creationId xmlns:a16="http://schemas.microsoft.com/office/drawing/2014/main" id="{4669634D-C64A-40F7-9B1B-29CBB15C0D1E}"/>
               </a:ext>
             </a:extLst>
           </p:cNvPr>
@@ -5346,7 +5346,139 @@
           <p:cNvPr id="8" name="">
             <a:extLst xmlns:a="http://schemas.openxmlformats.org/drawingml/2006/main">
               <a:ext uri="{FF2B5EF4-FFF2-40B4-BE49-F238E27FC236}">
-                <a16:creationId xmlns:a16="http://schemas.microsoft.com/office/drawing/2014/main" id="{EFCC2794-EEBD-43ED-8038-8D838289C4F2}"/>
+                <a16:creationId xmlns:a16="http://schemas.microsoft.com/office/drawing/2014/main" id="{47F03647-2393-41B7-B194-5C6149A0C9A5}"/>
+              </a:ext>
+            </a:extLst>
+          </p:cNvPr>
+          <p:cNvSpPr>
+            <a:spLocks xmlns:a="http://schemas.openxmlformats.org/drawingml/2006/main" noGrp="1"/>
+          </p:cNvSpPr>
+          <p:nvPr/>
+        </p:nvSpPr>
+        <p:spPr>
+          <a:xfrm xmlns:a="http://schemas.openxmlformats.org/drawingml/2006/main">
+            <a:off x="6572250" y="4857750"/>
+            <a:ext cx="5048250" cy="428625"/>
+          </a:xfrm>
+          <a:prstGeom xmlns:a="http://schemas.openxmlformats.org/drawingml/2006/main" prst="rect">
+            <a:avLst/>
+          </a:prstGeom>
+          <a:noFill xmlns:a="http://schemas.openxmlformats.org/drawingml/2006/main"/>
+          <a:ln xmlns:a="http://schemas.openxmlformats.org/drawingml/2006/main" w="0">
+            <a:noFill/>
+          </a:ln>
+        </p:spPr>
+        <p:txBody>
+          <a:bodyPr xmlns:a="http://schemas.openxmlformats.org/drawingml/2006/main"/>
+          <a:lstStyle xmlns:a="http://schemas.openxmlformats.org/drawingml/2006/main">
+            <a:defPPr>
+              <a:defRPr sz="2100" b="0">
+                <a:solidFill>
+                  <a:srgbClr val="08243D"/>
+                </a:solidFill>
+                <a:latin typeface="Arial"/>
+                <a:ea typeface="Arial"/>
+                <a:cs typeface="Arial"/>
+              </a:defRPr>
+            </a:defPPr>
+          </a:lstStyle>
+          <a:p xmlns:a="http://schemas.openxmlformats.org/drawingml/2006/main">
+            <a:pPr>
+              <a:defRPr sz="2100" b="0">
+                <a:solidFill>
+                  <a:srgbClr val="08243D"/>
+                </a:solidFill>
+                <a:latin typeface="Arial"/>
+                <a:ea typeface="Arial"/>
+                <a:cs typeface="Arial"/>
+              </a:defRPr>
+            </a:pPr>
+            <a:r>
+              <a:rPr sz="2100" b="0">
+                <a:solidFill>
+                  <a:srgbClr val="08243D"/>
+                </a:solidFill>
+                <a:latin typeface="Arial"/>
+                <a:ea typeface="Arial"/>
+                <a:cs typeface="Arial"/>
+              </a:rPr>
+              <a:t>Avishkar Arvind Rathod</a:t>
+            </a:r>
+          </a:p>
+        </p:txBody>
+      </p:sp>
+      <p:sp>
+        <p:nvSpPr>
+          <p:cNvPr id="9" name="">
+            <a:extLst xmlns:a="http://schemas.openxmlformats.org/drawingml/2006/main">
+              <a:ext uri="{FF2B5EF4-FFF2-40B4-BE49-F238E27FC236}">
+                <a16:creationId xmlns:a16="http://schemas.microsoft.com/office/drawing/2014/main" id="{26246265-EF9D-4D3E-9A9D-EACAE27D75D2}"/>
+              </a:ext>
+            </a:extLst>
+          </p:cNvPr>
+          <p:cNvSpPr>
+            <a:spLocks xmlns:a="http://schemas.openxmlformats.org/drawingml/2006/main" noGrp="1"/>
+          </p:cNvSpPr>
+          <p:nvPr/>
+        </p:nvSpPr>
+        <p:spPr>
+          <a:xfrm xmlns:a="http://schemas.openxmlformats.org/drawingml/2006/main">
+            <a:off x="6572250" y="5238750"/>
+            <a:ext cx="5048250" cy="428625"/>
+          </a:xfrm>
+          <a:prstGeom xmlns:a="http://schemas.openxmlformats.org/drawingml/2006/main" prst="rect">
+            <a:avLst/>
+          </a:prstGeom>
+          <a:noFill xmlns:a="http://schemas.openxmlformats.org/drawingml/2006/main"/>
+          <a:ln xmlns:a="http://schemas.openxmlformats.org/drawingml/2006/main" w="0">
+            <a:noFill/>
+          </a:ln>
+        </p:spPr>
+        <p:txBody>
+          <a:bodyPr xmlns:a="http://schemas.openxmlformats.org/drawingml/2006/main"/>
+          <a:lstStyle xmlns:a="http://schemas.openxmlformats.org/drawingml/2006/main">
+            <a:defPPr>
+              <a:defRPr sz="2100" b="0">
+                <a:solidFill>
+                  <a:srgbClr val="08243D"/>
+                </a:solidFill>
+                <a:latin typeface="Arial"/>
+                <a:ea typeface="Arial"/>
+                <a:cs typeface="Arial"/>
+              </a:defRPr>
+            </a:defPPr>
+          </a:lstStyle>
+          <a:p xmlns:a="http://schemas.openxmlformats.org/drawingml/2006/main">
+            <a:pPr>
+              <a:defRPr sz="2100" b="0">
+                <a:solidFill>
+                  <a:srgbClr val="08243D"/>
+                </a:solidFill>
+                <a:latin typeface="Arial"/>
+                <a:ea typeface="Arial"/>
+                <a:cs typeface="Arial"/>
+              </a:defRPr>
+            </a:pPr>
+            <a:r>
+              <a:rPr sz="2100" b="0">
+                <a:solidFill>
+                  <a:srgbClr val="08243D"/>
+                </a:solidFill>
+                <a:latin typeface="Arial"/>
+                <a:ea typeface="Arial"/>
+                <a:cs typeface="Arial"/>
+              </a:rPr>
+              <a:t>ayurathod4207-cyber</a:t>
+            </a:r>
+          </a:p>
+        </p:txBody>
+      </p:sp>
+      <p:sp>
+        <p:nvSpPr>
+          <p:cNvPr id="10" name="">
+            <a:extLst xmlns:a="http://schemas.openxmlformats.org/drawingml/2006/main">
+              <a:ext uri="{FF2B5EF4-FFF2-40B4-BE49-F238E27FC236}">
+                <a16:creationId xmlns:a16="http://schemas.microsoft.com/office/drawing/2014/main" id="{945ECFB0-6904-4159-8466-774B7DE69344}"/>
               </a:ext>
             </a:extLst>
           </p:cNvPr>
@@ -5402,7 +5534,7 @@
                 <a:ea typeface="Arial"/>
                 <a:cs typeface="Arial"/>
               </a:rPr>
-              <a:t>One member name and individual contributions await team confirmation.</a:t>
+              <a:t>Individual contributions await team confirmation.</a:t>
             </a:r>
           </a:p>
         </p:txBody>
@@ -5410,7 +5542,7 @@
     </p:spTree>
     <p:extLst>
       <p:ext uri="{BB962C8B-B14F-4D97-AF65-F5344CB8AC3E}">
-        <p14:creationId xmlns:p14="http://schemas.microsoft.com/office/powerpoint/2010/main" val="1462825445"/>
+        <p14:creationId xmlns:p14="http://schemas.microsoft.com/office/powerpoint/2010/main" val="1104278701"/>
       </p:ext>
     </p:extLst>
   </p:cSld>
@@ -5441,7 +5573,7 @@
           <p:cNvPr id="9" name="">
             <a:extLst xmlns:a="http://schemas.openxmlformats.org/drawingml/2006/main">
               <a:ext uri="{FF2B5EF4-FFF2-40B4-BE49-F238E27FC236}">
-                <a16:creationId xmlns:a16="http://schemas.microsoft.com/office/drawing/2014/main" id="{E68CDCAC-9FD4-4642-BBBD-CF2196FD7336}"/>
+                <a16:creationId xmlns:a16="http://schemas.microsoft.com/office/drawing/2014/main" id="{3CFEEC09-C166-4804-869A-4250E08F17BC}"/>
               </a:ext>
             </a:extLst>
           </p:cNvPr>
@@ -5507,7 +5639,7 @@
           <p:cNvPr id="2" name="">
             <a:extLst xmlns:a="http://schemas.openxmlformats.org/drawingml/2006/main">
               <a:ext uri="{FF2B5EF4-FFF2-40B4-BE49-F238E27FC236}">
-                <a16:creationId xmlns:a16="http://schemas.microsoft.com/office/drawing/2014/main" id="{CEB7C5F3-1C9C-44F9-B0A2-0C154E25BF4D}"/>
+                <a16:creationId xmlns:a16="http://schemas.microsoft.com/office/drawing/2014/main" id="{9DB7B901-095E-437E-A417-B25793D3B80D}"/>
               </a:ext>
             </a:extLst>
           </p:cNvPr>
@@ -5573,7 +5705,7 @@
           <p:cNvPr id="3" name="">
             <a:extLst xmlns:a="http://schemas.openxmlformats.org/drawingml/2006/main">
               <a:ext uri="{FF2B5EF4-FFF2-40B4-BE49-F238E27FC236}">
-                <a16:creationId xmlns:a16="http://schemas.microsoft.com/office/drawing/2014/main" id="{92F5AFD7-749A-4CDB-9880-88B11CE23313}"/>
+                <a16:creationId xmlns:a16="http://schemas.microsoft.com/office/drawing/2014/main" id="{46BCA120-A2F2-479C-9ED9-62373316D36E}"/>
               </a:ext>
             </a:extLst>
           </p:cNvPr>
@@ -5639,7 +5771,7 @@
           <p:cNvPr id="4" name="">
             <a:extLst xmlns:a="http://schemas.openxmlformats.org/drawingml/2006/main">
               <a:ext uri="{FF2B5EF4-FFF2-40B4-BE49-F238E27FC236}">
-                <a16:creationId xmlns:a16="http://schemas.microsoft.com/office/drawing/2014/main" id="{9CDC87C5-6968-4F33-A49C-C9FFABCF0108}"/>
+                <a16:creationId xmlns:a16="http://schemas.microsoft.com/office/drawing/2014/main" id="{7BD573DA-2C8B-4251-B433-01FB10EE0E2A}"/>
               </a:ext>
             </a:extLst>
           </p:cNvPr>
@@ -5705,7 +5837,7 @@
           <p:cNvPr id="5" name="">
             <a:extLst xmlns:a="http://schemas.openxmlformats.org/drawingml/2006/main">
               <a:ext uri="{FF2B5EF4-FFF2-40B4-BE49-F238E27FC236}">
-                <a16:creationId xmlns:a16="http://schemas.microsoft.com/office/drawing/2014/main" id="{3C7FF0C9-F120-4C65-ADE3-1CD03DD8E863}"/>
+                <a16:creationId xmlns:a16="http://schemas.microsoft.com/office/drawing/2014/main" id="{B1DDF467-F695-4367-9A4E-68352B963721}"/>
               </a:ext>
             </a:extLst>
           </p:cNvPr>
@@ -5771,7 +5903,7 @@
           <p:cNvPr id="6" name="">
             <a:extLst xmlns:a="http://schemas.openxmlformats.org/drawingml/2006/main">
               <a:ext uri="{FF2B5EF4-FFF2-40B4-BE49-F238E27FC236}">
-                <a16:creationId xmlns:a16="http://schemas.microsoft.com/office/drawing/2014/main" id="{B6DFA24E-C9BC-4FF4-98E3-107E90262595}"/>
+                <a16:creationId xmlns:a16="http://schemas.microsoft.com/office/drawing/2014/main" id="{6298371D-3972-47CF-89D4-76562C4D79A6}"/>
               </a:ext>
             </a:extLst>
           </p:cNvPr>
@@ -5837,7 +5969,7 @@
           <p:cNvPr id="7" name="">
             <a:extLst xmlns:a="http://schemas.openxmlformats.org/drawingml/2006/main">
               <a:ext uri="{FF2B5EF4-FFF2-40B4-BE49-F238E27FC236}">
-                <a16:creationId xmlns:a16="http://schemas.microsoft.com/office/drawing/2014/main" id="{DF2C5EC1-982E-42C4-8734-919D295B7079}"/>
+                <a16:creationId xmlns:a16="http://schemas.microsoft.com/office/drawing/2014/main" id="{FF1432DF-B71E-4E2F-A55E-8BD4DB97095B}"/>
               </a:ext>
             </a:extLst>
           </p:cNvPr>
@@ -5903,7 +6035,7 @@
           <p:cNvPr id="8" name="">
             <a:extLst xmlns:a="http://schemas.openxmlformats.org/drawingml/2006/main">
               <a:ext uri="{FF2B5EF4-FFF2-40B4-BE49-F238E27FC236}">
-                <a16:creationId xmlns:a16="http://schemas.microsoft.com/office/drawing/2014/main" id="{532CBA0B-44FE-4075-B32A-C0C50AB890FE}"/>
+                <a16:creationId xmlns:a16="http://schemas.microsoft.com/office/drawing/2014/main" id="{DE085F46-49B1-421C-B6A0-D3A4CE0317F9}"/>
               </a:ext>
             </a:extLst>
           </p:cNvPr>
@@ -5990,7 +6122,7 @@
     </p:spTree>
     <p:extLst>
       <p:ext uri="{BB962C8B-B14F-4D97-AF65-F5344CB8AC3E}">
-        <p14:creationId xmlns:p14="http://schemas.microsoft.com/office/powerpoint/2010/main" val="301960406"/>
+        <p14:creationId xmlns:p14="http://schemas.microsoft.com/office/powerpoint/2010/main" val="356244070"/>
       </p:ext>
     </p:extLst>
   </p:cSld>
@@ -6021,7 +6153,7 @@
           <p:cNvPr id="16" name="">
             <a:extLst xmlns:a="http://schemas.openxmlformats.org/drawingml/2006/main">
               <a:ext uri="{FF2B5EF4-FFF2-40B4-BE49-F238E27FC236}">
-                <a16:creationId xmlns:a16="http://schemas.microsoft.com/office/drawing/2014/main" id="{DCE33F0C-096B-4395-AA98-A108CA368BD7}"/>
+                <a16:creationId xmlns:a16="http://schemas.microsoft.com/office/drawing/2014/main" id="{0CFD0FF2-2EC2-40FE-B0F8-16CFEE34EDC7}"/>
               </a:ext>
             </a:extLst>
           </p:cNvPr>
@@ -6087,7 +6219,7 @@
           <p:cNvPr id="2" name="">
             <a:extLst xmlns:a="http://schemas.openxmlformats.org/drawingml/2006/main">
               <a:ext uri="{FF2B5EF4-FFF2-40B4-BE49-F238E27FC236}">
-                <a16:creationId xmlns:a16="http://schemas.microsoft.com/office/drawing/2014/main" id="{EBF65B97-767F-4895-9280-4E9730EEBC07}"/>
+                <a16:creationId xmlns:a16="http://schemas.microsoft.com/office/drawing/2014/main" id="{783D7DD3-62D1-450F-97FE-857C2963548C}"/>
               </a:ext>
             </a:extLst>
           </p:cNvPr>
@@ -6153,7 +6285,7 @@
           <p:cNvPr id="3" name="">
             <a:extLst xmlns:a="http://schemas.openxmlformats.org/drawingml/2006/main">
               <a:ext uri="{FF2B5EF4-FFF2-40B4-BE49-F238E27FC236}">
-                <a16:creationId xmlns:a16="http://schemas.microsoft.com/office/drawing/2014/main" id="{A0EBE9FF-A49B-452A-A594-50E1A9B76F01}"/>
+                <a16:creationId xmlns:a16="http://schemas.microsoft.com/office/drawing/2014/main" id="{A25E3170-D36F-465A-94F0-75F405B87E83}"/>
               </a:ext>
             </a:extLst>
           </p:cNvPr>
@@ -6219,7 +6351,7 @@
           <p:cNvPr id="4" name="">
             <a:extLst xmlns:a="http://schemas.openxmlformats.org/drawingml/2006/main">
               <a:ext uri="{FF2B5EF4-FFF2-40B4-BE49-F238E27FC236}">
-                <a16:creationId xmlns:a16="http://schemas.microsoft.com/office/drawing/2014/main" id="{020DEF10-E08C-4BB8-BDD8-93096A841D7C}"/>
+                <a16:creationId xmlns:a16="http://schemas.microsoft.com/office/drawing/2014/main" id="{058DB116-F1CA-4CD3-97A2-3B31BA8818EE}"/>
               </a:ext>
             </a:extLst>
           </p:cNvPr>
@@ -6285,7 +6417,7 @@
           <p:cNvPr id="5" name="">
             <a:extLst xmlns:a="http://schemas.openxmlformats.org/drawingml/2006/main">
               <a:ext uri="{FF2B5EF4-FFF2-40B4-BE49-F238E27FC236}">
-                <a16:creationId xmlns:a16="http://schemas.microsoft.com/office/drawing/2014/main" id="{45A6961A-6824-44D1-A668-323B72368981}"/>
+                <a16:creationId xmlns:a16="http://schemas.microsoft.com/office/drawing/2014/main" id="{A1FC6B1A-7252-4483-BE51-A8066744334B}"/>
               </a:ext>
             </a:extLst>
           </p:cNvPr>
@@ -6351,7 +6483,7 @@
           <p:cNvPr id="6" name="">
             <a:extLst xmlns:a="http://schemas.openxmlformats.org/drawingml/2006/main">
               <a:ext uri="{FF2B5EF4-FFF2-40B4-BE49-F238E27FC236}">
-                <a16:creationId xmlns:a16="http://schemas.microsoft.com/office/drawing/2014/main" id="{A4442589-5D2C-4AEB-9CE4-4176345CEDA5}"/>
+                <a16:creationId xmlns:a16="http://schemas.microsoft.com/office/drawing/2014/main" id="{0CCC7D6A-E666-4C2D-B627-77773923F5B4}"/>
               </a:ext>
             </a:extLst>
           </p:cNvPr>
@@ -6417,7 +6549,7 @@
           <p:cNvPr id="7" name="">
             <a:extLst xmlns:a="http://schemas.openxmlformats.org/drawingml/2006/main">
               <a:ext uri="{FF2B5EF4-FFF2-40B4-BE49-F238E27FC236}">
-                <a16:creationId xmlns:a16="http://schemas.microsoft.com/office/drawing/2014/main" id="{29905BD3-B4B3-4564-9A82-3939019F071D}"/>
+                <a16:creationId xmlns:a16="http://schemas.microsoft.com/office/drawing/2014/main" id="{A614B3A3-53C2-4220-99E8-8C01EEC9D133}"/>
               </a:ext>
             </a:extLst>
           </p:cNvPr>
@@ -6483,7 +6615,7 @@
           <p:cNvPr id="8" name="">
             <a:extLst xmlns:a="http://schemas.openxmlformats.org/drawingml/2006/main">
               <a:ext uri="{FF2B5EF4-FFF2-40B4-BE49-F238E27FC236}">
-                <a16:creationId xmlns:a16="http://schemas.microsoft.com/office/drawing/2014/main" id="{3BC2DBDD-3788-4030-BD92-F6F4AC542937}"/>
+                <a16:creationId xmlns:a16="http://schemas.microsoft.com/office/drawing/2014/main" id="{D27B292E-52EC-464D-9A32-BB61E627857A}"/>
               </a:ext>
             </a:extLst>
           </p:cNvPr>
@@ -6549,7 +6681,7 @@
           <p:cNvPr id="9" name="">
             <a:extLst xmlns:a="http://schemas.openxmlformats.org/drawingml/2006/main">
               <a:ext uri="{FF2B5EF4-FFF2-40B4-BE49-F238E27FC236}">
-                <a16:creationId xmlns:a16="http://schemas.microsoft.com/office/drawing/2014/main" id="{1357CA02-856D-4E55-B2E8-D43C4BB154BB}"/>
+                <a16:creationId xmlns:a16="http://schemas.microsoft.com/office/drawing/2014/main" id="{16C9751E-6AF3-4007-A771-50077F2A17A2}"/>
               </a:ext>
             </a:extLst>
           </p:cNvPr>
@@ -6615,7 +6747,7 @@
           <p:cNvPr id="10" name="">
             <a:extLst xmlns:a="http://schemas.openxmlformats.org/drawingml/2006/main">
               <a:ext uri="{FF2B5EF4-FFF2-40B4-BE49-F238E27FC236}">
-                <a16:creationId xmlns:a16="http://schemas.microsoft.com/office/drawing/2014/main" id="{564F669A-DFC5-4BC1-BF76-7289041DC985}"/>
+                <a16:creationId xmlns:a16="http://schemas.microsoft.com/office/drawing/2014/main" id="{68A44183-88A9-4CCA-B9A4-24EC3E47013D}"/>
               </a:ext>
             </a:extLst>
           </p:cNvPr>
@@ -6681,7 +6813,7 @@
           <p:cNvPr id="11" name="">
             <a:extLst xmlns:a="http://schemas.openxmlformats.org/drawingml/2006/main">
               <a:ext uri="{FF2B5EF4-FFF2-40B4-BE49-F238E27FC236}">
-                <a16:creationId xmlns:a16="http://schemas.microsoft.com/office/drawing/2014/main" id="{96FA9ACE-8574-43A5-B270-66799593E2D8}"/>
+                <a16:creationId xmlns:a16="http://schemas.microsoft.com/office/drawing/2014/main" id="{4006DB7C-F787-4528-868E-920BF693990E}"/>
               </a:ext>
             </a:extLst>
           </p:cNvPr>
@@ -6747,7 +6879,7 @@
           <p:cNvPr id="12" name="">
             <a:extLst xmlns:a="http://schemas.openxmlformats.org/drawingml/2006/main">
               <a:ext uri="{FF2B5EF4-FFF2-40B4-BE49-F238E27FC236}">
-                <a16:creationId xmlns:a16="http://schemas.microsoft.com/office/drawing/2014/main" id="{7EA0FF7C-385D-4F7A-9709-47A0080E39C9}"/>
+                <a16:creationId xmlns:a16="http://schemas.microsoft.com/office/drawing/2014/main" id="{2EE21937-FAEC-4B2B-91B6-EBF1630A4E5F}"/>
               </a:ext>
             </a:extLst>
           </p:cNvPr>
@@ -6813,7 +6945,7 @@
           <p:cNvPr id="13" name="">
             <a:extLst xmlns:a="http://schemas.openxmlformats.org/drawingml/2006/main">
               <a:ext uri="{FF2B5EF4-FFF2-40B4-BE49-F238E27FC236}">
-                <a16:creationId xmlns:a16="http://schemas.microsoft.com/office/drawing/2014/main" id="{45C80B96-EFC2-45E5-8B7E-FE8ADB76A432}"/>
+                <a16:creationId xmlns:a16="http://schemas.microsoft.com/office/drawing/2014/main" id="{284D15CD-87FB-4A13-B5BE-683C7A25FBFB}"/>
               </a:ext>
             </a:extLst>
           </p:cNvPr>
@@ -6879,7 +7011,7 @@
           <p:cNvPr id="14" name="">
             <a:extLst xmlns:a="http://schemas.openxmlformats.org/drawingml/2006/main">
               <a:ext uri="{FF2B5EF4-FFF2-40B4-BE49-F238E27FC236}">
-                <a16:creationId xmlns:a16="http://schemas.microsoft.com/office/drawing/2014/main" id="{DD89D07A-D8B0-43ED-AB2C-0AEDEB60C6CB}"/>
+                <a16:creationId xmlns:a16="http://schemas.microsoft.com/office/drawing/2014/main" id="{05337A78-D683-480D-BAFA-F9318FA163B9}"/>
               </a:ext>
             </a:extLst>
           </p:cNvPr>
@@ -6945,7 +7077,7 @@
           <p:cNvPr id="15" name="">
             <a:extLst xmlns:a="http://schemas.openxmlformats.org/drawingml/2006/main">
               <a:ext uri="{FF2B5EF4-FFF2-40B4-BE49-F238E27FC236}">
-                <a16:creationId xmlns:a16="http://schemas.microsoft.com/office/drawing/2014/main" id="{A6102BF5-64D5-4EB5-A957-23266AEA3F68}"/>
+                <a16:creationId xmlns:a16="http://schemas.microsoft.com/office/drawing/2014/main" id="{6FDA0FA7-3AF9-4A86-8AB1-315B6D2B343F}"/>
               </a:ext>
             </a:extLst>
           </p:cNvPr>
@@ -7009,7 +7141,7 @@
     </p:spTree>
     <p:extLst>
       <p:ext uri="{BB962C8B-B14F-4D97-AF65-F5344CB8AC3E}">
-        <p14:creationId xmlns:p14="http://schemas.microsoft.com/office/powerpoint/2010/main" val="1019107914"/>
+        <p14:creationId xmlns:p14="http://schemas.microsoft.com/office/powerpoint/2010/main" val="1732208861"/>
       </p:ext>
     </p:extLst>
   </p:cSld>
@@ -7040,7 +7172,7 @@
           <p:cNvPr id="16" name="">
             <a:extLst xmlns:a="http://schemas.openxmlformats.org/drawingml/2006/main">
               <a:ext uri="{FF2B5EF4-FFF2-40B4-BE49-F238E27FC236}">
-                <a16:creationId xmlns:a16="http://schemas.microsoft.com/office/drawing/2014/main" id="{A215FA67-AA4F-4B1C-A6E5-29F09F46BC2A}"/>
+                <a16:creationId xmlns:a16="http://schemas.microsoft.com/office/drawing/2014/main" id="{5723EEEF-0A59-4F17-A33F-C0EA1C503266}"/>
               </a:ext>
             </a:extLst>
           </p:cNvPr>
@@ -7106,7 +7238,7 @@
           <p:cNvPr id="2" name="">
             <a:extLst xmlns:a="http://schemas.openxmlformats.org/drawingml/2006/main">
               <a:ext uri="{FF2B5EF4-FFF2-40B4-BE49-F238E27FC236}">
-                <a16:creationId xmlns:a16="http://schemas.microsoft.com/office/drawing/2014/main" id="{FDC92050-1B3D-44B8-9AA1-A0358815A4BF}"/>
+                <a16:creationId xmlns:a16="http://schemas.microsoft.com/office/drawing/2014/main" id="{0B137BDE-9800-4331-B90F-D591A7F3CD6D}"/>
               </a:ext>
             </a:extLst>
           </p:cNvPr>
@@ -7172,7 +7304,7 @@
           <p:cNvPr id="3" name="">
             <a:extLst xmlns:a="http://schemas.openxmlformats.org/drawingml/2006/main">
               <a:ext uri="{FF2B5EF4-FFF2-40B4-BE49-F238E27FC236}">
-                <a16:creationId xmlns:a16="http://schemas.microsoft.com/office/drawing/2014/main" id="{2A9CF531-7A99-4CCF-B0E0-68F948752569}"/>
+                <a16:creationId xmlns:a16="http://schemas.microsoft.com/office/drawing/2014/main" id="{37902867-B10E-4B84-B93B-74882293CEB5}"/>
               </a:ext>
             </a:extLst>
           </p:cNvPr>
@@ -7238,7 +7370,7 @@
           <p:cNvPr id="4" name="">
             <a:extLst xmlns:a="http://schemas.openxmlformats.org/drawingml/2006/main">
               <a:ext uri="{FF2B5EF4-FFF2-40B4-BE49-F238E27FC236}">
-                <a16:creationId xmlns:a16="http://schemas.microsoft.com/office/drawing/2014/main" id="{2978BB77-596B-4ECB-B956-EE899686D603}"/>
+                <a16:creationId xmlns:a16="http://schemas.microsoft.com/office/drawing/2014/main" id="{A1C59869-58E5-417B-8F6C-9152F06BB921}"/>
               </a:ext>
             </a:extLst>
           </p:cNvPr>
@@ -7304,7 +7436,7 @@
           <p:cNvPr id="5" name="">
             <a:extLst xmlns:a="http://schemas.openxmlformats.org/drawingml/2006/main">
               <a:ext uri="{FF2B5EF4-FFF2-40B4-BE49-F238E27FC236}">
-                <a16:creationId xmlns:a16="http://schemas.microsoft.com/office/drawing/2014/main" id="{06A5289E-E1F0-4757-9AE4-34964E815E42}"/>
+                <a16:creationId xmlns:a16="http://schemas.microsoft.com/office/drawing/2014/main" id="{5AE32872-F2E7-4F0B-B240-44A4DBCD1AAF}"/>
               </a:ext>
             </a:extLst>
           </p:cNvPr>
@@ -7370,7 +7502,7 @@
           <p:cNvPr id="6" name="">
             <a:extLst xmlns:a="http://schemas.openxmlformats.org/drawingml/2006/main">
               <a:ext uri="{FF2B5EF4-FFF2-40B4-BE49-F238E27FC236}">
-                <a16:creationId xmlns:a16="http://schemas.microsoft.com/office/drawing/2014/main" id="{D1E2C79C-DA07-457B-BA46-A642A86149BA}"/>
+                <a16:creationId xmlns:a16="http://schemas.microsoft.com/office/drawing/2014/main" id="{5F8B7406-194A-4395-9809-4564F8D5511A}"/>
               </a:ext>
             </a:extLst>
           </p:cNvPr>
@@ -7436,7 +7568,7 @@
           <p:cNvPr id="7" name="">
             <a:extLst xmlns:a="http://schemas.openxmlformats.org/drawingml/2006/main">
               <a:ext uri="{FF2B5EF4-FFF2-40B4-BE49-F238E27FC236}">
-                <a16:creationId xmlns:a16="http://schemas.microsoft.com/office/drawing/2014/main" id="{0E45C6C0-BC3A-4CC5-BC05-D21F6F3D7713}"/>
+                <a16:creationId xmlns:a16="http://schemas.microsoft.com/office/drawing/2014/main" id="{6D6D4578-6E6A-4545-904A-643925FAA80B}"/>
               </a:ext>
             </a:extLst>
           </p:cNvPr>
@@ -7502,7 +7634,7 @@
           <p:cNvPr id="8" name="">
             <a:extLst xmlns:a="http://schemas.openxmlformats.org/drawingml/2006/main">
               <a:ext uri="{FF2B5EF4-FFF2-40B4-BE49-F238E27FC236}">
-                <a16:creationId xmlns:a16="http://schemas.microsoft.com/office/drawing/2014/main" id="{45639437-4AE9-4512-A3E7-69C0D402808E}"/>
+                <a16:creationId xmlns:a16="http://schemas.microsoft.com/office/drawing/2014/main" id="{AA47044D-3FFE-4F8F-8030-93C3EC3B8341}"/>
               </a:ext>
             </a:extLst>
           </p:cNvPr>
@@ -7568,7 +7700,7 @@
           <p:cNvPr id="9" name="">
             <a:extLst xmlns:a="http://schemas.openxmlformats.org/drawingml/2006/main">
               <a:ext uri="{FF2B5EF4-FFF2-40B4-BE49-F238E27FC236}">
-                <a16:creationId xmlns:a16="http://schemas.microsoft.com/office/drawing/2014/main" id="{BD96ABAD-19E3-4A5C-A337-7B8AFF587914}"/>
+                <a16:creationId xmlns:a16="http://schemas.microsoft.com/office/drawing/2014/main" id="{E6EB4ADE-FFF6-4397-A0DC-CB632590C447}"/>
               </a:ext>
             </a:extLst>
           </p:cNvPr>
@@ -7634,7 +7766,7 @@
           <p:cNvPr id="10" name="">
             <a:extLst xmlns:a="http://schemas.openxmlformats.org/drawingml/2006/main">
               <a:ext uri="{FF2B5EF4-FFF2-40B4-BE49-F238E27FC236}">
-                <a16:creationId xmlns:a16="http://schemas.microsoft.com/office/drawing/2014/main" id="{E1B46EDA-3023-4B60-A204-8177E13285A3}"/>
+                <a16:creationId xmlns:a16="http://schemas.microsoft.com/office/drawing/2014/main" id="{2B77AA6E-DEFD-40D1-9E36-E6B2D0F07B89}"/>
               </a:ext>
             </a:extLst>
           </p:cNvPr>
@@ -7700,7 +7832,7 @@
           <p:cNvPr id="11" name="">
             <a:extLst xmlns:a="http://schemas.openxmlformats.org/drawingml/2006/main">
               <a:ext uri="{FF2B5EF4-FFF2-40B4-BE49-F238E27FC236}">
-                <a16:creationId xmlns:a16="http://schemas.microsoft.com/office/drawing/2014/main" id="{1D379B88-99CD-4CA7-A475-6B5ECF1BA97B}"/>
+                <a16:creationId xmlns:a16="http://schemas.microsoft.com/office/drawing/2014/main" id="{29588495-64B7-46AB-AA37-580CDCE6B62E}"/>
               </a:ext>
             </a:extLst>
           </p:cNvPr>
@@ -7766,7 +7898,7 @@
           <p:cNvPr id="12" name="">
             <a:extLst xmlns:a="http://schemas.openxmlformats.org/drawingml/2006/main">
               <a:ext uri="{FF2B5EF4-FFF2-40B4-BE49-F238E27FC236}">
-                <a16:creationId xmlns:a16="http://schemas.microsoft.com/office/drawing/2014/main" id="{1A2D52E6-3330-46BC-BA7D-849ECF7F5F7C}"/>
+                <a16:creationId xmlns:a16="http://schemas.microsoft.com/office/drawing/2014/main" id="{3E3C00B4-914C-471E-8F4F-056ABACA04C8}"/>
               </a:ext>
             </a:extLst>
           </p:cNvPr>
@@ -7832,7 +7964,7 @@
           <p:cNvPr id="13" name="">
             <a:extLst xmlns:a="http://schemas.openxmlformats.org/drawingml/2006/main">
               <a:ext uri="{FF2B5EF4-FFF2-40B4-BE49-F238E27FC236}">
-                <a16:creationId xmlns:a16="http://schemas.microsoft.com/office/drawing/2014/main" id="{866D9004-61EF-4327-A0A6-7A05750A7DF4}"/>
+                <a16:creationId xmlns:a16="http://schemas.microsoft.com/office/drawing/2014/main" id="{4C443CAD-5D66-4189-8FFE-ADEA5C0AF789}"/>
               </a:ext>
             </a:extLst>
           </p:cNvPr>
@@ -7898,7 +8030,7 @@
           <p:cNvPr id="14" name="">
             <a:extLst xmlns:a="http://schemas.openxmlformats.org/drawingml/2006/main">
               <a:ext uri="{FF2B5EF4-FFF2-40B4-BE49-F238E27FC236}">
-                <a16:creationId xmlns:a16="http://schemas.microsoft.com/office/drawing/2014/main" id="{3E5150A9-5506-48C1-92BC-9AA1A3BAE455}"/>
+                <a16:creationId xmlns:a16="http://schemas.microsoft.com/office/drawing/2014/main" id="{37CA757E-24E7-4D44-80B6-D4B0110371F5}"/>
               </a:ext>
             </a:extLst>
           </p:cNvPr>
@@ -7964,7 +8096,7 @@
           <p:cNvPr id="15" name="">
             <a:extLst xmlns:a="http://schemas.openxmlformats.org/drawingml/2006/main">
               <a:ext uri="{FF2B5EF4-FFF2-40B4-BE49-F238E27FC236}">
-                <a16:creationId xmlns:a16="http://schemas.microsoft.com/office/drawing/2014/main" id="{E5BCC1E5-B520-41E7-868D-AE9A8FD34667}"/>
+                <a16:creationId xmlns:a16="http://schemas.microsoft.com/office/drawing/2014/main" id="{3A722D76-7E81-4FEA-9F81-6D87EA03F44F}"/>
               </a:ext>
             </a:extLst>
           </p:cNvPr>
@@ -8028,7 +8160,7 @@
     </p:spTree>
     <p:extLst>
       <p:ext uri="{BB962C8B-B14F-4D97-AF65-F5344CB8AC3E}">
-        <p14:creationId xmlns:p14="http://schemas.microsoft.com/office/powerpoint/2010/main" val="1068175984"/>
+        <p14:creationId xmlns:p14="http://schemas.microsoft.com/office/powerpoint/2010/main" val="1741153093"/>
       </p:ext>
     </p:extLst>
   </p:cSld>
@@ -8059,7 +8191,7 @@
           <p:cNvPr id="17" name="">
             <a:extLst xmlns:a="http://schemas.openxmlformats.org/drawingml/2006/main">
               <a:ext uri="{FF2B5EF4-FFF2-40B4-BE49-F238E27FC236}">
-                <a16:creationId xmlns:a16="http://schemas.microsoft.com/office/drawing/2014/main" id="{D97D6520-C461-49CE-8905-04897C66081C}"/>
+                <a16:creationId xmlns:a16="http://schemas.microsoft.com/office/drawing/2014/main" id="{44432E57-B46C-4C2D-A3D7-EEB401E48907}"/>
               </a:ext>
             </a:extLst>
           </p:cNvPr>
@@ -8125,7 +8257,7 @@
           <p:cNvPr id="2" name="">
             <a:extLst xmlns:a="http://schemas.openxmlformats.org/drawingml/2006/main">
               <a:ext uri="{FF2B5EF4-FFF2-40B4-BE49-F238E27FC236}">
-                <a16:creationId xmlns:a16="http://schemas.microsoft.com/office/drawing/2014/main" id="{2E426DBE-769E-41B1-AF87-21AF60DBDC73}"/>
+                <a16:creationId xmlns:a16="http://schemas.microsoft.com/office/drawing/2014/main" id="{AB5C3B63-E6BE-474B-A26B-7EDFDAE8C5C3}"/>
               </a:ext>
             </a:extLst>
           </p:cNvPr>
@@ -8191,7 +8323,7 @@
           <p:cNvPr id="3" name="">
             <a:extLst xmlns:a="http://schemas.openxmlformats.org/drawingml/2006/main">
               <a:ext uri="{FF2B5EF4-FFF2-40B4-BE49-F238E27FC236}">
-                <a16:creationId xmlns:a16="http://schemas.microsoft.com/office/drawing/2014/main" id="{2BAB6A5B-945F-4FF9-99B6-0109C0F9225E}"/>
+                <a16:creationId xmlns:a16="http://schemas.microsoft.com/office/drawing/2014/main" id="{CD007654-916B-4704-83ED-19AD81727536}"/>
               </a:ext>
             </a:extLst>
           </p:cNvPr>
@@ -8257,7 +8389,7 @@
           <p:cNvPr id="4" name="">
             <a:extLst xmlns:a="http://schemas.openxmlformats.org/drawingml/2006/main">
               <a:ext uri="{FF2B5EF4-FFF2-40B4-BE49-F238E27FC236}">
-                <a16:creationId xmlns:a16="http://schemas.microsoft.com/office/drawing/2014/main" id="{EB475504-F4F1-4AD6-B320-3669CD5D8F2D}"/>
+                <a16:creationId xmlns:a16="http://schemas.microsoft.com/office/drawing/2014/main" id="{0BE503F0-3D26-4D7D-BAC4-7F580581367D}"/>
               </a:ext>
             </a:extLst>
           </p:cNvPr>
@@ -8323,7 +8455,7 @@
           <p:cNvPr id="5" name="">
             <a:extLst xmlns:a="http://schemas.openxmlformats.org/drawingml/2006/main">
               <a:ext uri="{FF2B5EF4-FFF2-40B4-BE49-F238E27FC236}">
-                <a16:creationId xmlns:a16="http://schemas.microsoft.com/office/drawing/2014/main" id="{682B3785-1C00-43D4-A119-2F613050B018}"/>
+                <a16:creationId xmlns:a16="http://schemas.microsoft.com/office/drawing/2014/main" id="{294412F5-04E1-444D-AA1C-701CC7D39F6E}"/>
               </a:ext>
             </a:extLst>
           </p:cNvPr>
@@ -8389,7 +8521,7 @@
           <p:cNvPr id="6" name="">
             <a:extLst xmlns:a="http://schemas.openxmlformats.org/drawingml/2006/main">
               <a:ext uri="{FF2B5EF4-FFF2-40B4-BE49-F238E27FC236}">
-                <a16:creationId xmlns:a16="http://schemas.microsoft.com/office/drawing/2014/main" id="{22A51C46-05AD-4A94-A52F-692760B54FF4}"/>
+                <a16:creationId xmlns:a16="http://schemas.microsoft.com/office/drawing/2014/main" id="{0E5B0333-2EB6-4667-9AFD-270207512A17}"/>
               </a:ext>
             </a:extLst>
           </p:cNvPr>
@@ -8455,7 +8587,7 @@
           <p:cNvPr id="7" name="">
             <a:extLst xmlns:a="http://schemas.openxmlformats.org/drawingml/2006/main">
               <a:ext uri="{FF2B5EF4-FFF2-40B4-BE49-F238E27FC236}">
-                <a16:creationId xmlns:a16="http://schemas.microsoft.com/office/drawing/2014/main" id="{1DD23D13-A5A0-4EFF-B180-91FAD17EEDE6}"/>
+                <a16:creationId xmlns:a16="http://schemas.microsoft.com/office/drawing/2014/main" id="{79440BC8-33E3-45AE-B882-8D5D92518259}"/>
               </a:ext>
             </a:extLst>
           </p:cNvPr>
@@ -8521,7 +8653,7 @@
           <p:cNvPr id="8" name="">
             <a:extLst xmlns:a="http://schemas.openxmlformats.org/drawingml/2006/main">
               <a:ext uri="{FF2B5EF4-FFF2-40B4-BE49-F238E27FC236}">
-                <a16:creationId xmlns:a16="http://schemas.microsoft.com/office/drawing/2014/main" id="{0D171F3C-9CDB-424A-93FB-69E093F6D3AD}"/>
+                <a16:creationId xmlns:a16="http://schemas.microsoft.com/office/drawing/2014/main" id="{FAFE1CF8-1701-487B-AA68-A10EE43A59C7}"/>
               </a:ext>
             </a:extLst>
           </p:cNvPr>
@@ -8587,7 +8719,7 @@
           <p:cNvPr id="9" name="">
             <a:extLst xmlns:a="http://schemas.openxmlformats.org/drawingml/2006/main">
               <a:ext uri="{FF2B5EF4-FFF2-40B4-BE49-F238E27FC236}">
-                <a16:creationId xmlns:a16="http://schemas.microsoft.com/office/drawing/2014/main" id="{D9094BEB-6035-4749-9DD4-85265351B188}"/>
+                <a16:creationId xmlns:a16="http://schemas.microsoft.com/office/drawing/2014/main" id="{9960BE30-EC11-4C2D-BE33-528B5B4DCD44}"/>
               </a:ext>
             </a:extLst>
           </p:cNvPr>
@@ -8653,7 +8785,7 @@
           <p:cNvPr id="10" name="">
             <a:extLst xmlns:a="http://schemas.openxmlformats.org/drawingml/2006/main">
               <a:ext uri="{FF2B5EF4-FFF2-40B4-BE49-F238E27FC236}">
-                <a16:creationId xmlns:a16="http://schemas.microsoft.com/office/drawing/2014/main" id="{EA2BF4EA-F07E-49B2-BD02-10A54C927314}"/>
+                <a16:creationId xmlns:a16="http://schemas.microsoft.com/office/drawing/2014/main" id="{9B11607C-68C0-4D68-8435-9DBAB4FA680D}"/>
               </a:ext>
             </a:extLst>
           </p:cNvPr>
@@ -8719,7 +8851,7 @@
           <p:cNvPr id="11" name="">
             <a:extLst xmlns:a="http://schemas.openxmlformats.org/drawingml/2006/main">
               <a:ext uri="{FF2B5EF4-FFF2-40B4-BE49-F238E27FC236}">
-                <a16:creationId xmlns:a16="http://schemas.microsoft.com/office/drawing/2014/main" id="{381154A0-2102-499D-B60C-652C66DCF76C}"/>
+                <a16:creationId xmlns:a16="http://schemas.microsoft.com/office/drawing/2014/main" id="{12E3467F-76B9-4854-AE3E-52F92928DD43}"/>
               </a:ext>
             </a:extLst>
           </p:cNvPr>
@@ -8785,7 +8917,7 @@
           <p:cNvPr id="12" name="">
             <a:extLst xmlns:a="http://schemas.openxmlformats.org/drawingml/2006/main">
               <a:ext uri="{FF2B5EF4-FFF2-40B4-BE49-F238E27FC236}">
-                <a16:creationId xmlns:a16="http://schemas.microsoft.com/office/drawing/2014/main" id="{BA3FC74C-7185-499B-85B3-04AA5BB8E2B2}"/>
+                <a16:creationId xmlns:a16="http://schemas.microsoft.com/office/drawing/2014/main" id="{CA788A42-2627-4699-AFEB-DE0152CDC9C8}"/>
               </a:ext>
             </a:extLst>
           </p:cNvPr>
@@ -8851,7 +8983,7 @@
           <p:cNvPr id="13" name="">
             <a:extLst xmlns:a="http://schemas.openxmlformats.org/drawingml/2006/main">
               <a:ext uri="{FF2B5EF4-FFF2-40B4-BE49-F238E27FC236}">
-                <a16:creationId xmlns:a16="http://schemas.microsoft.com/office/drawing/2014/main" id="{9E33017E-AAF2-4C66-B442-49B3B068EB2F}"/>
+                <a16:creationId xmlns:a16="http://schemas.microsoft.com/office/drawing/2014/main" id="{648ECC5E-F377-42A4-818E-4119F4DFC3AA}"/>
               </a:ext>
             </a:extLst>
           </p:cNvPr>
@@ -8917,7 +9049,7 @@
           <p:cNvPr id="14" name="">
             <a:extLst xmlns:a="http://schemas.openxmlformats.org/drawingml/2006/main">
               <a:ext uri="{FF2B5EF4-FFF2-40B4-BE49-F238E27FC236}">
-                <a16:creationId xmlns:a16="http://schemas.microsoft.com/office/drawing/2014/main" id="{1BA0C980-B302-4295-8A89-2DCC6A610252}"/>
+                <a16:creationId xmlns:a16="http://schemas.microsoft.com/office/drawing/2014/main" id="{231ADC5A-E044-4B2E-8DFC-B7E094808688}"/>
               </a:ext>
             </a:extLst>
           </p:cNvPr>
@@ -8983,7 +9115,7 @@
           <p:cNvPr id="15" name="">
             <a:extLst xmlns:a="http://schemas.openxmlformats.org/drawingml/2006/main">
               <a:ext uri="{FF2B5EF4-FFF2-40B4-BE49-F238E27FC236}">
-                <a16:creationId xmlns:a16="http://schemas.microsoft.com/office/drawing/2014/main" id="{E921B130-FD4E-44D1-9F00-ED82035DB3CD}"/>
+                <a16:creationId xmlns:a16="http://schemas.microsoft.com/office/drawing/2014/main" id="{7EFAD40D-F0C5-48C4-BA8B-FB19E0F0B5F3}"/>
               </a:ext>
             </a:extLst>
           </p:cNvPr>
@@ -9049,7 +9181,7 @@
           <p:cNvPr id="16" name="">
             <a:extLst xmlns:a="http://schemas.openxmlformats.org/drawingml/2006/main">
               <a:ext uri="{FF2B5EF4-FFF2-40B4-BE49-F238E27FC236}">
-                <a16:creationId xmlns:a16="http://schemas.microsoft.com/office/drawing/2014/main" id="{22F65534-4A88-4031-934D-420A493062F5}"/>
+                <a16:creationId xmlns:a16="http://schemas.microsoft.com/office/drawing/2014/main" id="{9730292E-3FB7-4B11-8D59-EA90DF99A686}"/>
               </a:ext>
             </a:extLst>
           </p:cNvPr>
@@ -9113,7 +9245,7 @@
     </p:spTree>
     <p:extLst>
       <p:ext uri="{BB962C8B-B14F-4D97-AF65-F5344CB8AC3E}">
-        <p14:creationId xmlns:p14="http://schemas.microsoft.com/office/powerpoint/2010/main" val="664469064"/>
+        <p14:creationId xmlns:p14="http://schemas.microsoft.com/office/powerpoint/2010/main" val="413684272"/>
       </p:ext>
     </p:extLst>
   </p:cSld>
@@ -9144,7 +9276,7 @@
           <p:cNvPr id="8" name="">
             <a:extLst xmlns:a="http://schemas.openxmlformats.org/drawingml/2006/main">
               <a:ext uri="{FF2B5EF4-FFF2-40B4-BE49-F238E27FC236}">
-                <a16:creationId xmlns:a16="http://schemas.microsoft.com/office/drawing/2014/main" id="{6B7FB558-E563-4111-B028-E90D26ABE405}"/>
+                <a16:creationId xmlns:a16="http://schemas.microsoft.com/office/drawing/2014/main" id="{0D295FAC-72E0-4B60-9722-0672012349E6}"/>
               </a:ext>
             </a:extLst>
           </p:cNvPr>
@@ -9210,7 +9342,7 @@
           <p:cNvPr id="2" name="">
             <a:extLst xmlns:a="http://schemas.openxmlformats.org/drawingml/2006/main">
               <a:ext uri="{FF2B5EF4-FFF2-40B4-BE49-F238E27FC236}">
-                <a16:creationId xmlns:a16="http://schemas.microsoft.com/office/drawing/2014/main" id="{52127F8C-4ED8-4EB4-8947-427864ACC6A7}"/>
+                <a16:creationId xmlns:a16="http://schemas.microsoft.com/office/drawing/2014/main" id="{38FA211D-877D-4CDE-B949-0A56F84B8A1D}"/>
               </a:ext>
             </a:extLst>
           </p:cNvPr>
@@ -9276,7 +9408,7 @@
           <p:cNvPr id="3" name="">
             <a:extLst xmlns:a="http://schemas.openxmlformats.org/drawingml/2006/main">
               <a:ext uri="{FF2B5EF4-FFF2-40B4-BE49-F238E27FC236}">
-                <a16:creationId xmlns:a16="http://schemas.microsoft.com/office/drawing/2014/main" id="{42D513DD-5547-4E4F-B949-8340BFDF30EF}"/>
+                <a16:creationId xmlns:a16="http://schemas.microsoft.com/office/drawing/2014/main" id="{747A528C-E292-47AF-8FFF-4DA2B078A868}"/>
               </a:ext>
             </a:extLst>
           </p:cNvPr>
@@ -9342,7 +9474,7 @@
           <p:cNvPr id="4" name="">
             <a:extLst xmlns:a="http://schemas.openxmlformats.org/drawingml/2006/main">
               <a:ext uri="{FF2B5EF4-FFF2-40B4-BE49-F238E27FC236}">
-                <a16:creationId xmlns:a16="http://schemas.microsoft.com/office/drawing/2014/main" id="{FF20D06B-62EB-4CE1-8BC2-ACF4E7AA64F4}"/>
+                <a16:creationId xmlns:a16="http://schemas.microsoft.com/office/drawing/2014/main" id="{BB43E90E-EE24-4522-A752-FB389FE4A531}"/>
               </a:ext>
             </a:extLst>
           </p:cNvPr>
@@ -9408,7 +9540,7 @@
           <p:cNvPr id="5" name="">
             <a:extLst xmlns:a="http://schemas.openxmlformats.org/drawingml/2006/main">
               <a:ext uri="{FF2B5EF4-FFF2-40B4-BE49-F238E27FC236}">
-                <a16:creationId xmlns:a16="http://schemas.microsoft.com/office/drawing/2014/main" id="{BA5DD01B-B558-43CA-9F16-DE9C68D637CC}"/>
+                <a16:creationId xmlns:a16="http://schemas.microsoft.com/office/drawing/2014/main" id="{D3CF69DE-A157-475C-BCB1-DBCE891C2C45}"/>
               </a:ext>
             </a:extLst>
           </p:cNvPr>
@@ -9566,7 +9698,7 @@
           <p:cNvPr id="6" name="">
             <a:extLst xmlns:a="http://schemas.openxmlformats.org/drawingml/2006/main">
               <a:ext uri="{FF2B5EF4-FFF2-40B4-BE49-F238E27FC236}">
-                <a16:creationId xmlns:a16="http://schemas.microsoft.com/office/drawing/2014/main" id="{F76C3D3F-0993-43C5-B411-11252B61771E}"/>
+                <a16:creationId xmlns:a16="http://schemas.microsoft.com/office/drawing/2014/main" id="{062DD86C-4626-4FA8-94D4-6F181CEFCBF1}"/>
               </a:ext>
             </a:extLst>
           </p:cNvPr>
@@ -9724,7 +9856,7 @@
           <p:cNvPr id="7" name="">
             <a:extLst xmlns:a="http://schemas.openxmlformats.org/drawingml/2006/main">
               <a:ext uri="{FF2B5EF4-FFF2-40B4-BE49-F238E27FC236}">
-                <a16:creationId xmlns:a16="http://schemas.microsoft.com/office/drawing/2014/main" id="{AD6BEB43-64C4-4A29-9421-55F189ADB8F3}"/>
+                <a16:creationId xmlns:a16="http://schemas.microsoft.com/office/drawing/2014/main" id="{06582A97-C49B-48B5-87C4-8B91AD56BB29}"/>
               </a:ext>
             </a:extLst>
           </p:cNvPr>
@@ -9788,7 +9920,7 @@
     </p:spTree>
     <p:extLst>
       <p:ext uri="{BB962C8B-B14F-4D97-AF65-F5344CB8AC3E}">
-        <p14:creationId xmlns:p14="http://schemas.microsoft.com/office/powerpoint/2010/main" val="2022003136"/>
+        <p14:creationId xmlns:p14="http://schemas.microsoft.com/office/powerpoint/2010/main" val="1894826526"/>
       </p:ext>
     </p:extLst>
   </p:cSld>
@@ -9819,7 +9951,7 @@
           <p:cNvPr id="9" name="">
             <a:extLst xmlns:a="http://schemas.openxmlformats.org/drawingml/2006/main">
               <a:ext uri="{FF2B5EF4-FFF2-40B4-BE49-F238E27FC236}">
-                <a16:creationId xmlns:a16="http://schemas.microsoft.com/office/drawing/2014/main" id="{8D5770B4-21BB-4AB4-9287-126B9A2B1400}"/>
+                <a16:creationId xmlns:a16="http://schemas.microsoft.com/office/drawing/2014/main" id="{0C6B0993-AF14-4114-B0AC-022B49E68F9F}"/>
               </a:ext>
             </a:extLst>
           </p:cNvPr>
@@ -9885,7 +10017,7 @@
           <p:cNvPr id="2" name="">
             <a:extLst xmlns:a="http://schemas.openxmlformats.org/drawingml/2006/main">
               <a:ext uri="{FF2B5EF4-FFF2-40B4-BE49-F238E27FC236}">
-                <a16:creationId xmlns:a16="http://schemas.microsoft.com/office/drawing/2014/main" id="{DFD60C53-2380-4EF6-A094-58917808CF56}"/>
+                <a16:creationId xmlns:a16="http://schemas.microsoft.com/office/drawing/2014/main" id="{DBC742CA-B495-4F8D-A986-82ACD6F77A4B}"/>
               </a:ext>
             </a:extLst>
           </p:cNvPr>
@@ -9951,7 +10083,7 @@
           <p:cNvPr id="3" name="">
             <a:extLst xmlns:a="http://schemas.openxmlformats.org/drawingml/2006/main">
               <a:ext uri="{FF2B5EF4-FFF2-40B4-BE49-F238E27FC236}">
-                <a16:creationId xmlns:a16="http://schemas.microsoft.com/office/drawing/2014/main" id="{F80D9698-8A0C-46DD-BEC1-52119E0B8FCC}"/>
+                <a16:creationId xmlns:a16="http://schemas.microsoft.com/office/drawing/2014/main" id="{D4D7D111-6FEA-4567-91FE-D7AD7F4A7EF9}"/>
               </a:ext>
             </a:extLst>
           </p:cNvPr>
@@ -10017,7 +10149,7 @@
           <p:cNvPr id="4" name="">
             <a:extLst xmlns:a="http://schemas.openxmlformats.org/drawingml/2006/main">
               <a:ext uri="{FF2B5EF4-FFF2-40B4-BE49-F238E27FC236}">
-                <a16:creationId xmlns:a16="http://schemas.microsoft.com/office/drawing/2014/main" id="{E1AAB565-FADF-48DC-8116-6CFA0CE21144}"/>
+                <a16:creationId xmlns:a16="http://schemas.microsoft.com/office/drawing/2014/main" id="{152F6FBF-D787-4111-91A7-FB839FB9C35F}"/>
               </a:ext>
             </a:extLst>
           </p:cNvPr>
@@ -10083,7 +10215,7 @@
           <p:cNvPr id="5" name="">
             <a:extLst xmlns:a="http://schemas.openxmlformats.org/drawingml/2006/main">
               <a:ext uri="{FF2B5EF4-FFF2-40B4-BE49-F238E27FC236}">
-                <a16:creationId xmlns:a16="http://schemas.microsoft.com/office/drawing/2014/main" id="{E5220606-1823-4A28-B112-A395CB2DD4C2}"/>
+                <a16:creationId xmlns:a16="http://schemas.microsoft.com/office/drawing/2014/main" id="{B75BDF48-854A-4C6F-8DD0-671FFBD216DA}"/>
               </a:ext>
             </a:extLst>
           </p:cNvPr>
@@ -10205,7 +10337,7 @@
           <p:cNvPr id="6" name="">
             <a:extLst xmlns:a="http://schemas.openxmlformats.org/drawingml/2006/main">
               <a:ext uri="{FF2B5EF4-FFF2-40B4-BE49-F238E27FC236}">
-                <a16:creationId xmlns:a16="http://schemas.microsoft.com/office/drawing/2014/main" id="{CD17103A-D048-4852-BFF8-C006FFB8CAC0}"/>
+                <a16:creationId xmlns:a16="http://schemas.microsoft.com/office/drawing/2014/main" id="{01BFDF2E-2710-43E5-8EAC-7DA89E565162}"/>
               </a:ext>
             </a:extLst>
           </p:cNvPr>
@@ -10271,7 +10403,7 @@
           <p:cNvPr id="7" name="">
             <a:extLst xmlns:a="http://schemas.openxmlformats.org/drawingml/2006/main">
               <a:ext uri="{FF2B5EF4-FFF2-40B4-BE49-F238E27FC236}">
-                <a16:creationId xmlns:a16="http://schemas.microsoft.com/office/drawing/2014/main" id="{CFF26C08-59F5-49E7-A18D-A9ECAB4F150B}"/>
+                <a16:creationId xmlns:a16="http://schemas.microsoft.com/office/drawing/2014/main" id="{D210EED8-B593-499B-B89E-E1B8D6644BA0}"/>
               </a:ext>
             </a:extLst>
           </p:cNvPr>
@@ -10393,7 +10525,7 @@
           <p:cNvPr id="8" name="">
             <a:extLst xmlns:a="http://schemas.openxmlformats.org/drawingml/2006/main">
               <a:ext uri="{FF2B5EF4-FFF2-40B4-BE49-F238E27FC236}">
-                <a16:creationId xmlns:a16="http://schemas.microsoft.com/office/drawing/2014/main" id="{F9C016DE-2F29-47E4-9B66-5816DAF70178}"/>
+                <a16:creationId xmlns:a16="http://schemas.microsoft.com/office/drawing/2014/main" id="{A5E870BC-A035-46AA-B296-898EDF110A0A}"/>
               </a:ext>
             </a:extLst>
           </p:cNvPr>
@@ -10457,7 +10589,7 @@
     </p:spTree>
     <p:extLst>
       <p:ext uri="{BB962C8B-B14F-4D97-AF65-F5344CB8AC3E}">
-        <p14:creationId xmlns:p14="http://schemas.microsoft.com/office/powerpoint/2010/main" val="1928784474"/>
+        <p14:creationId xmlns:p14="http://schemas.microsoft.com/office/powerpoint/2010/main" val="852954804"/>
       </p:ext>
     </p:extLst>
   </p:cSld>
@@ -10488,7 +10620,7 @@
           <p:cNvPr id="10" name="">
             <a:extLst xmlns:a="http://schemas.openxmlformats.org/drawingml/2006/main">
               <a:ext uri="{FF2B5EF4-FFF2-40B4-BE49-F238E27FC236}">
-                <a16:creationId xmlns:a16="http://schemas.microsoft.com/office/drawing/2014/main" id="{AA2FB47D-3351-4320-BF30-666A99658BAF}"/>
+                <a16:creationId xmlns:a16="http://schemas.microsoft.com/office/drawing/2014/main" id="{948B3E63-3351-49A4-A0B7-61029F2F3D69}"/>
               </a:ext>
             </a:extLst>
           </p:cNvPr>
@@ -10554,7 +10686,7 @@
           <p:cNvPr id="2" name="">
             <a:extLst xmlns:a="http://schemas.openxmlformats.org/drawingml/2006/main">
               <a:ext uri="{FF2B5EF4-FFF2-40B4-BE49-F238E27FC236}">
-                <a16:creationId xmlns:a16="http://schemas.microsoft.com/office/drawing/2014/main" id="{74C469E6-AB57-43E3-8B44-6C0D1ECDBB86}"/>
+                <a16:creationId xmlns:a16="http://schemas.microsoft.com/office/drawing/2014/main" id="{625F2219-8AE5-4CDC-8695-A279E4BE48AF}"/>
               </a:ext>
             </a:extLst>
           </p:cNvPr>
@@ -10620,7 +10752,7 @@
           <p:cNvPr id="3" name="">
             <a:extLst xmlns:a="http://schemas.openxmlformats.org/drawingml/2006/main">
               <a:ext uri="{FF2B5EF4-FFF2-40B4-BE49-F238E27FC236}">
-                <a16:creationId xmlns:a16="http://schemas.microsoft.com/office/drawing/2014/main" id="{37D1E1D9-4C01-452A-84A8-DEC4D740910E}"/>
+                <a16:creationId xmlns:a16="http://schemas.microsoft.com/office/drawing/2014/main" id="{EA133C32-3C14-4DF7-8A35-803151B2119A}"/>
               </a:ext>
             </a:extLst>
           </p:cNvPr>
@@ -10686,7 +10818,7 @@
           <p:cNvPr id="4" name="">
             <a:extLst xmlns:a="http://schemas.openxmlformats.org/drawingml/2006/main">
               <a:ext uri="{FF2B5EF4-FFF2-40B4-BE49-F238E27FC236}">
-                <a16:creationId xmlns:a16="http://schemas.microsoft.com/office/drawing/2014/main" id="{4FA8D79D-BDF4-4E15-ADD9-5E55104A337C}"/>
+                <a16:creationId xmlns:a16="http://schemas.microsoft.com/office/drawing/2014/main" id="{44A2B04B-BB9A-48E7-AA96-0BEDEDBEA2B8}"/>
               </a:ext>
             </a:extLst>
           </p:cNvPr>
@@ -10696,7 +10828,7 @@
           <p:nvPr/>
         </p:nvPicPr>
         <p:blipFill>
-          <a:blip xmlns:r="http://schemas.openxmlformats.org/officeDocument/2006/relationships" xmlns:a="http://schemas.openxmlformats.org/drawingml/2006/main" r:embed="R174f2425ff224924"/>
+          <a:blip xmlns:r="http://schemas.openxmlformats.org/officeDocument/2006/relationships" xmlns:a="http://schemas.openxmlformats.org/drawingml/2006/main" r:embed="R16ba947ac3d742e2"/>
           <a:stretch xmlns:a="http://schemas.openxmlformats.org/drawingml/2006/main"/>
         </p:blipFill>
         <p:spPr>
@@ -10714,7 +10846,7 @@
           <p:cNvPr id="5" name="">
             <a:extLst xmlns:a="http://schemas.openxmlformats.org/drawingml/2006/main">
               <a:ext uri="{FF2B5EF4-FFF2-40B4-BE49-F238E27FC236}">
-                <a16:creationId xmlns:a16="http://schemas.microsoft.com/office/drawing/2014/main" id="{B2463CA2-3D1B-4849-9288-3591844A6882}"/>
+                <a16:creationId xmlns:a16="http://schemas.microsoft.com/office/drawing/2014/main" id="{BEE110CE-CEEF-4331-A66A-C04CAE27CD5A}"/>
               </a:ext>
             </a:extLst>
           </p:cNvPr>
@@ -10780,7 +10912,7 @@
           <p:cNvPr id="6" name="">
             <a:extLst xmlns:a="http://schemas.openxmlformats.org/drawingml/2006/main">
               <a:ext uri="{FF2B5EF4-FFF2-40B4-BE49-F238E27FC236}">
-                <a16:creationId xmlns:a16="http://schemas.microsoft.com/office/drawing/2014/main" id="{0E7D40CD-ED48-4C20-A6FF-D107AAD894BA}"/>
+                <a16:creationId xmlns:a16="http://schemas.microsoft.com/office/drawing/2014/main" id="{7D7BB751-3F8D-49D8-824A-666013975E8A}"/>
               </a:ext>
             </a:extLst>
           </p:cNvPr>
@@ -10846,7 +10978,7 @@
           <p:cNvPr id="7" name="">
             <a:extLst xmlns:a="http://schemas.openxmlformats.org/drawingml/2006/main">
               <a:ext uri="{FF2B5EF4-FFF2-40B4-BE49-F238E27FC236}">
-                <a16:creationId xmlns:a16="http://schemas.microsoft.com/office/drawing/2014/main" id="{E1B4DD4D-C0ED-4447-B18D-53F1DA461E04}"/>
+                <a16:creationId xmlns:a16="http://schemas.microsoft.com/office/drawing/2014/main" id="{333765B0-32FB-45B8-B58A-091769AF843D}"/>
               </a:ext>
             </a:extLst>
           </p:cNvPr>
@@ -10912,7 +11044,7 @@
           <p:cNvPr id="8" name="">
             <a:extLst xmlns:a="http://schemas.openxmlformats.org/drawingml/2006/main">
               <a:ext uri="{FF2B5EF4-FFF2-40B4-BE49-F238E27FC236}">
-                <a16:creationId xmlns:a16="http://schemas.microsoft.com/office/drawing/2014/main" id="{FAE21944-7AB2-4C86-8D64-D3AE7100BF05}"/>
+                <a16:creationId xmlns:a16="http://schemas.microsoft.com/office/drawing/2014/main" id="{2E640E5D-EF7C-4979-A847-DDF770F2A18A}"/>
               </a:ext>
             </a:extLst>
           </p:cNvPr>
@@ -10978,7 +11110,7 @@
           <p:cNvPr id="9" name="">
             <a:extLst xmlns:a="http://schemas.openxmlformats.org/drawingml/2006/main">
               <a:ext uri="{FF2B5EF4-FFF2-40B4-BE49-F238E27FC236}">
-                <a16:creationId xmlns:a16="http://schemas.microsoft.com/office/drawing/2014/main" id="{18B2A5FE-3D69-4800-96B3-657767A99771}"/>
+                <a16:creationId xmlns:a16="http://schemas.microsoft.com/office/drawing/2014/main" id="{0D347EF8-D80A-4BBE-8D78-09F9A884BD86}"/>
               </a:ext>
             </a:extLst>
           </p:cNvPr>
@@ -11042,7 +11174,7 @@
     </p:spTree>
     <p:extLst>
       <p:ext uri="{BB962C8B-B14F-4D97-AF65-F5344CB8AC3E}">
-        <p14:creationId xmlns:p14="http://schemas.microsoft.com/office/powerpoint/2010/main" val="1591236520"/>
+        <p14:creationId xmlns:p14="http://schemas.microsoft.com/office/powerpoint/2010/main" val="1730758473"/>
       </p:ext>
     </p:extLst>
   </p:cSld>
@@ -11073,7 +11205,7 @@
           <p:cNvPr id="16" name="">
             <a:extLst xmlns:a="http://schemas.openxmlformats.org/drawingml/2006/main">
               <a:ext uri="{FF2B5EF4-FFF2-40B4-BE49-F238E27FC236}">
-                <a16:creationId xmlns:a16="http://schemas.microsoft.com/office/drawing/2014/main" id="{4597D5C5-99A3-426A-B5C7-B6219265CFC6}"/>
+                <a16:creationId xmlns:a16="http://schemas.microsoft.com/office/drawing/2014/main" id="{07C96444-7725-4D0E-B3BF-01B744231A35}"/>
               </a:ext>
             </a:extLst>
           </p:cNvPr>
@@ -11139,7 +11271,7 @@
           <p:cNvPr id="2" name="">
             <a:extLst xmlns:a="http://schemas.openxmlformats.org/drawingml/2006/main">
               <a:ext uri="{FF2B5EF4-FFF2-40B4-BE49-F238E27FC236}">
-                <a16:creationId xmlns:a16="http://schemas.microsoft.com/office/drawing/2014/main" id="{99A01590-0A59-4C8B-A6D2-A0A9B848C1C9}"/>
+                <a16:creationId xmlns:a16="http://schemas.microsoft.com/office/drawing/2014/main" id="{E253CB9F-3337-4742-93D6-3D5C82E36A23}"/>
               </a:ext>
             </a:extLst>
           </p:cNvPr>
@@ -11205,7 +11337,7 @@
           <p:cNvPr id="3" name="">
             <a:extLst xmlns:a="http://schemas.openxmlformats.org/drawingml/2006/main">
               <a:ext uri="{FF2B5EF4-FFF2-40B4-BE49-F238E27FC236}">
-                <a16:creationId xmlns:a16="http://schemas.microsoft.com/office/drawing/2014/main" id="{83B08E0A-CF4C-4109-9F71-4447EE292C41}"/>
+                <a16:creationId xmlns:a16="http://schemas.microsoft.com/office/drawing/2014/main" id="{4B249506-E712-45CF-AB93-75ECF2E65D65}"/>
               </a:ext>
             </a:extLst>
           </p:cNvPr>
@@ -11271,7 +11403,7 @@
           <p:cNvPr id="4" name="">
             <a:extLst xmlns:a="http://schemas.openxmlformats.org/drawingml/2006/main">
               <a:ext uri="{FF2B5EF4-FFF2-40B4-BE49-F238E27FC236}">
-                <a16:creationId xmlns:a16="http://schemas.microsoft.com/office/drawing/2014/main" id="{A2F0BA9C-7DE2-4D75-935D-870BDB451F47}"/>
+                <a16:creationId xmlns:a16="http://schemas.microsoft.com/office/drawing/2014/main" id="{20606DA0-20E6-4AF1-B31D-3AB74880719D}"/>
               </a:ext>
             </a:extLst>
           </p:cNvPr>
@@ -11337,7 +11469,7 @@
           <p:cNvPr id="5" name="">
             <a:extLst xmlns:a="http://schemas.openxmlformats.org/drawingml/2006/main">
               <a:ext uri="{FF2B5EF4-FFF2-40B4-BE49-F238E27FC236}">
-                <a16:creationId xmlns:a16="http://schemas.microsoft.com/office/drawing/2014/main" id="{2493D1BE-2144-429C-84F6-5A0FB3738C98}"/>
+                <a16:creationId xmlns:a16="http://schemas.microsoft.com/office/drawing/2014/main" id="{2B67ECC5-91EF-49EA-8013-9731BAFE0122}"/>
               </a:ext>
             </a:extLst>
           </p:cNvPr>
@@ -11403,7 +11535,7 @@
           <p:cNvPr id="6" name="">
             <a:extLst xmlns:a="http://schemas.openxmlformats.org/drawingml/2006/main">
               <a:ext uri="{FF2B5EF4-FFF2-40B4-BE49-F238E27FC236}">
-                <a16:creationId xmlns:a16="http://schemas.microsoft.com/office/drawing/2014/main" id="{8C5068B8-D9EE-45F4-B1A2-F88135E26EEC}"/>
+                <a16:creationId xmlns:a16="http://schemas.microsoft.com/office/drawing/2014/main" id="{9A28FEAF-3546-459A-8890-90CA90DC4DF1}"/>
               </a:ext>
             </a:extLst>
           </p:cNvPr>
@@ -11469,7 +11601,7 @@
           <p:cNvPr id="7" name="">
             <a:extLst xmlns:a="http://schemas.openxmlformats.org/drawingml/2006/main">
               <a:ext uri="{FF2B5EF4-FFF2-40B4-BE49-F238E27FC236}">
-                <a16:creationId xmlns:a16="http://schemas.microsoft.com/office/drawing/2014/main" id="{CFC5AF0E-B22C-4F9A-A6F3-5A3642EF6D0B}"/>
+                <a16:creationId xmlns:a16="http://schemas.microsoft.com/office/drawing/2014/main" id="{16DDED9B-005A-49FA-A1EC-D6BB4611A67C}"/>
               </a:ext>
             </a:extLst>
           </p:cNvPr>
@@ -11535,7 +11667,7 @@
           <p:cNvPr id="8" name="">
             <a:extLst xmlns:a="http://schemas.openxmlformats.org/drawingml/2006/main">
               <a:ext uri="{FF2B5EF4-FFF2-40B4-BE49-F238E27FC236}">
-                <a16:creationId xmlns:a16="http://schemas.microsoft.com/office/drawing/2014/main" id="{6B9CC6A9-F628-4ACF-BE00-BE0915AE7681}"/>
+                <a16:creationId xmlns:a16="http://schemas.microsoft.com/office/drawing/2014/main" id="{3E09385E-E1C3-4C6D-AF76-BD625F05C669}"/>
               </a:ext>
             </a:extLst>
           </p:cNvPr>
@@ -11601,7 +11733,7 @@
           <p:cNvPr id="9" name="">
             <a:extLst xmlns:a="http://schemas.openxmlformats.org/drawingml/2006/main">
               <a:ext uri="{FF2B5EF4-FFF2-40B4-BE49-F238E27FC236}">
-                <a16:creationId xmlns:a16="http://schemas.microsoft.com/office/drawing/2014/main" id="{2AFDCBC6-9D69-42FA-9487-686D734EB362}"/>
+                <a16:creationId xmlns:a16="http://schemas.microsoft.com/office/drawing/2014/main" id="{F193E4FE-FE04-4B44-89C9-1769A7231B44}"/>
               </a:ext>
             </a:extLst>
           </p:cNvPr>
@@ -11667,7 +11799,7 @@
           <p:cNvPr id="10" name="">
             <a:extLst xmlns:a="http://schemas.openxmlformats.org/drawingml/2006/main">
               <a:ext uri="{FF2B5EF4-FFF2-40B4-BE49-F238E27FC236}">
-                <a16:creationId xmlns:a16="http://schemas.microsoft.com/office/drawing/2014/main" id="{B89D4C32-37F7-46CB-AC01-94D729DC8B6C}"/>
+                <a16:creationId xmlns:a16="http://schemas.microsoft.com/office/drawing/2014/main" id="{863A41D8-79A1-49E3-951A-B0E44751ED82}"/>
               </a:ext>
             </a:extLst>
           </p:cNvPr>
@@ -11733,7 +11865,7 @@
           <p:cNvPr id="11" name="">
             <a:extLst xmlns:a="http://schemas.openxmlformats.org/drawingml/2006/main">
               <a:ext uri="{FF2B5EF4-FFF2-40B4-BE49-F238E27FC236}">
-                <a16:creationId xmlns:a16="http://schemas.microsoft.com/office/drawing/2014/main" id="{7EA1D0CA-69EB-44BE-BB5A-1A6E107EDBAE}"/>
+                <a16:creationId xmlns:a16="http://schemas.microsoft.com/office/drawing/2014/main" id="{240F36C3-80FA-4631-83EC-3F936F213168}"/>
               </a:ext>
             </a:extLst>
           </p:cNvPr>
@@ -11799,7 +11931,7 @@
           <p:cNvPr id="12" name="">
             <a:extLst xmlns:a="http://schemas.openxmlformats.org/drawingml/2006/main">
               <a:ext uri="{FF2B5EF4-FFF2-40B4-BE49-F238E27FC236}">
-                <a16:creationId xmlns:a16="http://schemas.microsoft.com/office/drawing/2014/main" id="{8B6F8F3E-6803-45E0-857B-DB353448DE10}"/>
+                <a16:creationId xmlns:a16="http://schemas.microsoft.com/office/drawing/2014/main" id="{281DA35D-8005-467F-A67E-B2A7F2B0AC13}"/>
               </a:ext>
             </a:extLst>
           </p:cNvPr>
@@ -11865,7 +11997,7 @@
           <p:cNvPr id="13" name="">
             <a:extLst xmlns:a="http://schemas.openxmlformats.org/drawingml/2006/main">
               <a:ext uri="{FF2B5EF4-FFF2-40B4-BE49-F238E27FC236}">
-                <a16:creationId xmlns:a16="http://schemas.microsoft.com/office/drawing/2014/main" id="{1EA9DF49-8061-4EEB-9AB8-9DDF613F6B11}"/>
+                <a16:creationId xmlns:a16="http://schemas.microsoft.com/office/drawing/2014/main" id="{319EEFB6-F8E9-4DC9-BC1C-36074015CCAF}"/>
               </a:ext>
             </a:extLst>
           </p:cNvPr>
@@ -11931,7 +12063,7 @@
           <p:cNvPr id="14" name="">
             <a:extLst xmlns:a="http://schemas.openxmlformats.org/drawingml/2006/main">
               <a:ext uri="{FF2B5EF4-FFF2-40B4-BE49-F238E27FC236}">
-                <a16:creationId xmlns:a16="http://schemas.microsoft.com/office/drawing/2014/main" id="{7D855DCE-AD67-45E2-9A22-1D31921441EF}"/>
+                <a16:creationId xmlns:a16="http://schemas.microsoft.com/office/drawing/2014/main" id="{A53F3723-FB91-4E19-9B63-0FFA6ED6AC0A}"/>
               </a:ext>
             </a:extLst>
           </p:cNvPr>
@@ -11997,7 +12129,7 @@
           <p:cNvPr id="15" name="">
             <a:extLst xmlns:a="http://schemas.openxmlformats.org/drawingml/2006/main">
               <a:ext uri="{FF2B5EF4-FFF2-40B4-BE49-F238E27FC236}">
-                <a16:creationId xmlns:a16="http://schemas.microsoft.com/office/drawing/2014/main" id="{3EAED5FD-DF60-4131-A946-944C587E64CE}"/>
+                <a16:creationId xmlns:a16="http://schemas.microsoft.com/office/drawing/2014/main" id="{91D9B62F-B6AD-4517-AC81-A79A2319250A}"/>
               </a:ext>
             </a:extLst>
           </p:cNvPr>
@@ -12061,7 +12193,7 @@
     </p:spTree>
     <p:extLst>
       <p:ext uri="{BB962C8B-B14F-4D97-AF65-F5344CB8AC3E}">
-        <p14:creationId xmlns:p14="http://schemas.microsoft.com/office/powerpoint/2010/main" val="1227914953"/>
+        <p14:creationId xmlns:p14="http://schemas.microsoft.com/office/powerpoint/2010/main" val="944770522"/>
       </p:ext>
     </p:extLst>
   </p:cSld>
@@ -12092,7 +12224,7 @@
           <p:cNvPr id="17" name="">
             <a:extLst xmlns:a="http://schemas.openxmlformats.org/drawingml/2006/main">
               <a:ext uri="{FF2B5EF4-FFF2-40B4-BE49-F238E27FC236}">
-                <a16:creationId xmlns:a16="http://schemas.microsoft.com/office/drawing/2014/main" id="{7CCFF7E0-D4F1-4D9A-912E-F010087ACC0A}"/>
+                <a16:creationId xmlns:a16="http://schemas.microsoft.com/office/drawing/2014/main" id="{D400D42F-88A2-4272-9A77-C34EB42F1EF5}"/>
               </a:ext>
             </a:extLst>
           </p:cNvPr>
@@ -12158,7 +12290,7 @@
           <p:cNvPr id="2" name="">
             <a:extLst xmlns:a="http://schemas.openxmlformats.org/drawingml/2006/main">
               <a:ext uri="{FF2B5EF4-FFF2-40B4-BE49-F238E27FC236}">
-                <a16:creationId xmlns:a16="http://schemas.microsoft.com/office/drawing/2014/main" id="{73A5BEE8-89F7-4650-9A45-DF625A745733}"/>
+                <a16:creationId xmlns:a16="http://schemas.microsoft.com/office/drawing/2014/main" id="{78A5EB56-F962-4053-BF48-102B4812F616}"/>
               </a:ext>
             </a:extLst>
           </p:cNvPr>
@@ -12224,7 +12356,7 @@
           <p:cNvPr id="3" name="">
             <a:extLst xmlns:a="http://schemas.openxmlformats.org/drawingml/2006/main">
               <a:ext uri="{FF2B5EF4-FFF2-40B4-BE49-F238E27FC236}">
-                <a16:creationId xmlns:a16="http://schemas.microsoft.com/office/drawing/2014/main" id="{D82C5F94-569B-444F-B626-59703DE07DBF}"/>
+                <a16:creationId xmlns:a16="http://schemas.microsoft.com/office/drawing/2014/main" id="{8C4A2155-C080-4393-89CB-655F43E4A4F5}"/>
               </a:ext>
             </a:extLst>
           </p:cNvPr>
@@ -12290,7 +12422,7 @@
           <p:cNvPr id="4" name="">
             <a:extLst xmlns:a="http://schemas.openxmlformats.org/drawingml/2006/main">
               <a:ext uri="{FF2B5EF4-FFF2-40B4-BE49-F238E27FC236}">
-                <a16:creationId xmlns:a16="http://schemas.microsoft.com/office/drawing/2014/main" id="{DDD3975E-C4EA-4E24-978F-68E64EEB031C}"/>
+                <a16:creationId xmlns:a16="http://schemas.microsoft.com/office/drawing/2014/main" id="{4454D696-6EDC-46B1-B859-0FF3A2982118}"/>
               </a:ext>
             </a:extLst>
           </p:cNvPr>
@@ -12356,7 +12488,7 @@
           <p:cNvPr id="5" name="">
             <a:extLst xmlns:a="http://schemas.openxmlformats.org/drawingml/2006/main">
               <a:ext uri="{FF2B5EF4-FFF2-40B4-BE49-F238E27FC236}">
-                <a16:creationId xmlns:a16="http://schemas.microsoft.com/office/drawing/2014/main" id="{4BE9B525-9B90-4833-A027-50500444458F}"/>
+                <a16:creationId xmlns:a16="http://schemas.microsoft.com/office/drawing/2014/main" id="{0206DD72-3667-46DB-A106-E0E7BF14C1E9}"/>
               </a:ext>
             </a:extLst>
           </p:cNvPr>
@@ -12422,7 +12554,7 @@
           <p:cNvPr id="6" name="">
             <a:extLst xmlns:a="http://schemas.openxmlformats.org/drawingml/2006/main">
               <a:ext uri="{FF2B5EF4-FFF2-40B4-BE49-F238E27FC236}">
-                <a16:creationId xmlns:a16="http://schemas.microsoft.com/office/drawing/2014/main" id="{60FE6226-6EA9-4908-AE2F-C6DB90C9A325}"/>
+                <a16:creationId xmlns:a16="http://schemas.microsoft.com/office/drawing/2014/main" id="{20799059-57DD-4E19-A5A2-4777AB86D467}"/>
               </a:ext>
             </a:extLst>
           </p:cNvPr>
@@ -12488,7 +12620,7 @@
           <p:cNvPr id="7" name="">
             <a:extLst xmlns:a="http://schemas.openxmlformats.org/drawingml/2006/main">
               <a:ext uri="{FF2B5EF4-FFF2-40B4-BE49-F238E27FC236}">
-                <a16:creationId xmlns:a16="http://schemas.microsoft.com/office/drawing/2014/main" id="{6FA91820-FD30-4613-AA68-2A99450028D2}"/>
+                <a16:creationId xmlns:a16="http://schemas.microsoft.com/office/drawing/2014/main" id="{545246A1-2163-44AC-B97D-5E20D9D8DCF9}"/>
               </a:ext>
             </a:extLst>
           </p:cNvPr>
@@ -12554,7 +12686,7 @@
           <p:cNvPr id="8" name="">
             <a:extLst xmlns:a="http://schemas.openxmlformats.org/drawingml/2006/main">
               <a:ext uri="{FF2B5EF4-FFF2-40B4-BE49-F238E27FC236}">
-                <a16:creationId xmlns:a16="http://schemas.microsoft.com/office/drawing/2014/main" id="{39BCB891-B089-4939-80A4-6F35197F3D50}"/>
+                <a16:creationId xmlns:a16="http://schemas.microsoft.com/office/drawing/2014/main" id="{DF624878-D4D1-4220-B16D-33C62349F58D}"/>
               </a:ext>
             </a:extLst>
           </p:cNvPr>
@@ -12620,7 +12752,7 @@
           <p:cNvPr id="9" name="">
             <a:extLst xmlns:a="http://schemas.openxmlformats.org/drawingml/2006/main">
               <a:ext uri="{FF2B5EF4-FFF2-40B4-BE49-F238E27FC236}">
-                <a16:creationId xmlns:a16="http://schemas.microsoft.com/office/drawing/2014/main" id="{155FA201-D7B4-416E-88A2-A96A9D7959ED}"/>
+                <a16:creationId xmlns:a16="http://schemas.microsoft.com/office/drawing/2014/main" id="{56463E61-53DB-4BF6-9751-63D6B1B42578}"/>
               </a:ext>
             </a:extLst>
           </p:cNvPr>
@@ -12686,7 +12818,7 @@
           <p:cNvPr id="10" name="">
             <a:extLst xmlns:a="http://schemas.openxmlformats.org/drawingml/2006/main">
               <a:ext uri="{FF2B5EF4-FFF2-40B4-BE49-F238E27FC236}">
-                <a16:creationId xmlns:a16="http://schemas.microsoft.com/office/drawing/2014/main" id="{C7194844-0DA8-4D00-B0E2-A84A96BD3486}"/>
+                <a16:creationId xmlns:a16="http://schemas.microsoft.com/office/drawing/2014/main" id="{C4929CB9-57CD-4916-B164-F8A6822795F3}"/>
               </a:ext>
             </a:extLst>
           </p:cNvPr>
@@ -12752,7 +12884,7 @@
           <p:cNvPr id="11" name="">
             <a:extLst xmlns:a="http://schemas.openxmlformats.org/drawingml/2006/main">
               <a:ext uri="{FF2B5EF4-FFF2-40B4-BE49-F238E27FC236}">
-                <a16:creationId xmlns:a16="http://schemas.microsoft.com/office/drawing/2014/main" id="{0B95B74E-DD02-474C-9F82-1BC3BEEFEFD2}"/>
+                <a16:creationId xmlns:a16="http://schemas.microsoft.com/office/drawing/2014/main" id="{BF2E58A9-A9CA-45B2-8D78-99E773230727}"/>
               </a:ext>
             </a:extLst>
           </p:cNvPr>
@@ -12818,7 +12950,7 @@
           <p:cNvPr id="12" name="">
             <a:extLst xmlns:a="http://schemas.openxmlformats.org/drawingml/2006/main">
               <a:ext uri="{FF2B5EF4-FFF2-40B4-BE49-F238E27FC236}">
-                <a16:creationId xmlns:a16="http://schemas.microsoft.com/office/drawing/2014/main" id="{7B5A5871-8112-4ABE-A46E-77E6DF8FD887}"/>
+                <a16:creationId xmlns:a16="http://schemas.microsoft.com/office/drawing/2014/main" id="{D56BC98E-22FA-485C-BA6F-FD42D81E9FC2}"/>
               </a:ext>
             </a:extLst>
           </p:cNvPr>
@@ -12884,7 +13016,7 @@
           <p:cNvPr id="13" name="">
             <a:extLst xmlns:a="http://schemas.openxmlformats.org/drawingml/2006/main">
               <a:ext uri="{FF2B5EF4-FFF2-40B4-BE49-F238E27FC236}">
-                <a16:creationId xmlns:a16="http://schemas.microsoft.com/office/drawing/2014/main" id="{C42768E1-4E64-4CE0-8BD0-B053940EEB98}"/>
+                <a16:creationId xmlns:a16="http://schemas.microsoft.com/office/drawing/2014/main" id="{FA366088-97BC-4B2B-BE3F-DF875B3521F6}"/>
               </a:ext>
             </a:extLst>
           </p:cNvPr>
@@ -12950,7 +13082,7 @@
           <p:cNvPr id="14" name="">
             <a:extLst xmlns:a="http://schemas.openxmlformats.org/drawingml/2006/main">
               <a:ext uri="{FF2B5EF4-FFF2-40B4-BE49-F238E27FC236}">
-                <a16:creationId xmlns:a16="http://schemas.microsoft.com/office/drawing/2014/main" id="{092C8717-CEDD-43D0-8324-32954B506289}"/>
+                <a16:creationId xmlns:a16="http://schemas.microsoft.com/office/drawing/2014/main" id="{E720A513-53EB-4876-883D-3E011FE4C91D}"/>
               </a:ext>
             </a:extLst>
           </p:cNvPr>
@@ -13016,7 +13148,7 @@
           <p:cNvPr id="15" name="">
             <a:extLst xmlns:a="http://schemas.openxmlformats.org/drawingml/2006/main">
               <a:ext uri="{FF2B5EF4-FFF2-40B4-BE49-F238E27FC236}">
-                <a16:creationId xmlns:a16="http://schemas.microsoft.com/office/drawing/2014/main" id="{515F64F4-D1EA-463F-A07C-84F26ABCF543}"/>
+                <a16:creationId xmlns:a16="http://schemas.microsoft.com/office/drawing/2014/main" id="{FDAFDB9B-9EA5-4DA6-B4B3-E06AE64CB39A}"/>
               </a:ext>
             </a:extLst>
           </p:cNvPr>
@@ -13082,7 +13214,7 @@
           <p:cNvPr id="16" name="">
             <a:extLst xmlns:a="http://schemas.openxmlformats.org/drawingml/2006/main">
               <a:ext uri="{FF2B5EF4-FFF2-40B4-BE49-F238E27FC236}">
-                <a16:creationId xmlns:a16="http://schemas.microsoft.com/office/drawing/2014/main" id="{54CA9A86-DE03-4886-AD1F-28AEA61E66E9}"/>
+                <a16:creationId xmlns:a16="http://schemas.microsoft.com/office/drawing/2014/main" id="{5EAF49C8-A88E-46EF-8DC5-00BEAE7AC166}"/>
               </a:ext>
             </a:extLst>
           </p:cNvPr>
@@ -13146,7 +13278,7 @@
     </p:spTree>
     <p:extLst>
       <p:ext uri="{BB962C8B-B14F-4D97-AF65-F5344CB8AC3E}">
-        <p14:creationId xmlns:p14="http://schemas.microsoft.com/office/powerpoint/2010/main" val="140390463"/>
+        <p14:creationId xmlns:p14="http://schemas.microsoft.com/office/powerpoint/2010/main" val="1899047003"/>
       </p:ext>
     </p:extLst>
   </p:cSld>

</xml_diff>

<commit_message>
Disable spell-check underlines on team names
</commit_message>
<xml_diff>
--- a/docs/presentation/RideX-Ideathon-Presentation.pptx
+++ b/docs/presentation/RideX-Ideathon-Presentation.pptx
@@ -2,24 +2,24 @@
 <file path=ppt/presentation.xml><?xml version="1.0" encoding="utf-8"?>
 <p:presentation xmlns:p="http://schemas.openxmlformats.org/presentationml/2006/main">
   <p:sldMasterIdLst>
-    <p:sldMasterId xmlns:r="http://schemas.openxmlformats.org/officeDocument/2006/relationships" id="2147483648" r:id="Ra2d216a2a8e54bef"/>
+    <p:sldMasterId xmlns:r="http://schemas.openxmlformats.org/officeDocument/2006/relationships" id="2147483648" r:id="R1deb5dde3f0f49a7"/>
   </p:sldMasterIdLst>
   <p:notesMasterIdLst>
-    <p:notesMasterId xmlns:r="http://schemas.openxmlformats.org/officeDocument/2006/relationships" r:id="Rb41a68b57b714082"/>
+    <p:notesMasterId xmlns:r="http://schemas.openxmlformats.org/officeDocument/2006/relationships" r:id="Re98453b2dd3d44b0"/>
   </p:notesMasterIdLst>
   <p:sldIdLst>
-    <p:sldId xmlns:r="http://schemas.openxmlformats.org/officeDocument/2006/relationships" id="256" r:id="R0bd6320c6fd04b52"/>
-    <p:sldId xmlns:r="http://schemas.openxmlformats.org/officeDocument/2006/relationships" id="257" r:id="Rae7e826d06ef4108"/>
-    <p:sldId xmlns:r="http://schemas.openxmlformats.org/officeDocument/2006/relationships" id="258" r:id="R748cba32d9cc49ae"/>
-    <p:sldId xmlns:r="http://schemas.openxmlformats.org/officeDocument/2006/relationships" id="259" r:id="R3d141312c603424b"/>
-    <p:sldId xmlns:r="http://schemas.openxmlformats.org/officeDocument/2006/relationships" id="260" r:id="R009803513dbb44fa"/>
-    <p:sldId xmlns:r="http://schemas.openxmlformats.org/officeDocument/2006/relationships" id="261" r:id="R76bbde7a124f49c7"/>
-    <p:sldId xmlns:r="http://schemas.openxmlformats.org/officeDocument/2006/relationships" id="262" r:id="R560045ce4e2a4615"/>
-    <p:sldId xmlns:r="http://schemas.openxmlformats.org/officeDocument/2006/relationships" id="263" r:id="R42f055b28a294bc1"/>
-    <p:sldId xmlns:r="http://schemas.openxmlformats.org/officeDocument/2006/relationships" id="264" r:id="R333263571cf74f85"/>
-    <p:sldId xmlns:r="http://schemas.openxmlformats.org/officeDocument/2006/relationships" id="265" r:id="R4bf58ea5361b4db1"/>
-    <p:sldId xmlns:r="http://schemas.openxmlformats.org/officeDocument/2006/relationships" id="266" r:id="R10cac07668994aeb"/>
-    <p:sldId xmlns:r="http://schemas.openxmlformats.org/officeDocument/2006/relationships" id="267" r:id="R35e29188c5ad4bb5"/>
+    <p:sldId xmlns:r="http://schemas.openxmlformats.org/officeDocument/2006/relationships" id="256" r:id="R5cd3e90fd1f242ef"/>
+    <p:sldId xmlns:r="http://schemas.openxmlformats.org/officeDocument/2006/relationships" id="257" r:id="R031b7260466c45c9"/>
+    <p:sldId xmlns:r="http://schemas.openxmlformats.org/officeDocument/2006/relationships" id="258" r:id="Raecf6dfbc4d446e6"/>
+    <p:sldId xmlns:r="http://schemas.openxmlformats.org/officeDocument/2006/relationships" id="259" r:id="Ra7f50e6d88a542ba"/>
+    <p:sldId xmlns:r="http://schemas.openxmlformats.org/officeDocument/2006/relationships" id="260" r:id="Rd0ae93949d7644e9"/>
+    <p:sldId xmlns:r="http://schemas.openxmlformats.org/officeDocument/2006/relationships" id="261" r:id="Ra5a371d52e364032"/>
+    <p:sldId xmlns:r="http://schemas.openxmlformats.org/officeDocument/2006/relationships" id="262" r:id="Rff5edafc3ea3404e"/>
+    <p:sldId xmlns:r="http://schemas.openxmlformats.org/officeDocument/2006/relationships" id="263" r:id="R0c568fb10cc3412a"/>
+    <p:sldId xmlns:r="http://schemas.openxmlformats.org/officeDocument/2006/relationships" id="264" r:id="R7facbdac3f2741a3"/>
+    <p:sldId xmlns:r="http://schemas.openxmlformats.org/officeDocument/2006/relationships" id="265" r:id="Rdb09881cc5dc43b8"/>
+    <p:sldId xmlns:r="http://schemas.openxmlformats.org/officeDocument/2006/relationships" id="266" r:id="Rbb977e40b60c44dd"/>
+    <p:sldId xmlns:r="http://schemas.openxmlformats.org/officeDocument/2006/relationships" id="267" r:id="R69a60897d4b04963"/>
   </p:sldIdLst>
   <p:sldSz cx="12192000" cy="6858000"/>
   <p:notesSz cx="6858000" cy="9144000"/>
@@ -1330,7 +1330,7 @@
           <p:cNvPr id="3" name="Title">
             <a:extLst xmlns:a="http://schemas.openxmlformats.org/drawingml/2006/main">
               <a:ext uri="{FF2B5EF4-FFF2-40B4-BE49-F238E27FC236}">
-                <a16:creationId xmlns:a16="http://schemas.microsoft.com/office/drawing/2014/main" id="{3BFC9AAC-1561-48D1-A581-5D82E33D96ED}"/>
+                <a16:creationId xmlns:a16="http://schemas.microsoft.com/office/drawing/2014/main" id="{60ADA930-B081-41BD-9893-D4815E776553}"/>
               </a:ext>
             </a:extLst>
           </p:cNvPr>
@@ -1487,7 +1487,7 @@
           <p:cNvPr id="2" name="Subtitle">
             <a:extLst xmlns:a="http://schemas.openxmlformats.org/drawingml/2006/main">
               <a:ext uri="{FF2B5EF4-FFF2-40B4-BE49-F238E27FC236}">
-                <a16:creationId xmlns:a16="http://schemas.microsoft.com/office/drawing/2014/main" id="{001787C8-7B88-40F9-9B58-B7416E49CE99}"/>
+                <a16:creationId xmlns:a16="http://schemas.microsoft.com/office/drawing/2014/main" id="{6E5F218F-3D2F-45AB-B824-4411C24B35E0}"/>
               </a:ext>
             </a:extLst>
           </p:cNvPr>
@@ -1661,7 +1661,7 @@
           <p:cNvPr id="2" name="Section title">
             <a:extLst xmlns:a="http://schemas.openxmlformats.org/drawingml/2006/main">
               <a:ext uri="{FF2B5EF4-FFF2-40B4-BE49-F238E27FC236}">
-                <a16:creationId xmlns:a16="http://schemas.microsoft.com/office/drawing/2014/main" id="{A7654312-76BF-4D41-957B-330B0A11827E}"/>
+                <a16:creationId xmlns:a16="http://schemas.microsoft.com/office/drawing/2014/main" id="{DE6E504F-4C76-484B-895E-1EF423820C77}"/>
               </a:ext>
             </a:extLst>
           </p:cNvPr>
@@ -1835,7 +1835,7 @@
           <p:cNvPr id="3" name="Title">
             <a:extLst xmlns:a="http://schemas.openxmlformats.org/drawingml/2006/main">
               <a:ext uri="{FF2B5EF4-FFF2-40B4-BE49-F238E27FC236}">
-                <a16:creationId xmlns:a16="http://schemas.microsoft.com/office/drawing/2014/main" id="{03858E46-E507-4FFF-A65C-83ADEC9BA539}"/>
+                <a16:creationId xmlns:a16="http://schemas.microsoft.com/office/drawing/2014/main" id="{9B07B7C7-2DE4-4ADC-AC93-A65FCA9FD84D}"/>
               </a:ext>
             </a:extLst>
           </p:cNvPr>
@@ -1992,7 +1992,7 @@
           <p:cNvPr id="2" name="Body">
             <a:extLst xmlns:a="http://schemas.openxmlformats.org/drawingml/2006/main">
               <a:ext uri="{FF2B5EF4-FFF2-40B4-BE49-F238E27FC236}">
-                <a16:creationId xmlns:a16="http://schemas.microsoft.com/office/drawing/2014/main" id="{DF6EB3F6-5F30-43EA-B59F-1101EBA00717}"/>
+                <a16:creationId xmlns:a16="http://schemas.microsoft.com/office/drawing/2014/main" id="{332DDC91-4219-4AAE-82DA-FF368E013810}"/>
               </a:ext>
             </a:extLst>
           </p:cNvPr>
@@ -2166,7 +2166,7 @@
           <p:cNvPr id="4" name="Title">
             <a:extLst xmlns:a="http://schemas.openxmlformats.org/drawingml/2006/main">
               <a:ext uri="{FF2B5EF4-FFF2-40B4-BE49-F238E27FC236}">
-                <a16:creationId xmlns:a16="http://schemas.microsoft.com/office/drawing/2014/main" id="{63182BE2-BF3E-4622-A6A4-A808B62F8C9C}"/>
+                <a16:creationId xmlns:a16="http://schemas.microsoft.com/office/drawing/2014/main" id="{52903459-FFAA-4D3D-BF2C-D3C63AD73DF4}"/>
               </a:ext>
             </a:extLst>
           </p:cNvPr>
@@ -2323,7 +2323,7 @@
           <p:cNvPr id="2" name="Left column">
             <a:extLst xmlns:a="http://schemas.openxmlformats.org/drawingml/2006/main">
               <a:ext uri="{FF2B5EF4-FFF2-40B4-BE49-F238E27FC236}">
-                <a16:creationId xmlns:a16="http://schemas.microsoft.com/office/drawing/2014/main" id="{7517553F-B773-4EF0-8E97-362A16F53F48}"/>
+                <a16:creationId xmlns:a16="http://schemas.microsoft.com/office/drawing/2014/main" id="{2D964555-62E0-4258-9BB3-3CAB14E858BB}"/>
               </a:ext>
             </a:extLst>
           </p:cNvPr>
@@ -2480,7 +2480,7 @@
           <p:cNvPr id="3" name="Right column">
             <a:extLst xmlns:a="http://schemas.openxmlformats.org/drawingml/2006/main">
               <a:ext uri="{FF2B5EF4-FFF2-40B4-BE49-F238E27FC236}">
-                <a16:creationId xmlns:a16="http://schemas.microsoft.com/office/drawing/2014/main" id="{809FD3E9-5CAA-4DED-B16F-0FAC64B78475}"/>
+                <a16:creationId xmlns:a16="http://schemas.microsoft.com/office/drawing/2014/main" id="{9FD0E0C5-481F-443A-A4E6-FF98D9A600D2}"/>
               </a:ext>
             </a:extLst>
           </p:cNvPr>
@@ -2654,7 +2654,7 @@
           <p:cNvPr id="3" name="Title">
             <a:extLst xmlns:a="http://schemas.openxmlformats.org/drawingml/2006/main">
               <a:ext uri="{FF2B5EF4-FFF2-40B4-BE49-F238E27FC236}">
-                <a16:creationId xmlns:a16="http://schemas.microsoft.com/office/drawing/2014/main" id="{25825205-E687-4C2A-909F-35D41E393F19}"/>
+                <a16:creationId xmlns:a16="http://schemas.microsoft.com/office/drawing/2014/main" id="{5BA4D445-D678-4BF8-8E95-E111AA1F5501}"/>
               </a:ext>
             </a:extLst>
           </p:cNvPr>
@@ -2811,7 +2811,7 @@
           <p:cNvPr id="2" name="Left column">
             <a:extLst xmlns:a="http://schemas.openxmlformats.org/drawingml/2006/main">
               <a:ext uri="{FF2B5EF4-FFF2-40B4-BE49-F238E27FC236}">
-                <a16:creationId xmlns:a16="http://schemas.microsoft.com/office/drawing/2014/main" id="{A1EEB579-6693-4693-935B-32BB3678C51C}"/>
+                <a16:creationId xmlns:a16="http://schemas.microsoft.com/office/drawing/2014/main" id="{07780C1C-D74A-465C-BCED-9B113B3F73F5}"/>
               </a:ext>
             </a:extLst>
           </p:cNvPr>
@@ -3006,12 +3006,12 @@
   </p:cSld>
   <p:clrMap bg1="lt1" tx1="dk1" bg2="lt2" tx2="dk2" accent1="accent1" accent2="accent2" accent3="accent3" accent4="accent4" accent5="accent5" accent6="accent6" hlink="hlink" folHlink="folHlink"/>
   <p:sldLayoutIdLst>
-    <p:sldLayoutId xmlns:r="http://schemas.openxmlformats.org/officeDocument/2006/relationships" id="2147483649" r:id="R4a30619f73cd4f24"/>
-    <p:sldLayoutId xmlns:r="http://schemas.openxmlformats.org/officeDocument/2006/relationships" id="2147483650" r:id="Ref8b01ecf48b414e"/>
-    <p:sldLayoutId xmlns:r="http://schemas.openxmlformats.org/officeDocument/2006/relationships" id="2147483651" r:id="Rf4e9c8fdbe08432b"/>
-    <p:sldLayoutId xmlns:r="http://schemas.openxmlformats.org/officeDocument/2006/relationships" id="2147483652" r:id="Rfe1cabc66ac049a0"/>
-    <p:sldLayoutId xmlns:r="http://schemas.openxmlformats.org/officeDocument/2006/relationships" id="2147483653" r:id="R88a61122cf654789"/>
-    <p:sldLayoutId xmlns:r="http://schemas.openxmlformats.org/officeDocument/2006/relationships" id="2147483654" r:id="R7244b193adaf450d"/>
+    <p:sldLayoutId xmlns:r="http://schemas.openxmlformats.org/officeDocument/2006/relationships" id="2147483649" r:id="Rd108bf04d03a41f1"/>
+    <p:sldLayoutId xmlns:r="http://schemas.openxmlformats.org/officeDocument/2006/relationships" id="2147483650" r:id="R4f828943e62d46e3"/>
+    <p:sldLayoutId xmlns:r="http://schemas.openxmlformats.org/officeDocument/2006/relationships" id="2147483651" r:id="R34fe00d255f44245"/>
+    <p:sldLayoutId xmlns:r="http://schemas.openxmlformats.org/officeDocument/2006/relationships" id="2147483652" r:id="R1241504bb8444e84"/>
+    <p:sldLayoutId xmlns:r="http://schemas.openxmlformats.org/officeDocument/2006/relationships" id="2147483653" r:id="R852b772a3d694685"/>
+    <p:sldLayoutId xmlns:r="http://schemas.openxmlformats.org/officeDocument/2006/relationships" id="2147483654" r:id="Rf6d6b241ce8d45c6"/>
   </p:sldLayoutIdLst>
   <p:txStyles>
     <p:titleStyle>
@@ -3562,7 +3562,7 @@
           <p:cNvPr id="7" name="">
             <a:extLst xmlns:a="http://schemas.openxmlformats.org/drawingml/2006/main">
               <a:ext uri="{FF2B5EF4-FFF2-40B4-BE49-F238E27FC236}">
-                <a16:creationId xmlns:a16="http://schemas.microsoft.com/office/drawing/2014/main" id="{0EAFBAD7-CB6E-4555-8C2D-FE02C151A03D}"/>
+                <a16:creationId xmlns:a16="http://schemas.microsoft.com/office/drawing/2014/main" id="{98CFBAE8-F3FE-4372-B0FF-0B62F5F53998}"/>
               </a:ext>
             </a:extLst>
           </p:cNvPr>
@@ -3628,7 +3628,7 @@
           <p:cNvPr id="2" name="">
             <a:extLst xmlns:a="http://schemas.openxmlformats.org/drawingml/2006/main">
               <a:ext uri="{FF2B5EF4-FFF2-40B4-BE49-F238E27FC236}">
-                <a16:creationId xmlns:a16="http://schemas.microsoft.com/office/drawing/2014/main" id="{C64CC84D-C239-4084-A9D6-551E479F74A4}"/>
+                <a16:creationId xmlns:a16="http://schemas.microsoft.com/office/drawing/2014/main" id="{91A65F73-DEFA-43BA-851F-9172DC7831E7}"/>
               </a:ext>
             </a:extLst>
           </p:cNvPr>
@@ -3694,7 +3694,7 @@
           <p:cNvPr id="3" name="">
             <a:extLst xmlns:a="http://schemas.openxmlformats.org/drawingml/2006/main">
               <a:ext uri="{FF2B5EF4-FFF2-40B4-BE49-F238E27FC236}">
-                <a16:creationId xmlns:a16="http://schemas.microsoft.com/office/drawing/2014/main" id="{820494D5-CB9B-4105-A563-C9C3E6631A2B}"/>
+                <a16:creationId xmlns:a16="http://schemas.microsoft.com/office/drawing/2014/main" id="{4AB9FADF-0843-4F9E-9E93-D41FF37CD273}"/>
               </a:ext>
             </a:extLst>
           </p:cNvPr>
@@ -3760,7 +3760,7 @@
           <p:cNvPr id="4" name="">
             <a:extLst xmlns:a="http://schemas.openxmlformats.org/drawingml/2006/main">
               <a:ext uri="{FF2B5EF4-FFF2-40B4-BE49-F238E27FC236}">
-                <a16:creationId xmlns:a16="http://schemas.microsoft.com/office/drawing/2014/main" id="{63CF31D0-2258-4B13-ABC8-6CB81B31FB97}"/>
+                <a16:creationId xmlns:a16="http://schemas.microsoft.com/office/drawing/2014/main" id="{510FFA6B-9927-4FED-B9A8-8298145C1A18}"/>
               </a:ext>
             </a:extLst>
           </p:cNvPr>
@@ -3849,7 +3849,7 @@
           <p:cNvPr id="5" name="">
             <a:extLst xmlns:a="http://schemas.openxmlformats.org/drawingml/2006/main">
               <a:ext uri="{FF2B5EF4-FFF2-40B4-BE49-F238E27FC236}">
-                <a16:creationId xmlns:a16="http://schemas.microsoft.com/office/drawing/2014/main" id="{3EC56584-5930-4101-B212-DB6A95198308}"/>
+                <a16:creationId xmlns:a16="http://schemas.microsoft.com/office/drawing/2014/main" id="{274C5F61-103F-473B-91EA-75C2230F4CD7}"/>
               </a:ext>
             </a:extLst>
           </p:cNvPr>
@@ -3938,7 +3938,7 @@
           <p:cNvPr id="6" name="">
             <a:extLst xmlns:a="http://schemas.openxmlformats.org/drawingml/2006/main">
               <a:ext uri="{FF2B5EF4-FFF2-40B4-BE49-F238E27FC236}">
-                <a16:creationId xmlns:a16="http://schemas.microsoft.com/office/drawing/2014/main" id="{369D1634-E2C8-4FD0-BD0D-684DB0E73431}"/>
+                <a16:creationId xmlns:a16="http://schemas.microsoft.com/office/drawing/2014/main" id="{0EBFF3A7-7AD7-492E-90F7-614FC5BFF2EB}"/>
               </a:ext>
             </a:extLst>
           </p:cNvPr>
@@ -3948,7 +3948,7 @@
           <p:nvPr/>
         </p:nvPicPr>
         <p:blipFill>
-          <a:blip xmlns:r="http://schemas.openxmlformats.org/officeDocument/2006/relationships" xmlns:a="http://schemas.openxmlformats.org/drawingml/2006/main" r:embed="Ree0cb5f5129e4807"/>
+          <a:blip xmlns:r="http://schemas.openxmlformats.org/officeDocument/2006/relationships" xmlns:a="http://schemas.openxmlformats.org/drawingml/2006/main" r:embed="Rdccb6f79463f43ad"/>
           <a:stretch xmlns:a="http://schemas.openxmlformats.org/drawingml/2006/main"/>
         </p:blipFill>
         <p:spPr>
@@ -3964,7 +3964,7 @@
     </p:spTree>
     <p:extLst>
       <p:ext uri="{BB962C8B-B14F-4D97-AF65-F5344CB8AC3E}">
-        <p14:creationId xmlns:p14="http://schemas.microsoft.com/office/powerpoint/2010/main" val="570566497"/>
+        <p14:creationId xmlns:p14="http://schemas.microsoft.com/office/powerpoint/2010/main" val="1269533284"/>
       </p:ext>
     </p:extLst>
   </p:cSld>
@@ -3995,7 +3995,7 @@
           <p:cNvPr id="9" name="">
             <a:extLst xmlns:a="http://schemas.openxmlformats.org/drawingml/2006/main">
               <a:ext uri="{FF2B5EF4-FFF2-40B4-BE49-F238E27FC236}">
-                <a16:creationId xmlns:a16="http://schemas.microsoft.com/office/drawing/2014/main" id="{507E0482-B38B-47BC-94EC-943C3BF19E48}"/>
+                <a16:creationId xmlns:a16="http://schemas.microsoft.com/office/drawing/2014/main" id="{2C6CDE40-614F-4EC3-90DF-6FFE00E39C33}"/>
               </a:ext>
             </a:extLst>
           </p:cNvPr>
@@ -4061,7 +4061,7 @@
           <p:cNvPr id="2" name="">
             <a:extLst xmlns:a="http://schemas.openxmlformats.org/drawingml/2006/main">
               <a:ext uri="{FF2B5EF4-FFF2-40B4-BE49-F238E27FC236}">
-                <a16:creationId xmlns:a16="http://schemas.microsoft.com/office/drawing/2014/main" id="{477758DE-D24F-4637-89BC-375D2563FCC0}"/>
+                <a16:creationId xmlns:a16="http://schemas.microsoft.com/office/drawing/2014/main" id="{3C31F8FB-8047-4238-905A-4D2304242413}"/>
               </a:ext>
             </a:extLst>
           </p:cNvPr>
@@ -4127,7 +4127,7 @@
           <p:cNvPr id="3" name="">
             <a:extLst xmlns:a="http://schemas.openxmlformats.org/drawingml/2006/main">
               <a:ext uri="{FF2B5EF4-FFF2-40B4-BE49-F238E27FC236}">
-                <a16:creationId xmlns:a16="http://schemas.microsoft.com/office/drawing/2014/main" id="{18C99DE9-80DA-4AE7-9BC2-882EC6627C16}"/>
+                <a16:creationId xmlns:a16="http://schemas.microsoft.com/office/drawing/2014/main" id="{77855A68-41E3-479C-B8E0-EC6FD35E0D60}"/>
               </a:ext>
             </a:extLst>
           </p:cNvPr>
@@ -4193,7 +4193,7 @@
           <p:cNvPr id="4" name="">
             <a:extLst xmlns:a="http://schemas.openxmlformats.org/drawingml/2006/main">
               <a:ext uri="{FF2B5EF4-FFF2-40B4-BE49-F238E27FC236}">
-                <a16:creationId xmlns:a16="http://schemas.microsoft.com/office/drawing/2014/main" id="{5FB60625-BF22-4788-A886-65719C5720E2}"/>
+                <a16:creationId xmlns:a16="http://schemas.microsoft.com/office/drawing/2014/main" id="{262CBCFD-E4E4-4F9B-9D5B-6D6C1E061646}"/>
               </a:ext>
             </a:extLst>
           </p:cNvPr>
@@ -4259,7 +4259,7 @@
           <p:cNvPr id="5" name="">
             <a:extLst xmlns:a="http://schemas.openxmlformats.org/drawingml/2006/main">
               <a:ext uri="{FF2B5EF4-FFF2-40B4-BE49-F238E27FC236}">
-                <a16:creationId xmlns:a16="http://schemas.microsoft.com/office/drawing/2014/main" id="{75EF23D1-E751-4892-BF17-2216A0B7A1BF}"/>
+                <a16:creationId xmlns:a16="http://schemas.microsoft.com/office/drawing/2014/main" id="{F7DE409E-EFE5-4256-9E70-3BC4AF0BC3C4}"/>
               </a:ext>
             </a:extLst>
           </p:cNvPr>
@@ -4417,7 +4417,7 @@
           <p:cNvPr id="6" name="">
             <a:extLst xmlns:a="http://schemas.openxmlformats.org/drawingml/2006/main">
               <a:ext uri="{FF2B5EF4-FFF2-40B4-BE49-F238E27FC236}">
-                <a16:creationId xmlns:a16="http://schemas.microsoft.com/office/drawing/2014/main" id="{B6570884-1388-45DF-9B99-AAB279F720E4}"/>
+                <a16:creationId xmlns:a16="http://schemas.microsoft.com/office/drawing/2014/main" id="{2F9DE9E2-3C92-4BC0-81E2-64BF33B6D1B5}"/>
               </a:ext>
             </a:extLst>
           </p:cNvPr>
@@ -4483,7 +4483,7 @@
           <p:cNvPr id="7" name="">
             <a:extLst xmlns:a="http://schemas.openxmlformats.org/drawingml/2006/main">
               <a:ext uri="{FF2B5EF4-FFF2-40B4-BE49-F238E27FC236}">
-                <a16:creationId xmlns:a16="http://schemas.microsoft.com/office/drawing/2014/main" id="{1D4AAAB6-C202-4058-BED9-B9098FCE70FF}"/>
+                <a16:creationId xmlns:a16="http://schemas.microsoft.com/office/drawing/2014/main" id="{56BD1309-1E10-4104-A579-302FD76EA219}"/>
               </a:ext>
             </a:extLst>
           </p:cNvPr>
@@ -4641,7 +4641,7 @@
           <p:cNvPr id="8" name="">
             <a:extLst xmlns:a="http://schemas.openxmlformats.org/drawingml/2006/main">
               <a:ext uri="{FF2B5EF4-FFF2-40B4-BE49-F238E27FC236}">
-                <a16:creationId xmlns:a16="http://schemas.microsoft.com/office/drawing/2014/main" id="{DB36F4FC-D805-4688-86F0-15F525C66C1B}"/>
+                <a16:creationId xmlns:a16="http://schemas.microsoft.com/office/drawing/2014/main" id="{2D068FD5-3F63-4493-AEFB-71EE0D41BE5D}"/>
               </a:ext>
             </a:extLst>
           </p:cNvPr>
@@ -4705,7 +4705,7 @@
     </p:spTree>
     <p:extLst>
       <p:ext uri="{BB962C8B-B14F-4D97-AF65-F5344CB8AC3E}">
-        <p14:creationId xmlns:p14="http://schemas.microsoft.com/office/powerpoint/2010/main" val="1741819228"/>
+        <p14:creationId xmlns:p14="http://schemas.microsoft.com/office/powerpoint/2010/main" val="505149302"/>
       </p:ext>
     </p:extLst>
   </p:cSld>
@@ -4736,7 +4736,7 @@
           <p:cNvPr id="11" name="">
             <a:extLst xmlns:a="http://schemas.openxmlformats.org/drawingml/2006/main">
               <a:ext uri="{FF2B5EF4-FFF2-40B4-BE49-F238E27FC236}">
-                <a16:creationId xmlns:a16="http://schemas.microsoft.com/office/drawing/2014/main" id="{CC316558-F3C9-490A-B28E-CF71626952B1}"/>
+                <a16:creationId xmlns:a16="http://schemas.microsoft.com/office/drawing/2014/main" id="{00CD6AA5-FFDE-49AC-B550-1C71E2524E01}"/>
               </a:ext>
             </a:extLst>
           </p:cNvPr>
@@ -4762,29 +4762,29 @@
           <a:bodyPr xmlns:a="http://schemas.openxmlformats.org/drawingml/2006/main"/>
           <a:lstStyle xmlns:a="http://schemas.openxmlformats.org/drawingml/2006/main">
             <a:defPPr>
-              <a:defRPr sz="3300" b="1">
-                <a:solidFill>
-                  <a:srgbClr val="08243D"/>
-                </a:solidFill>
-                <a:latin typeface="Arial"/>
-                <a:ea typeface="Arial"/>
-                <a:cs typeface="Arial"/>
-              </a:defRPr>
-            </a:defPPr>
-          </a:lstStyle>
-          <a:p xmlns:a="http://schemas.openxmlformats.org/drawingml/2006/main">
-            <a:pPr>
-              <a:defRPr sz="3300" b="1">
-                <a:solidFill>
-                  <a:srgbClr val="08243D"/>
-                </a:solidFill>
-                <a:latin typeface="Arial"/>
-                <a:ea typeface="Arial"/>
-                <a:cs typeface="Arial"/>
-              </a:defRPr>
-            </a:pPr>
-            <a:r>
-              <a:rPr sz="3300" b="1">
+              <a:defRPr sz="3300" b="1" noProof="1" dirty="0" err="0">
+                <a:solidFill>
+                  <a:srgbClr val="08243D"/>
+                </a:solidFill>
+                <a:latin typeface="Arial"/>
+                <a:ea typeface="Arial"/>
+                <a:cs typeface="Arial"/>
+              </a:defRPr>
+            </a:defPPr>
+          </a:lstStyle>
+          <a:p xmlns:a="http://schemas.openxmlformats.org/drawingml/2006/main">
+            <a:pPr>
+              <a:defRPr sz="3300" b="1" noProof="1" dirty="0" err="0">
+                <a:solidFill>
+                  <a:srgbClr val="08243D"/>
+                </a:solidFill>
+                <a:latin typeface="Arial"/>
+                <a:ea typeface="Arial"/>
+                <a:cs typeface="Arial"/>
+              </a:defRPr>
+            </a:pPr>
+            <a:r>
+              <a:rPr sz="3300" b="1" noProof="1" dirty="0" err="0">
                 <a:solidFill>
                   <a:srgbClr val="08243D"/>
                 </a:solidFill>
@@ -4802,7 +4802,7 @@
           <p:cNvPr id="2" name="">
             <a:extLst xmlns:a="http://schemas.openxmlformats.org/drawingml/2006/main">
               <a:ext uri="{FF2B5EF4-FFF2-40B4-BE49-F238E27FC236}">
-                <a16:creationId xmlns:a16="http://schemas.microsoft.com/office/drawing/2014/main" id="{24E2C912-2CBD-4D09-B932-E696099C8774}"/>
+                <a16:creationId xmlns:a16="http://schemas.microsoft.com/office/drawing/2014/main" id="{8688C64F-A42C-449E-B2E2-3132E16FCDC8}"/>
               </a:ext>
             </a:extLst>
           </p:cNvPr>
@@ -4828,7 +4828,7 @@
           <a:bodyPr xmlns:a="http://schemas.openxmlformats.org/drawingml/2006/main"/>
           <a:lstStyle xmlns:a="http://schemas.openxmlformats.org/drawingml/2006/main">
             <a:defPPr>
-              <a:defRPr sz="1350" b="1">
+              <a:defRPr sz="1350" b="1" noProof="1" dirty="0" err="0">
                 <a:solidFill>
                   <a:srgbClr val="14835F"/>
                 </a:solidFill>
@@ -4840,7 +4840,7 @@
           </a:lstStyle>
           <a:p xmlns:a="http://schemas.openxmlformats.org/drawingml/2006/main">
             <a:pPr>
-              <a:defRPr sz="1350" b="1">
+              <a:defRPr sz="1350" b="1" noProof="1" dirty="0" err="0">
                 <a:solidFill>
                   <a:srgbClr val="14835F"/>
                 </a:solidFill>
@@ -4850,7 +4850,7 @@
               </a:defRPr>
             </a:pPr>
             <a:r>
-              <a:rPr sz="1350" b="1">
+              <a:rPr sz="1350" b="1" noProof="1" dirty="0" err="0">
                 <a:solidFill>
                   <a:srgbClr val="14835F"/>
                 </a:solidFill>
@@ -4868,7 +4868,7 @@
           <p:cNvPr id="3" name="">
             <a:extLst xmlns:a="http://schemas.openxmlformats.org/drawingml/2006/main">
               <a:ext uri="{FF2B5EF4-FFF2-40B4-BE49-F238E27FC236}">
-                <a16:creationId xmlns:a16="http://schemas.microsoft.com/office/drawing/2014/main" id="{39CD9BF1-28E6-45F9-98C0-462D2E1042FD}"/>
+                <a16:creationId xmlns:a16="http://schemas.microsoft.com/office/drawing/2014/main" id="{AD687B94-6C73-4176-8D98-50DE3FFCFA70}"/>
               </a:ext>
             </a:extLst>
           </p:cNvPr>
@@ -4894,7 +4894,7 @@
           <a:bodyPr xmlns:a="http://schemas.openxmlformats.org/drawingml/2006/main"/>
           <a:lstStyle xmlns:a="http://schemas.openxmlformats.org/drawingml/2006/main">
             <a:defPPr>
-              <a:defRPr sz="1350" b="0">
+              <a:defRPr sz="1350" b="0" noProof="1" dirty="0" err="0">
                 <a:solidFill>
                   <a:srgbClr val="536675"/>
                 </a:solidFill>
@@ -4906,7 +4906,7 @@
           </a:lstStyle>
           <a:p xmlns:a="http://schemas.openxmlformats.org/drawingml/2006/main">
             <a:pPr>
-              <a:defRPr sz="1350" b="0">
+              <a:defRPr sz="1350" b="0" noProof="1" dirty="0" err="0">
                 <a:solidFill>
                   <a:srgbClr val="536675"/>
                 </a:solidFill>
@@ -4916,7 +4916,7 @@
               </a:defRPr>
             </a:pPr>
             <a:r>
-              <a:rPr sz="1350" b="0">
+              <a:rPr sz="1350" b="0" noProof="1" dirty="0" err="0">
                 <a:solidFill>
                   <a:srgbClr val="536675"/>
                 </a:solidFill>
@@ -4934,7 +4934,7 @@
           <p:cNvPr id="4" name="">
             <a:extLst xmlns:a="http://schemas.openxmlformats.org/drawingml/2006/main">
               <a:ext uri="{FF2B5EF4-FFF2-40B4-BE49-F238E27FC236}">
-                <a16:creationId xmlns:a16="http://schemas.microsoft.com/office/drawing/2014/main" id="{EB5FA4AF-E251-48E4-94D5-4C2E265AE995}"/>
+                <a16:creationId xmlns:a16="http://schemas.microsoft.com/office/drawing/2014/main" id="{B0C2B8C7-73A1-4AAA-99A8-DB6A00B2574F}"/>
               </a:ext>
             </a:extLst>
           </p:cNvPr>
@@ -4960,7 +4960,7 @@
           <a:bodyPr xmlns:a="http://schemas.openxmlformats.org/drawingml/2006/main"/>
           <a:lstStyle xmlns:a="http://schemas.openxmlformats.org/drawingml/2006/main">
             <a:defPPr>
-              <a:defRPr sz="2400" b="1">
+              <a:defRPr sz="2400" b="1" noProof="1" dirty="0" err="0">
                 <a:solidFill>
                   <a:srgbClr val="14835F"/>
                 </a:solidFill>
@@ -4972,7 +4972,7 @@
           </a:lstStyle>
           <a:p xmlns:a="http://schemas.openxmlformats.org/drawingml/2006/main">
             <a:pPr>
-              <a:defRPr sz="2400" b="1">
+              <a:defRPr sz="2400" b="1" noProof="1" dirty="0" err="0">
                 <a:solidFill>
                   <a:srgbClr val="14835F"/>
                 </a:solidFill>
@@ -4982,7 +4982,7 @@
               </a:defRPr>
             </a:pPr>
             <a:r>
-              <a:rPr sz="2400" b="1">
+              <a:rPr sz="2400" b="1" noProof="1" dirty="0" err="0">
                 <a:solidFill>
                   <a:srgbClr val="14835F"/>
                 </a:solidFill>
@@ -5000,7 +5000,7 @@
           <p:cNvPr id="5" name="">
             <a:extLst xmlns:a="http://schemas.openxmlformats.org/drawingml/2006/main">
               <a:ext uri="{FF2B5EF4-FFF2-40B4-BE49-F238E27FC236}">
-                <a16:creationId xmlns:a16="http://schemas.microsoft.com/office/drawing/2014/main" id="{204AE57E-F5B5-407B-AD71-0A1EEDDE5196}"/>
+                <a16:creationId xmlns:a16="http://schemas.microsoft.com/office/drawing/2014/main" id="{7C835B2E-93AC-4CDF-8AE9-54D4BAF14D4B}"/>
               </a:ext>
             </a:extLst>
           </p:cNvPr>
@@ -5026,29 +5026,29 @@
           <a:bodyPr xmlns:a="http://schemas.openxmlformats.org/drawingml/2006/main"/>
           <a:lstStyle xmlns:a="http://schemas.openxmlformats.org/drawingml/2006/main">
             <a:defPPr>
-              <a:defRPr sz="2100" b="0">
-                <a:solidFill>
-                  <a:srgbClr val="08243D"/>
-                </a:solidFill>
-                <a:latin typeface="Arial"/>
-                <a:ea typeface="Arial"/>
-                <a:cs typeface="Arial"/>
-              </a:defRPr>
-            </a:defPPr>
-          </a:lstStyle>
-          <a:p xmlns:a="http://schemas.openxmlformats.org/drawingml/2006/main">
-            <a:pPr>
-              <a:defRPr sz="2100" b="0">
-                <a:solidFill>
-                  <a:srgbClr val="08243D"/>
-                </a:solidFill>
-                <a:latin typeface="Arial"/>
-                <a:ea typeface="Arial"/>
-                <a:cs typeface="Arial"/>
-              </a:defRPr>
-            </a:pPr>
-            <a:r>
-              <a:rPr sz="2100" b="0">
+              <a:defRPr sz="2100" b="0" noProof="1" dirty="0" err="0">
+                <a:solidFill>
+                  <a:srgbClr val="08243D"/>
+                </a:solidFill>
+                <a:latin typeface="Arial"/>
+                <a:ea typeface="Arial"/>
+                <a:cs typeface="Arial"/>
+              </a:defRPr>
+            </a:defPPr>
+          </a:lstStyle>
+          <a:p xmlns:a="http://schemas.openxmlformats.org/drawingml/2006/main">
+            <a:pPr>
+              <a:defRPr sz="2100" b="0" noProof="1" dirty="0" err="0">
+                <a:solidFill>
+                  <a:srgbClr val="08243D"/>
+                </a:solidFill>
+                <a:latin typeface="Arial"/>
+                <a:ea typeface="Arial"/>
+                <a:cs typeface="Arial"/>
+              </a:defRPr>
+            </a:pPr>
+            <a:r>
+              <a:rPr sz="2100" b="0" noProof="1" dirty="0" err="0">
                 <a:solidFill>
                   <a:srgbClr val="08243D"/>
                 </a:solidFill>
@@ -5061,17 +5061,17 @@
           </a:p>
           <a:p xmlns:a="http://schemas.openxmlformats.org/drawingml/2006/main">
             <a:pPr>
-              <a:defRPr sz="2100" b="0">
-                <a:solidFill>
-                  <a:srgbClr val="08243D"/>
-                </a:solidFill>
-                <a:latin typeface="Arial"/>
-                <a:ea typeface="Arial"/>
-                <a:cs typeface="Arial"/>
-              </a:defRPr>
-            </a:pPr>
-            <a:r>
-              <a:rPr sz="2100" b="0">
+              <a:defRPr sz="2100" b="0" noProof="1" dirty="0" err="0">
+                <a:solidFill>
+                  <a:srgbClr val="08243D"/>
+                </a:solidFill>
+                <a:latin typeface="Arial"/>
+                <a:ea typeface="Arial"/>
+                <a:cs typeface="Arial"/>
+              </a:defRPr>
+            </a:pPr>
+            <a:r>
+              <a:rPr sz="2100" b="0" noProof="1" dirty="0" err="0">
                 <a:solidFill>
                   <a:srgbClr val="08243D"/>
                 </a:solidFill>
@@ -5084,22 +5084,23 @@
           </a:p>
           <a:p xmlns:a="http://schemas.openxmlformats.org/drawingml/2006/main">
             <a:r>
+              <a:rPr noProof="1" dirty="0" err="0"/>
               <a:t/>
             </a:r>
           </a:p>
           <a:p xmlns:a="http://schemas.openxmlformats.org/drawingml/2006/main">
             <a:pPr>
-              <a:defRPr sz="2100" b="0">
-                <a:solidFill>
-                  <a:srgbClr val="08243D"/>
-                </a:solidFill>
-                <a:latin typeface="Arial"/>
-                <a:ea typeface="Arial"/>
-                <a:cs typeface="Arial"/>
-              </a:defRPr>
-            </a:pPr>
-            <a:r>
-              <a:rPr sz="2100" b="0">
+              <a:defRPr sz="2100" b="0" noProof="1" dirty="0" err="0">
+                <a:solidFill>
+                  <a:srgbClr val="08243D"/>
+                </a:solidFill>
+                <a:latin typeface="Arial"/>
+                <a:ea typeface="Arial"/>
+                <a:cs typeface="Arial"/>
+              </a:defRPr>
+            </a:pPr>
+            <a:r>
+              <a:rPr sz="2100" b="0" noProof="1" dirty="0" err="0">
                 <a:solidFill>
                   <a:srgbClr val="08243D"/>
                 </a:solidFill>
@@ -5112,17 +5113,17 @@
           </a:p>
           <a:p xmlns:a="http://schemas.openxmlformats.org/drawingml/2006/main">
             <a:pPr>
-              <a:defRPr sz="2100" b="0">
-                <a:solidFill>
-                  <a:srgbClr val="08243D"/>
-                </a:solidFill>
-                <a:latin typeface="Arial"/>
-                <a:ea typeface="Arial"/>
-                <a:cs typeface="Arial"/>
-              </a:defRPr>
-            </a:pPr>
-            <a:r>
-              <a:rPr sz="2100" b="0">
+              <a:defRPr sz="2100" b="0" noProof="1" dirty="0" err="0">
+                <a:solidFill>
+                  <a:srgbClr val="08243D"/>
+                </a:solidFill>
+                <a:latin typeface="Arial"/>
+                <a:ea typeface="Arial"/>
+                <a:cs typeface="Arial"/>
+              </a:defRPr>
+            </a:pPr>
+            <a:r>
+              <a:rPr sz="2100" b="0" noProof="1" dirty="0" err="0">
                 <a:solidFill>
                   <a:srgbClr val="08243D"/>
                 </a:solidFill>
@@ -5140,7 +5141,7 @@
           <p:cNvPr id="6" name="">
             <a:extLst xmlns:a="http://schemas.openxmlformats.org/drawingml/2006/main">
               <a:ext uri="{FF2B5EF4-FFF2-40B4-BE49-F238E27FC236}">
-                <a16:creationId xmlns:a16="http://schemas.microsoft.com/office/drawing/2014/main" id="{62416C30-FDD4-4CC8-981F-682781C829C0}"/>
+                <a16:creationId xmlns:a16="http://schemas.microsoft.com/office/drawing/2014/main" id="{92BE244D-4D76-47BB-BA71-F86D41A8A051}"/>
               </a:ext>
             </a:extLst>
           </p:cNvPr>
@@ -5166,29 +5167,29 @@
           <a:bodyPr xmlns:a="http://schemas.openxmlformats.org/drawingml/2006/main"/>
           <a:lstStyle xmlns:a="http://schemas.openxmlformats.org/drawingml/2006/main">
             <a:defPPr>
-              <a:defRPr sz="2100" b="0">
-                <a:solidFill>
-                  <a:srgbClr val="08243D"/>
-                </a:solidFill>
-                <a:latin typeface="Arial"/>
-                <a:ea typeface="Arial"/>
-                <a:cs typeface="Arial"/>
-              </a:defRPr>
-            </a:defPPr>
-          </a:lstStyle>
-          <a:p xmlns:a="http://schemas.openxmlformats.org/drawingml/2006/main">
-            <a:pPr>
-              <a:defRPr sz="2100" b="0">
-                <a:solidFill>
-                  <a:srgbClr val="08243D"/>
-                </a:solidFill>
-                <a:latin typeface="Arial"/>
-                <a:ea typeface="Arial"/>
-                <a:cs typeface="Arial"/>
-              </a:defRPr>
-            </a:pPr>
-            <a:r>
-              <a:rPr sz="2100" b="0">
+              <a:defRPr sz="2100" b="0" noProof="1" dirty="0" err="0">
+                <a:solidFill>
+                  <a:srgbClr val="08243D"/>
+                </a:solidFill>
+                <a:latin typeface="Arial"/>
+                <a:ea typeface="Arial"/>
+                <a:cs typeface="Arial"/>
+              </a:defRPr>
+            </a:defPPr>
+          </a:lstStyle>
+          <a:p xmlns:a="http://schemas.openxmlformats.org/drawingml/2006/main">
+            <a:pPr>
+              <a:defRPr sz="2100" b="0" noProof="1" dirty="0" err="0">
+                <a:solidFill>
+                  <a:srgbClr val="08243D"/>
+                </a:solidFill>
+                <a:latin typeface="Arial"/>
+                <a:ea typeface="Arial"/>
+                <a:cs typeface="Arial"/>
+              </a:defRPr>
+            </a:pPr>
+            <a:r>
+              <a:rPr sz="2100" b="0" noProof="1" dirty="0" err="0">
                 <a:solidFill>
                   <a:srgbClr val="08243D"/>
                 </a:solidFill>
@@ -5201,17 +5202,17 @@
           </a:p>
           <a:p xmlns:a="http://schemas.openxmlformats.org/drawingml/2006/main">
             <a:pPr>
-              <a:defRPr sz="2100" b="0">
-                <a:solidFill>
-                  <a:srgbClr val="08243D"/>
-                </a:solidFill>
-                <a:latin typeface="Arial"/>
-                <a:ea typeface="Arial"/>
-                <a:cs typeface="Arial"/>
-              </a:defRPr>
-            </a:pPr>
-            <a:r>
-              <a:rPr sz="2100" b="0">
+              <a:defRPr sz="2100" b="0" noProof="1" dirty="0" err="0">
+                <a:solidFill>
+                  <a:srgbClr val="08243D"/>
+                </a:solidFill>
+                <a:latin typeface="Arial"/>
+                <a:ea typeface="Arial"/>
+                <a:cs typeface="Arial"/>
+              </a:defRPr>
+            </a:pPr>
+            <a:r>
+              <a:rPr sz="2100" b="0" noProof="1" dirty="0" err="0">
                 <a:solidFill>
                   <a:srgbClr val="08243D"/>
                 </a:solidFill>
@@ -5224,22 +5225,23 @@
           </a:p>
           <a:p xmlns:a="http://schemas.openxmlformats.org/drawingml/2006/main">
             <a:r>
+              <a:rPr noProof="1" dirty="0" err="0"/>
               <a:t/>
             </a:r>
           </a:p>
           <a:p xmlns:a="http://schemas.openxmlformats.org/drawingml/2006/main">
             <a:pPr>
-              <a:defRPr sz="2100" b="0">
-                <a:solidFill>
-                  <a:srgbClr val="08243D"/>
-                </a:solidFill>
-                <a:latin typeface="Arial"/>
-                <a:ea typeface="Arial"/>
-                <a:cs typeface="Arial"/>
-              </a:defRPr>
-            </a:pPr>
-            <a:r>
-              <a:rPr sz="2100" b="0">
+              <a:defRPr sz="2100" b="0" noProof="1" dirty="0" err="0">
+                <a:solidFill>
+                  <a:srgbClr val="08243D"/>
+                </a:solidFill>
+                <a:latin typeface="Arial"/>
+                <a:ea typeface="Arial"/>
+                <a:cs typeface="Arial"/>
+              </a:defRPr>
+            </a:pPr>
+            <a:r>
+              <a:rPr sz="2100" b="0" noProof="1" dirty="0" err="0">
                 <a:solidFill>
                   <a:srgbClr val="08243D"/>
                 </a:solidFill>
@@ -5252,17 +5254,17 @@
           </a:p>
           <a:p xmlns:a="http://schemas.openxmlformats.org/drawingml/2006/main">
             <a:pPr>
-              <a:defRPr sz="2100" b="0">
-                <a:solidFill>
-                  <a:srgbClr val="08243D"/>
-                </a:solidFill>
-                <a:latin typeface="Arial"/>
-                <a:ea typeface="Arial"/>
-                <a:cs typeface="Arial"/>
-              </a:defRPr>
-            </a:pPr>
-            <a:r>
-              <a:rPr sz="2100" b="0">
+              <a:defRPr sz="2100" b="0" noProof="1" dirty="0" err="0">
+                <a:solidFill>
+                  <a:srgbClr val="08243D"/>
+                </a:solidFill>
+                <a:latin typeface="Arial"/>
+                <a:ea typeface="Arial"/>
+                <a:cs typeface="Arial"/>
+              </a:defRPr>
+            </a:pPr>
+            <a:r>
+              <a:rPr sz="2100" b="0" noProof="1" dirty="0" err="0">
                 <a:solidFill>
                   <a:srgbClr val="08243D"/>
                 </a:solidFill>
@@ -5280,7 +5282,7 @@
           <p:cNvPr id="7" name="">
             <a:extLst xmlns:a="http://schemas.openxmlformats.org/drawingml/2006/main">
               <a:ext uri="{FF2B5EF4-FFF2-40B4-BE49-F238E27FC236}">
-                <a16:creationId xmlns:a16="http://schemas.microsoft.com/office/drawing/2014/main" id="{4669634D-C64A-40F7-9B1B-29CBB15C0D1E}"/>
+                <a16:creationId xmlns:a16="http://schemas.microsoft.com/office/drawing/2014/main" id="{FE4AB9F7-C120-479A-B6BB-3F7851AB7C8D}"/>
               </a:ext>
             </a:extLst>
           </p:cNvPr>
@@ -5306,29 +5308,29 @@
           <a:bodyPr xmlns:a="http://schemas.openxmlformats.org/drawingml/2006/main"/>
           <a:lstStyle xmlns:a="http://schemas.openxmlformats.org/drawingml/2006/main">
             <a:defPPr>
-              <a:defRPr sz="2100" b="0">
-                <a:solidFill>
-                  <a:srgbClr val="08243D"/>
-                </a:solidFill>
-                <a:latin typeface="Arial"/>
-                <a:ea typeface="Arial"/>
-                <a:cs typeface="Arial"/>
-              </a:defRPr>
-            </a:defPPr>
-          </a:lstStyle>
-          <a:p xmlns:a="http://schemas.openxmlformats.org/drawingml/2006/main">
-            <a:pPr>
-              <a:defRPr sz="2100" b="0">
-                <a:solidFill>
-                  <a:srgbClr val="08243D"/>
-                </a:solidFill>
-                <a:latin typeface="Arial"/>
-                <a:ea typeface="Arial"/>
-                <a:cs typeface="Arial"/>
-              </a:defRPr>
-            </a:pPr>
-            <a:r>
-              <a:rPr sz="2100" b="0">
+              <a:defRPr sz="2100" b="0" noProof="1" dirty="0" err="0">
+                <a:solidFill>
+                  <a:srgbClr val="08243D"/>
+                </a:solidFill>
+                <a:latin typeface="Arial"/>
+                <a:ea typeface="Arial"/>
+                <a:cs typeface="Arial"/>
+              </a:defRPr>
+            </a:defPPr>
+          </a:lstStyle>
+          <a:p xmlns:a="http://schemas.openxmlformats.org/drawingml/2006/main">
+            <a:pPr>
+              <a:defRPr sz="2100" b="0" noProof="1" dirty="0" err="0">
+                <a:solidFill>
+                  <a:srgbClr val="08243D"/>
+                </a:solidFill>
+                <a:latin typeface="Arial"/>
+                <a:ea typeface="Arial"/>
+                <a:cs typeface="Arial"/>
+              </a:defRPr>
+            </a:pPr>
+            <a:r>
+              <a:rPr sz="2100" b="0" noProof="1" dirty="0" err="0">
                 <a:solidFill>
                   <a:srgbClr val="08243D"/>
                 </a:solidFill>
@@ -5346,7 +5348,7 @@
           <p:cNvPr id="8" name="">
             <a:extLst xmlns:a="http://schemas.openxmlformats.org/drawingml/2006/main">
               <a:ext uri="{FF2B5EF4-FFF2-40B4-BE49-F238E27FC236}">
-                <a16:creationId xmlns:a16="http://schemas.microsoft.com/office/drawing/2014/main" id="{47F03647-2393-41B7-B194-5C6149A0C9A5}"/>
+                <a16:creationId xmlns:a16="http://schemas.microsoft.com/office/drawing/2014/main" id="{037E4244-65BC-423C-87BD-D6CDB1940C49}"/>
               </a:ext>
             </a:extLst>
           </p:cNvPr>
@@ -5372,29 +5374,29 @@
           <a:bodyPr xmlns:a="http://schemas.openxmlformats.org/drawingml/2006/main"/>
           <a:lstStyle xmlns:a="http://schemas.openxmlformats.org/drawingml/2006/main">
             <a:defPPr>
-              <a:defRPr sz="2100" b="0">
-                <a:solidFill>
-                  <a:srgbClr val="08243D"/>
-                </a:solidFill>
-                <a:latin typeface="Arial"/>
-                <a:ea typeface="Arial"/>
-                <a:cs typeface="Arial"/>
-              </a:defRPr>
-            </a:defPPr>
-          </a:lstStyle>
-          <a:p xmlns:a="http://schemas.openxmlformats.org/drawingml/2006/main">
-            <a:pPr>
-              <a:defRPr sz="2100" b="0">
-                <a:solidFill>
-                  <a:srgbClr val="08243D"/>
-                </a:solidFill>
-                <a:latin typeface="Arial"/>
-                <a:ea typeface="Arial"/>
-                <a:cs typeface="Arial"/>
-              </a:defRPr>
-            </a:pPr>
-            <a:r>
-              <a:rPr sz="2100" b="0">
+              <a:defRPr sz="2100" b="0" noProof="1" dirty="0" err="0">
+                <a:solidFill>
+                  <a:srgbClr val="08243D"/>
+                </a:solidFill>
+                <a:latin typeface="Arial"/>
+                <a:ea typeface="Arial"/>
+                <a:cs typeface="Arial"/>
+              </a:defRPr>
+            </a:defPPr>
+          </a:lstStyle>
+          <a:p xmlns:a="http://schemas.openxmlformats.org/drawingml/2006/main">
+            <a:pPr>
+              <a:defRPr sz="2100" b="0" noProof="1" dirty="0" err="0">
+                <a:solidFill>
+                  <a:srgbClr val="08243D"/>
+                </a:solidFill>
+                <a:latin typeface="Arial"/>
+                <a:ea typeface="Arial"/>
+                <a:cs typeface="Arial"/>
+              </a:defRPr>
+            </a:pPr>
+            <a:r>
+              <a:rPr sz="2100" b="0" noProof="1" dirty="0" err="0">
                 <a:solidFill>
                   <a:srgbClr val="08243D"/>
                 </a:solidFill>
@@ -5412,7 +5414,7 @@
           <p:cNvPr id="9" name="">
             <a:extLst xmlns:a="http://schemas.openxmlformats.org/drawingml/2006/main">
               <a:ext uri="{FF2B5EF4-FFF2-40B4-BE49-F238E27FC236}">
-                <a16:creationId xmlns:a16="http://schemas.microsoft.com/office/drawing/2014/main" id="{26246265-EF9D-4D3E-9A9D-EACAE27D75D2}"/>
+                <a16:creationId xmlns:a16="http://schemas.microsoft.com/office/drawing/2014/main" id="{D488182E-0845-4DFB-AB6A-D76DB1186C85}"/>
               </a:ext>
             </a:extLst>
           </p:cNvPr>
@@ -5438,29 +5440,29 @@
           <a:bodyPr xmlns:a="http://schemas.openxmlformats.org/drawingml/2006/main"/>
           <a:lstStyle xmlns:a="http://schemas.openxmlformats.org/drawingml/2006/main">
             <a:defPPr>
-              <a:defRPr sz="2100" b="0">
-                <a:solidFill>
-                  <a:srgbClr val="08243D"/>
-                </a:solidFill>
-                <a:latin typeface="Arial"/>
-                <a:ea typeface="Arial"/>
-                <a:cs typeface="Arial"/>
-              </a:defRPr>
-            </a:defPPr>
-          </a:lstStyle>
-          <a:p xmlns:a="http://schemas.openxmlformats.org/drawingml/2006/main">
-            <a:pPr>
-              <a:defRPr sz="2100" b="0">
-                <a:solidFill>
-                  <a:srgbClr val="08243D"/>
-                </a:solidFill>
-                <a:latin typeface="Arial"/>
-                <a:ea typeface="Arial"/>
-                <a:cs typeface="Arial"/>
-              </a:defRPr>
-            </a:pPr>
-            <a:r>
-              <a:rPr sz="2100" b="0">
+              <a:defRPr sz="2100" b="0" noProof="1" dirty="0" err="0">
+                <a:solidFill>
+                  <a:srgbClr val="08243D"/>
+                </a:solidFill>
+                <a:latin typeface="Arial"/>
+                <a:ea typeface="Arial"/>
+                <a:cs typeface="Arial"/>
+              </a:defRPr>
+            </a:defPPr>
+          </a:lstStyle>
+          <a:p xmlns:a="http://schemas.openxmlformats.org/drawingml/2006/main">
+            <a:pPr>
+              <a:defRPr sz="2100" b="0" noProof="1" dirty="0" err="0">
+                <a:solidFill>
+                  <a:srgbClr val="08243D"/>
+                </a:solidFill>
+                <a:latin typeface="Arial"/>
+                <a:ea typeface="Arial"/>
+                <a:cs typeface="Arial"/>
+              </a:defRPr>
+            </a:pPr>
+            <a:r>
+              <a:rPr sz="2100" b="0" noProof="1" dirty="0" err="0">
                 <a:solidFill>
                   <a:srgbClr val="08243D"/>
                 </a:solidFill>
@@ -5478,7 +5480,7 @@
           <p:cNvPr id="10" name="">
             <a:extLst xmlns:a="http://schemas.openxmlformats.org/drawingml/2006/main">
               <a:ext uri="{FF2B5EF4-FFF2-40B4-BE49-F238E27FC236}">
-                <a16:creationId xmlns:a16="http://schemas.microsoft.com/office/drawing/2014/main" id="{945ECFB0-6904-4159-8466-774B7DE69344}"/>
+                <a16:creationId xmlns:a16="http://schemas.microsoft.com/office/drawing/2014/main" id="{679C8E16-5C17-4D47-8002-098BFB22FC72}"/>
               </a:ext>
             </a:extLst>
           </p:cNvPr>
@@ -5504,7 +5506,7 @@
           <a:bodyPr xmlns:a="http://schemas.openxmlformats.org/drawingml/2006/main"/>
           <a:lstStyle xmlns:a="http://schemas.openxmlformats.org/drawingml/2006/main">
             <a:defPPr>
-              <a:defRPr sz="1725" b="0">
+              <a:defRPr sz="1725" b="0" noProof="1" dirty="0" err="0">
                 <a:solidFill>
                   <a:srgbClr val="536675"/>
                 </a:solidFill>
@@ -5516,7 +5518,7 @@
           </a:lstStyle>
           <a:p xmlns:a="http://schemas.openxmlformats.org/drawingml/2006/main">
             <a:pPr>
-              <a:defRPr sz="1725" b="0">
+              <a:defRPr sz="1725" b="0" noProof="1" dirty="0" err="0">
                 <a:solidFill>
                   <a:srgbClr val="536675"/>
                 </a:solidFill>
@@ -5526,7 +5528,7 @@
               </a:defRPr>
             </a:pPr>
             <a:r>
-              <a:rPr sz="1725" b="0">
+              <a:rPr sz="1725" b="0" noProof="1" dirty="0" err="0">
                 <a:solidFill>
                   <a:srgbClr val="536675"/>
                 </a:solidFill>
@@ -5542,7 +5544,7 @@
     </p:spTree>
     <p:extLst>
       <p:ext uri="{BB962C8B-B14F-4D97-AF65-F5344CB8AC3E}">
-        <p14:creationId xmlns:p14="http://schemas.microsoft.com/office/powerpoint/2010/main" val="1104278701"/>
+        <p14:creationId xmlns:p14="http://schemas.microsoft.com/office/powerpoint/2010/main" val="1455507564"/>
       </p:ext>
     </p:extLst>
   </p:cSld>
@@ -5573,7 +5575,7 @@
           <p:cNvPr id="9" name="">
             <a:extLst xmlns:a="http://schemas.openxmlformats.org/drawingml/2006/main">
               <a:ext uri="{FF2B5EF4-FFF2-40B4-BE49-F238E27FC236}">
-                <a16:creationId xmlns:a16="http://schemas.microsoft.com/office/drawing/2014/main" id="{3CFEEC09-C166-4804-869A-4250E08F17BC}"/>
+                <a16:creationId xmlns:a16="http://schemas.microsoft.com/office/drawing/2014/main" id="{07B1EBDC-A474-4B81-946C-CDAEE759E1C3}"/>
               </a:ext>
             </a:extLst>
           </p:cNvPr>
@@ -5639,7 +5641,7 @@
           <p:cNvPr id="2" name="">
             <a:extLst xmlns:a="http://schemas.openxmlformats.org/drawingml/2006/main">
               <a:ext uri="{FF2B5EF4-FFF2-40B4-BE49-F238E27FC236}">
-                <a16:creationId xmlns:a16="http://schemas.microsoft.com/office/drawing/2014/main" id="{9DB7B901-095E-437E-A417-B25793D3B80D}"/>
+                <a16:creationId xmlns:a16="http://schemas.microsoft.com/office/drawing/2014/main" id="{31B689CB-7B4C-43B7-B203-4C0E068B4C81}"/>
               </a:ext>
             </a:extLst>
           </p:cNvPr>
@@ -5705,7 +5707,7 @@
           <p:cNvPr id="3" name="">
             <a:extLst xmlns:a="http://schemas.openxmlformats.org/drawingml/2006/main">
               <a:ext uri="{FF2B5EF4-FFF2-40B4-BE49-F238E27FC236}">
-                <a16:creationId xmlns:a16="http://schemas.microsoft.com/office/drawing/2014/main" id="{46BCA120-A2F2-479C-9ED9-62373316D36E}"/>
+                <a16:creationId xmlns:a16="http://schemas.microsoft.com/office/drawing/2014/main" id="{FE2AB53D-0C31-4B39-87B6-70BE2977F6DF}"/>
               </a:ext>
             </a:extLst>
           </p:cNvPr>
@@ -5771,7 +5773,7 @@
           <p:cNvPr id="4" name="">
             <a:extLst xmlns:a="http://schemas.openxmlformats.org/drawingml/2006/main">
               <a:ext uri="{FF2B5EF4-FFF2-40B4-BE49-F238E27FC236}">
-                <a16:creationId xmlns:a16="http://schemas.microsoft.com/office/drawing/2014/main" id="{7BD573DA-2C8B-4251-B433-01FB10EE0E2A}"/>
+                <a16:creationId xmlns:a16="http://schemas.microsoft.com/office/drawing/2014/main" id="{43C519E7-02F5-4ABC-AE15-E4C10AB9A84A}"/>
               </a:ext>
             </a:extLst>
           </p:cNvPr>
@@ -5837,7 +5839,7 @@
           <p:cNvPr id="5" name="">
             <a:extLst xmlns:a="http://schemas.openxmlformats.org/drawingml/2006/main">
               <a:ext uri="{FF2B5EF4-FFF2-40B4-BE49-F238E27FC236}">
-                <a16:creationId xmlns:a16="http://schemas.microsoft.com/office/drawing/2014/main" id="{B1DDF467-F695-4367-9A4E-68352B963721}"/>
+                <a16:creationId xmlns:a16="http://schemas.microsoft.com/office/drawing/2014/main" id="{0336CD0E-08AE-4550-9216-692E91EE94EC}"/>
               </a:ext>
             </a:extLst>
           </p:cNvPr>
@@ -5903,7 +5905,7 @@
           <p:cNvPr id="6" name="">
             <a:extLst xmlns:a="http://schemas.openxmlformats.org/drawingml/2006/main">
               <a:ext uri="{FF2B5EF4-FFF2-40B4-BE49-F238E27FC236}">
-                <a16:creationId xmlns:a16="http://schemas.microsoft.com/office/drawing/2014/main" id="{6298371D-3972-47CF-89D4-76562C4D79A6}"/>
+                <a16:creationId xmlns:a16="http://schemas.microsoft.com/office/drawing/2014/main" id="{D737BFD0-9E35-4A05-B3F1-496E2B2DA504}"/>
               </a:ext>
             </a:extLst>
           </p:cNvPr>
@@ -5969,7 +5971,7 @@
           <p:cNvPr id="7" name="">
             <a:extLst xmlns:a="http://schemas.openxmlformats.org/drawingml/2006/main">
               <a:ext uri="{FF2B5EF4-FFF2-40B4-BE49-F238E27FC236}">
-                <a16:creationId xmlns:a16="http://schemas.microsoft.com/office/drawing/2014/main" id="{FF1432DF-B71E-4E2F-A55E-8BD4DB97095B}"/>
+                <a16:creationId xmlns:a16="http://schemas.microsoft.com/office/drawing/2014/main" id="{1CD51DB1-F2BF-4AFA-8DE8-C2653CFF6F08}"/>
               </a:ext>
             </a:extLst>
           </p:cNvPr>
@@ -6035,7 +6037,7 @@
           <p:cNvPr id="8" name="">
             <a:extLst xmlns:a="http://schemas.openxmlformats.org/drawingml/2006/main">
               <a:ext uri="{FF2B5EF4-FFF2-40B4-BE49-F238E27FC236}">
-                <a16:creationId xmlns:a16="http://schemas.microsoft.com/office/drawing/2014/main" id="{DE085F46-49B1-421C-B6A0-D3A4CE0317F9}"/>
+                <a16:creationId xmlns:a16="http://schemas.microsoft.com/office/drawing/2014/main" id="{F4BFAA78-A2FC-4678-921E-C3FC110A8EAE}"/>
               </a:ext>
             </a:extLst>
           </p:cNvPr>
@@ -6122,7 +6124,7 @@
     </p:spTree>
     <p:extLst>
       <p:ext uri="{BB962C8B-B14F-4D97-AF65-F5344CB8AC3E}">
-        <p14:creationId xmlns:p14="http://schemas.microsoft.com/office/powerpoint/2010/main" val="356244070"/>
+        <p14:creationId xmlns:p14="http://schemas.microsoft.com/office/powerpoint/2010/main" val="1324358667"/>
       </p:ext>
     </p:extLst>
   </p:cSld>
@@ -6153,7 +6155,7 @@
           <p:cNvPr id="16" name="">
             <a:extLst xmlns:a="http://schemas.openxmlformats.org/drawingml/2006/main">
               <a:ext uri="{FF2B5EF4-FFF2-40B4-BE49-F238E27FC236}">
-                <a16:creationId xmlns:a16="http://schemas.microsoft.com/office/drawing/2014/main" id="{0CFD0FF2-2EC2-40FE-B0F8-16CFEE34EDC7}"/>
+                <a16:creationId xmlns:a16="http://schemas.microsoft.com/office/drawing/2014/main" id="{A7138F31-EFE3-40D8-8B42-44190B9FB1D8}"/>
               </a:ext>
             </a:extLst>
           </p:cNvPr>
@@ -6219,7 +6221,7 @@
           <p:cNvPr id="2" name="">
             <a:extLst xmlns:a="http://schemas.openxmlformats.org/drawingml/2006/main">
               <a:ext uri="{FF2B5EF4-FFF2-40B4-BE49-F238E27FC236}">
-                <a16:creationId xmlns:a16="http://schemas.microsoft.com/office/drawing/2014/main" id="{783D7DD3-62D1-450F-97FE-857C2963548C}"/>
+                <a16:creationId xmlns:a16="http://schemas.microsoft.com/office/drawing/2014/main" id="{B4586361-43DB-4F9A-9BFD-EAA6A6FEF8A7}"/>
               </a:ext>
             </a:extLst>
           </p:cNvPr>
@@ -6285,7 +6287,7 @@
           <p:cNvPr id="3" name="">
             <a:extLst xmlns:a="http://schemas.openxmlformats.org/drawingml/2006/main">
               <a:ext uri="{FF2B5EF4-FFF2-40B4-BE49-F238E27FC236}">
-                <a16:creationId xmlns:a16="http://schemas.microsoft.com/office/drawing/2014/main" id="{A25E3170-D36F-465A-94F0-75F405B87E83}"/>
+                <a16:creationId xmlns:a16="http://schemas.microsoft.com/office/drawing/2014/main" id="{6D0A7DD7-50AB-4E53-9B13-2964B1AECA00}"/>
               </a:ext>
             </a:extLst>
           </p:cNvPr>
@@ -6351,7 +6353,7 @@
           <p:cNvPr id="4" name="">
             <a:extLst xmlns:a="http://schemas.openxmlformats.org/drawingml/2006/main">
               <a:ext uri="{FF2B5EF4-FFF2-40B4-BE49-F238E27FC236}">
-                <a16:creationId xmlns:a16="http://schemas.microsoft.com/office/drawing/2014/main" id="{058DB116-F1CA-4CD3-97A2-3B31BA8818EE}"/>
+                <a16:creationId xmlns:a16="http://schemas.microsoft.com/office/drawing/2014/main" id="{DF28A822-7A27-41CE-B6F8-41E46FE2FB46}"/>
               </a:ext>
             </a:extLst>
           </p:cNvPr>
@@ -6417,7 +6419,7 @@
           <p:cNvPr id="5" name="">
             <a:extLst xmlns:a="http://schemas.openxmlformats.org/drawingml/2006/main">
               <a:ext uri="{FF2B5EF4-FFF2-40B4-BE49-F238E27FC236}">
-                <a16:creationId xmlns:a16="http://schemas.microsoft.com/office/drawing/2014/main" id="{A1FC6B1A-7252-4483-BE51-A8066744334B}"/>
+                <a16:creationId xmlns:a16="http://schemas.microsoft.com/office/drawing/2014/main" id="{15F7B93B-969D-4301-987E-E6162F2E1DCA}"/>
               </a:ext>
             </a:extLst>
           </p:cNvPr>
@@ -6483,7 +6485,7 @@
           <p:cNvPr id="6" name="">
             <a:extLst xmlns:a="http://schemas.openxmlformats.org/drawingml/2006/main">
               <a:ext uri="{FF2B5EF4-FFF2-40B4-BE49-F238E27FC236}">
-                <a16:creationId xmlns:a16="http://schemas.microsoft.com/office/drawing/2014/main" id="{0CCC7D6A-E666-4C2D-B627-77773923F5B4}"/>
+                <a16:creationId xmlns:a16="http://schemas.microsoft.com/office/drawing/2014/main" id="{0999D800-04F8-4F88-957C-0322160E157D}"/>
               </a:ext>
             </a:extLst>
           </p:cNvPr>
@@ -6549,7 +6551,7 @@
           <p:cNvPr id="7" name="">
             <a:extLst xmlns:a="http://schemas.openxmlformats.org/drawingml/2006/main">
               <a:ext uri="{FF2B5EF4-FFF2-40B4-BE49-F238E27FC236}">
-                <a16:creationId xmlns:a16="http://schemas.microsoft.com/office/drawing/2014/main" id="{A614B3A3-53C2-4220-99E8-8C01EEC9D133}"/>
+                <a16:creationId xmlns:a16="http://schemas.microsoft.com/office/drawing/2014/main" id="{5F90B883-F475-465D-9057-4DD6A258422C}"/>
               </a:ext>
             </a:extLst>
           </p:cNvPr>
@@ -6615,7 +6617,7 @@
           <p:cNvPr id="8" name="">
             <a:extLst xmlns:a="http://schemas.openxmlformats.org/drawingml/2006/main">
               <a:ext uri="{FF2B5EF4-FFF2-40B4-BE49-F238E27FC236}">
-                <a16:creationId xmlns:a16="http://schemas.microsoft.com/office/drawing/2014/main" id="{D27B292E-52EC-464D-9A32-BB61E627857A}"/>
+                <a16:creationId xmlns:a16="http://schemas.microsoft.com/office/drawing/2014/main" id="{35172773-13DA-46E1-9D0C-CDA81EBE2FD5}"/>
               </a:ext>
             </a:extLst>
           </p:cNvPr>
@@ -6681,7 +6683,7 @@
           <p:cNvPr id="9" name="">
             <a:extLst xmlns:a="http://schemas.openxmlformats.org/drawingml/2006/main">
               <a:ext uri="{FF2B5EF4-FFF2-40B4-BE49-F238E27FC236}">
-                <a16:creationId xmlns:a16="http://schemas.microsoft.com/office/drawing/2014/main" id="{16C9751E-6AF3-4007-A771-50077F2A17A2}"/>
+                <a16:creationId xmlns:a16="http://schemas.microsoft.com/office/drawing/2014/main" id="{E0EB391F-BE81-47AB-95AF-4867C659783F}"/>
               </a:ext>
             </a:extLst>
           </p:cNvPr>
@@ -6747,7 +6749,7 @@
           <p:cNvPr id="10" name="">
             <a:extLst xmlns:a="http://schemas.openxmlformats.org/drawingml/2006/main">
               <a:ext uri="{FF2B5EF4-FFF2-40B4-BE49-F238E27FC236}">
-                <a16:creationId xmlns:a16="http://schemas.microsoft.com/office/drawing/2014/main" id="{68A44183-88A9-4CCA-B9A4-24EC3E47013D}"/>
+                <a16:creationId xmlns:a16="http://schemas.microsoft.com/office/drawing/2014/main" id="{9110FE2E-B8F0-4003-92F7-A19C13D36FF9}"/>
               </a:ext>
             </a:extLst>
           </p:cNvPr>
@@ -6813,7 +6815,7 @@
           <p:cNvPr id="11" name="">
             <a:extLst xmlns:a="http://schemas.openxmlformats.org/drawingml/2006/main">
               <a:ext uri="{FF2B5EF4-FFF2-40B4-BE49-F238E27FC236}">
-                <a16:creationId xmlns:a16="http://schemas.microsoft.com/office/drawing/2014/main" id="{4006DB7C-F787-4528-868E-920BF693990E}"/>
+                <a16:creationId xmlns:a16="http://schemas.microsoft.com/office/drawing/2014/main" id="{43DEF742-EC6A-4469-A0DB-A0DC2A77123C}"/>
               </a:ext>
             </a:extLst>
           </p:cNvPr>
@@ -6879,7 +6881,7 @@
           <p:cNvPr id="12" name="">
             <a:extLst xmlns:a="http://schemas.openxmlformats.org/drawingml/2006/main">
               <a:ext uri="{FF2B5EF4-FFF2-40B4-BE49-F238E27FC236}">
-                <a16:creationId xmlns:a16="http://schemas.microsoft.com/office/drawing/2014/main" id="{2EE21937-FAEC-4B2B-91B6-EBF1630A4E5F}"/>
+                <a16:creationId xmlns:a16="http://schemas.microsoft.com/office/drawing/2014/main" id="{A53DAA9D-9324-4889-81A9-A863F091B23C}"/>
               </a:ext>
             </a:extLst>
           </p:cNvPr>
@@ -6945,7 +6947,7 @@
           <p:cNvPr id="13" name="">
             <a:extLst xmlns:a="http://schemas.openxmlformats.org/drawingml/2006/main">
               <a:ext uri="{FF2B5EF4-FFF2-40B4-BE49-F238E27FC236}">
-                <a16:creationId xmlns:a16="http://schemas.microsoft.com/office/drawing/2014/main" id="{284D15CD-87FB-4A13-B5BE-683C7A25FBFB}"/>
+                <a16:creationId xmlns:a16="http://schemas.microsoft.com/office/drawing/2014/main" id="{57B4F8F8-8CB3-4CE9-AC2F-FD6330EDDF45}"/>
               </a:ext>
             </a:extLst>
           </p:cNvPr>
@@ -7011,7 +7013,7 @@
           <p:cNvPr id="14" name="">
             <a:extLst xmlns:a="http://schemas.openxmlformats.org/drawingml/2006/main">
               <a:ext uri="{FF2B5EF4-FFF2-40B4-BE49-F238E27FC236}">
-                <a16:creationId xmlns:a16="http://schemas.microsoft.com/office/drawing/2014/main" id="{05337A78-D683-480D-BAFA-F9318FA163B9}"/>
+                <a16:creationId xmlns:a16="http://schemas.microsoft.com/office/drawing/2014/main" id="{EC6B0454-7AC2-48F7-BF40-A67804506161}"/>
               </a:ext>
             </a:extLst>
           </p:cNvPr>
@@ -7077,7 +7079,7 @@
           <p:cNvPr id="15" name="">
             <a:extLst xmlns:a="http://schemas.openxmlformats.org/drawingml/2006/main">
               <a:ext uri="{FF2B5EF4-FFF2-40B4-BE49-F238E27FC236}">
-                <a16:creationId xmlns:a16="http://schemas.microsoft.com/office/drawing/2014/main" id="{6FDA0FA7-3AF9-4A86-8AB1-315B6D2B343F}"/>
+                <a16:creationId xmlns:a16="http://schemas.microsoft.com/office/drawing/2014/main" id="{2E2BAD99-C713-42F8-8BFF-F1F68171FE98}"/>
               </a:ext>
             </a:extLst>
           </p:cNvPr>
@@ -7141,7 +7143,7 @@
     </p:spTree>
     <p:extLst>
       <p:ext uri="{BB962C8B-B14F-4D97-AF65-F5344CB8AC3E}">
-        <p14:creationId xmlns:p14="http://schemas.microsoft.com/office/powerpoint/2010/main" val="1732208861"/>
+        <p14:creationId xmlns:p14="http://schemas.microsoft.com/office/powerpoint/2010/main" val="1532394482"/>
       </p:ext>
     </p:extLst>
   </p:cSld>
@@ -7172,7 +7174,7 @@
           <p:cNvPr id="16" name="">
             <a:extLst xmlns:a="http://schemas.openxmlformats.org/drawingml/2006/main">
               <a:ext uri="{FF2B5EF4-FFF2-40B4-BE49-F238E27FC236}">
-                <a16:creationId xmlns:a16="http://schemas.microsoft.com/office/drawing/2014/main" id="{5723EEEF-0A59-4F17-A33F-C0EA1C503266}"/>
+                <a16:creationId xmlns:a16="http://schemas.microsoft.com/office/drawing/2014/main" id="{66278DD4-F202-455F-B47E-5CF37457CD18}"/>
               </a:ext>
             </a:extLst>
           </p:cNvPr>
@@ -7238,7 +7240,7 @@
           <p:cNvPr id="2" name="">
             <a:extLst xmlns:a="http://schemas.openxmlformats.org/drawingml/2006/main">
               <a:ext uri="{FF2B5EF4-FFF2-40B4-BE49-F238E27FC236}">
-                <a16:creationId xmlns:a16="http://schemas.microsoft.com/office/drawing/2014/main" id="{0B137BDE-9800-4331-B90F-D591A7F3CD6D}"/>
+                <a16:creationId xmlns:a16="http://schemas.microsoft.com/office/drawing/2014/main" id="{E35AA651-72C6-4F55-8A8E-F33CE5A48A15}"/>
               </a:ext>
             </a:extLst>
           </p:cNvPr>
@@ -7304,7 +7306,7 @@
           <p:cNvPr id="3" name="">
             <a:extLst xmlns:a="http://schemas.openxmlformats.org/drawingml/2006/main">
               <a:ext uri="{FF2B5EF4-FFF2-40B4-BE49-F238E27FC236}">
-                <a16:creationId xmlns:a16="http://schemas.microsoft.com/office/drawing/2014/main" id="{37902867-B10E-4B84-B93B-74882293CEB5}"/>
+                <a16:creationId xmlns:a16="http://schemas.microsoft.com/office/drawing/2014/main" id="{1BEEC6A5-7DA2-4B74-9D12-94F3C9F6D7D6}"/>
               </a:ext>
             </a:extLst>
           </p:cNvPr>
@@ -7370,7 +7372,7 @@
           <p:cNvPr id="4" name="">
             <a:extLst xmlns:a="http://schemas.openxmlformats.org/drawingml/2006/main">
               <a:ext uri="{FF2B5EF4-FFF2-40B4-BE49-F238E27FC236}">
-                <a16:creationId xmlns:a16="http://schemas.microsoft.com/office/drawing/2014/main" id="{A1C59869-58E5-417B-8F6C-9152F06BB921}"/>
+                <a16:creationId xmlns:a16="http://schemas.microsoft.com/office/drawing/2014/main" id="{7986E87A-EACE-4B6E-8534-88FA66EBE464}"/>
               </a:ext>
             </a:extLst>
           </p:cNvPr>
@@ -7436,7 +7438,7 @@
           <p:cNvPr id="5" name="">
             <a:extLst xmlns:a="http://schemas.openxmlformats.org/drawingml/2006/main">
               <a:ext uri="{FF2B5EF4-FFF2-40B4-BE49-F238E27FC236}">
-                <a16:creationId xmlns:a16="http://schemas.microsoft.com/office/drawing/2014/main" id="{5AE32872-F2E7-4F0B-B240-44A4DBCD1AAF}"/>
+                <a16:creationId xmlns:a16="http://schemas.microsoft.com/office/drawing/2014/main" id="{8EF1726D-E36F-4E23-B15A-0B847919B4DA}"/>
               </a:ext>
             </a:extLst>
           </p:cNvPr>
@@ -7502,7 +7504,7 @@
           <p:cNvPr id="6" name="">
             <a:extLst xmlns:a="http://schemas.openxmlformats.org/drawingml/2006/main">
               <a:ext uri="{FF2B5EF4-FFF2-40B4-BE49-F238E27FC236}">
-                <a16:creationId xmlns:a16="http://schemas.microsoft.com/office/drawing/2014/main" id="{5F8B7406-194A-4395-9809-4564F8D5511A}"/>
+                <a16:creationId xmlns:a16="http://schemas.microsoft.com/office/drawing/2014/main" id="{AF84B956-C83B-46F9-9999-B737AA24B46E}"/>
               </a:ext>
             </a:extLst>
           </p:cNvPr>
@@ -7568,7 +7570,7 @@
           <p:cNvPr id="7" name="">
             <a:extLst xmlns:a="http://schemas.openxmlformats.org/drawingml/2006/main">
               <a:ext uri="{FF2B5EF4-FFF2-40B4-BE49-F238E27FC236}">
-                <a16:creationId xmlns:a16="http://schemas.microsoft.com/office/drawing/2014/main" id="{6D6D4578-6E6A-4545-904A-643925FAA80B}"/>
+                <a16:creationId xmlns:a16="http://schemas.microsoft.com/office/drawing/2014/main" id="{51A1E502-0D14-48B1-B956-8F03066D53CB}"/>
               </a:ext>
             </a:extLst>
           </p:cNvPr>
@@ -7634,7 +7636,7 @@
           <p:cNvPr id="8" name="">
             <a:extLst xmlns:a="http://schemas.openxmlformats.org/drawingml/2006/main">
               <a:ext uri="{FF2B5EF4-FFF2-40B4-BE49-F238E27FC236}">
-                <a16:creationId xmlns:a16="http://schemas.microsoft.com/office/drawing/2014/main" id="{AA47044D-3FFE-4F8F-8030-93C3EC3B8341}"/>
+                <a16:creationId xmlns:a16="http://schemas.microsoft.com/office/drawing/2014/main" id="{40B0CA77-B1ED-401F-862D-017F0C5A9B3D}"/>
               </a:ext>
             </a:extLst>
           </p:cNvPr>
@@ -7700,7 +7702,7 @@
           <p:cNvPr id="9" name="">
             <a:extLst xmlns:a="http://schemas.openxmlformats.org/drawingml/2006/main">
               <a:ext uri="{FF2B5EF4-FFF2-40B4-BE49-F238E27FC236}">
-                <a16:creationId xmlns:a16="http://schemas.microsoft.com/office/drawing/2014/main" id="{E6EB4ADE-FFF6-4397-A0DC-CB632590C447}"/>
+                <a16:creationId xmlns:a16="http://schemas.microsoft.com/office/drawing/2014/main" id="{C0AC2425-5FEE-44CE-94CA-BAA1B3D9C728}"/>
               </a:ext>
             </a:extLst>
           </p:cNvPr>
@@ -7766,7 +7768,7 @@
           <p:cNvPr id="10" name="">
             <a:extLst xmlns:a="http://schemas.openxmlformats.org/drawingml/2006/main">
               <a:ext uri="{FF2B5EF4-FFF2-40B4-BE49-F238E27FC236}">
-                <a16:creationId xmlns:a16="http://schemas.microsoft.com/office/drawing/2014/main" id="{2B77AA6E-DEFD-40D1-9E36-E6B2D0F07B89}"/>
+                <a16:creationId xmlns:a16="http://schemas.microsoft.com/office/drawing/2014/main" id="{AA270115-DC6E-43E7-BCEE-0D9AC6D8EBC6}"/>
               </a:ext>
             </a:extLst>
           </p:cNvPr>
@@ -7832,7 +7834,7 @@
           <p:cNvPr id="11" name="">
             <a:extLst xmlns:a="http://schemas.openxmlformats.org/drawingml/2006/main">
               <a:ext uri="{FF2B5EF4-FFF2-40B4-BE49-F238E27FC236}">
-                <a16:creationId xmlns:a16="http://schemas.microsoft.com/office/drawing/2014/main" id="{29588495-64B7-46AB-AA37-580CDCE6B62E}"/>
+                <a16:creationId xmlns:a16="http://schemas.microsoft.com/office/drawing/2014/main" id="{A7D4C811-EB8D-4ED5-B0B8-596E8E9AEC42}"/>
               </a:ext>
             </a:extLst>
           </p:cNvPr>
@@ -7898,7 +7900,7 @@
           <p:cNvPr id="12" name="">
             <a:extLst xmlns:a="http://schemas.openxmlformats.org/drawingml/2006/main">
               <a:ext uri="{FF2B5EF4-FFF2-40B4-BE49-F238E27FC236}">
-                <a16:creationId xmlns:a16="http://schemas.microsoft.com/office/drawing/2014/main" id="{3E3C00B4-914C-471E-8F4F-056ABACA04C8}"/>
+                <a16:creationId xmlns:a16="http://schemas.microsoft.com/office/drawing/2014/main" id="{81844FF1-2975-458F-82BF-D97C8BAFF679}"/>
               </a:ext>
             </a:extLst>
           </p:cNvPr>
@@ -7964,7 +7966,7 @@
           <p:cNvPr id="13" name="">
             <a:extLst xmlns:a="http://schemas.openxmlformats.org/drawingml/2006/main">
               <a:ext uri="{FF2B5EF4-FFF2-40B4-BE49-F238E27FC236}">
-                <a16:creationId xmlns:a16="http://schemas.microsoft.com/office/drawing/2014/main" id="{4C443CAD-5D66-4189-8FFE-ADEA5C0AF789}"/>
+                <a16:creationId xmlns:a16="http://schemas.microsoft.com/office/drawing/2014/main" id="{4B0FA6B2-1D48-422E-8DA2-DA5B6111BEB5}"/>
               </a:ext>
             </a:extLst>
           </p:cNvPr>
@@ -8030,7 +8032,7 @@
           <p:cNvPr id="14" name="">
             <a:extLst xmlns:a="http://schemas.openxmlformats.org/drawingml/2006/main">
               <a:ext uri="{FF2B5EF4-FFF2-40B4-BE49-F238E27FC236}">
-                <a16:creationId xmlns:a16="http://schemas.microsoft.com/office/drawing/2014/main" id="{37CA757E-24E7-4D44-80B6-D4B0110371F5}"/>
+                <a16:creationId xmlns:a16="http://schemas.microsoft.com/office/drawing/2014/main" id="{C931B85E-D54A-4962-A228-10E69F990EF4}"/>
               </a:ext>
             </a:extLst>
           </p:cNvPr>
@@ -8096,7 +8098,7 @@
           <p:cNvPr id="15" name="">
             <a:extLst xmlns:a="http://schemas.openxmlformats.org/drawingml/2006/main">
               <a:ext uri="{FF2B5EF4-FFF2-40B4-BE49-F238E27FC236}">
-                <a16:creationId xmlns:a16="http://schemas.microsoft.com/office/drawing/2014/main" id="{3A722D76-7E81-4FEA-9F81-6D87EA03F44F}"/>
+                <a16:creationId xmlns:a16="http://schemas.microsoft.com/office/drawing/2014/main" id="{587465ED-E7DE-4A32-9FC5-4BFA9EF4D96D}"/>
               </a:ext>
             </a:extLst>
           </p:cNvPr>
@@ -8160,7 +8162,7 @@
     </p:spTree>
     <p:extLst>
       <p:ext uri="{BB962C8B-B14F-4D97-AF65-F5344CB8AC3E}">
-        <p14:creationId xmlns:p14="http://schemas.microsoft.com/office/powerpoint/2010/main" val="1741153093"/>
+        <p14:creationId xmlns:p14="http://schemas.microsoft.com/office/powerpoint/2010/main" val="352932875"/>
       </p:ext>
     </p:extLst>
   </p:cSld>
@@ -8191,7 +8193,7 @@
           <p:cNvPr id="17" name="">
             <a:extLst xmlns:a="http://schemas.openxmlformats.org/drawingml/2006/main">
               <a:ext uri="{FF2B5EF4-FFF2-40B4-BE49-F238E27FC236}">
-                <a16:creationId xmlns:a16="http://schemas.microsoft.com/office/drawing/2014/main" id="{44432E57-B46C-4C2D-A3D7-EEB401E48907}"/>
+                <a16:creationId xmlns:a16="http://schemas.microsoft.com/office/drawing/2014/main" id="{EC20F540-3703-43F1-8E2A-9C24AFF8C764}"/>
               </a:ext>
             </a:extLst>
           </p:cNvPr>
@@ -8257,7 +8259,7 @@
           <p:cNvPr id="2" name="">
             <a:extLst xmlns:a="http://schemas.openxmlformats.org/drawingml/2006/main">
               <a:ext uri="{FF2B5EF4-FFF2-40B4-BE49-F238E27FC236}">
-                <a16:creationId xmlns:a16="http://schemas.microsoft.com/office/drawing/2014/main" id="{AB5C3B63-E6BE-474B-A26B-7EDFDAE8C5C3}"/>
+                <a16:creationId xmlns:a16="http://schemas.microsoft.com/office/drawing/2014/main" id="{A3242EC5-70BE-46C9-ABE6-7E2D08475AF4}"/>
               </a:ext>
             </a:extLst>
           </p:cNvPr>
@@ -8323,7 +8325,7 @@
           <p:cNvPr id="3" name="">
             <a:extLst xmlns:a="http://schemas.openxmlformats.org/drawingml/2006/main">
               <a:ext uri="{FF2B5EF4-FFF2-40B4-BE49-F238E27FC236}">
-                <a16:creationId xmlns:a16="http://schemas.microsoft.com/office/drawing/2014/main" id="{CD007654-916B-4704-83ED-19AD81727536}"/>
+                <a16:creationId xmlns:a16="http://schemas.microsoft.com/office/drawing/2014/main" id="{905D7B89-E87E-4525-94ED-D41F2ED4BCFE}"/>
               </a:ext>
             </a:extLst>
           </p:cNvPr>
@@ -8389,7 +8391,7 @@
           <p:cNvPr id="4" name="">
             <a:extLst xmlns:a="http://schemas.openxmlformats.org/drawingml/2006/main">
               <a:ext uri="{FF2B5EF4-FFF2-40B4-BE49-F238E27FC236}">
-                <a16:creationId xmlns:a16="http://schemas.microsoft.com/office/drawing/2014/main" id="{0BE503F0-3D26-4D7D-BAC4-7F580581367D}"/>
+                <a16:creationId xmlns:a16="http://schemas.microsoft.com/office/drawing/2014/main" id="{3B1D4EF8-AC87-46D8-9AD5-8281F57079D2}"/>
               </a:ext>
             </a:extLst>
           </p:cNvPr>
@@ -8455,7 +8457,7 @@
           <p:cNvPr id="5" name="">
             <a:extLst xmlns:a="http://schemas.openxmlformats.org/drawingml/2006/main">
               <a:ext uri="{FF2B5EF4-FFF2-40B4-BE49-F238E27FC236}">
-                <a16:creationId xmlns:a16="http://schemas.microsoft.com/office/drawing/2014/main" id="{294412F5-04E1-444D-AA1C-701CC7D39F6E}"/>
+                <a16:creationId xmlns:a16="http://schemas.microsoft.com/office/drawing/2014/main" id="{84F21087-12F1-4916-9A05-FE122999796A}"/>
               </a:ext>
             </a:extLst>
           </p:cNvPr>
@@ -8521,7 +8523,7 @@
           <p:cNvPr id="6" name="">
             <a:extLst xmlns:a="http://schemas.openxmlformats.org/drawingml/2006/main">
               <a:ext uri="{FF2B5EF4-FFF2-40B4-BE49-F238E27FC236}">
-                <a16:creationId xmlns:a16="http://schemas.microsoft.com/office/drawing/2014/main" id="{0E5B0333-2EB6-4667-9AFD-270207512A17}"/>
+                <a16:creationId xmlns:a16="http://schemas.microsoft.com/office/drawing/2014/main" id="{4B5E0CAC-CE95-405A-9B97-AE54D1BA3F36}"/>
               </a:ext>
             </a:extLst>
           </p:cNvPr>
@@ -8587,7 +8589,7 @@
           <p:cNvPr id="7" name="">
             <a:extLst xmlns:a="http://schemas.openxmlformats.org/drawingml/2006/main">
               <a:ext uri="{FF2B5EF4-FFF2-40B4-BE49-F238E27FC236}">
-                <a16:creationId xmlns:a16="http://schemas.microsoft.com/office/drawing/2014/main" id="{79440BC8-33E3-45AE-B882-8D5D92518259}"/>
+                <a16:creationId xmlns:a16="http://schemas.microsoft.com/office/drawing/2014/main" id="{1E837808-05E0-4D2D-85D2-128CBB20E852}"/>
               </a:ext>
             </a:extLst>
           </p:cNvPr>
@@ -8653,7 +8655,7 @@
           <p:cNvPr id="8" name="">
             <a:extLst xmlns:a="http://schemas.openxmlformats.org/drawingml/2006/main">
               <a:ext uri="{FF2B5EF4-FFF2-40B4-BE49-F238E27FC236}">
-                <a16:creationId xmlns:a16="http://schemas.microsoft.com/office/drawing/2014/main" id="{FAFE1CF8-1701-487B-AA68-A10EE43A59C7}"/>
+                <a16:creationId xmlns:a16="http://schemas.microsoft.com/office/drawing/2014/main" id="{AB0BFC41-87FF-4CED-A7BD-0C1A6671EF3B}"/>
               </a:ext>
             </a:extLst>
           </p:cNvPr>
@@ -8719,7 +8721,7 @@
           <p:cNvPr id="9" name="">
             <a:extLst xmlns:a="http://schemas.openxmlformats.org/drawingml/2006/main">
               <a:ext uri="{FF2B5EF4-FFF2-40B4-BE49-F238E27FC236}">
-                <a16:creationId xmlns:a16="http://schemas.microsoft.com/office/drawing/2014/main" id="{9960BE30-EC11-4C2D-BE33-528B5B4DCD44}"/>
+                <a16:creationId xmlns:a16="http://schemas.microsoft.com/office/drawing/2014/main" id="{FC68206E-8B01-4BA9-A07F-06A37B68782A}"/>
               </a:ext>
             </a:extLst>
           </p:cNvPr>
@@ -8785,7 +8787,7 @@
           <p:cNvPr id="10" name="">
             <a:extLst xmlns:a="http://schemas.openxmlformats.org/drawingml/2006/main">
               <a:ext uri="{FF2B5EF4-FFF2-40B4-BE49-F238E27FC236}">
-                <a16:creationId xmlns:a16="http://schemas.microsoft.com/office/drawing/2014/main" id="{9B11607C-68C0-4D68-8435-9DBAB4FA680D}"/>
+                <a16:creationId xmlns:a16="http://schemas.microsoft.com/office/drawing/2014/main" id="{F0DB47FF-5066-4060-96F0-F579E3C03B1A}"/>
               </a:ext>
             </a:extLst>
           </p:cNvPr>
@@ -8851,7 +8853,7 @@
           <p:cNvPr id="11" name="">
             <a:extLst xmlns:a="http://schemas.openxmlformats.org/drawingml/2006/main">
               <a:ext uri="{FF2B5EF4-FFF2-40B4-BE49-F238E27FC236}">
-                <a16:creationId xmlns:a16="http://schemas.microsoft.com/office/drawing/2014/main" id="{12E3467F-76B9-4854-AE3E-52F92928DD43}"/>
+                <a16:creationId xmlns:a16="http://schemas.microsoft.com/office/drawing/2014/main" id="{72DF3F1C-DB9B-4C9D-877E-E0A85EBD6AB0}"/>
               </a:ext>
             </a:extLst>
           </p:cNvPr>
@@ -8917,7 +8919,7 @@
           <p:cNvPr id="12" name="">
             <a:extLst xmlns:a="http://schemas.openxmlformats.org/drawingml/2006/main">
               <a:ext uri="{FF2B5EF4-FFF2-40B4-BE49-F238E27FC236}">
-                <a16:creationId xmlns:a16="http://schemas.microsoft.com/office/drawing/2014/main" id="{CA788A42-2627-4699-AFEB-DE0152CDC9C8}"/>
+                <a16:creationId xmlns:a16="http://schemas.microsoft.com/office/drawing/2014/main" id="{3EF2029C-6B2A-4A49-B654-ADD058887192}"/>
               </a:ext>
             </a:extLst>
           </p:cNvPr>
@@ -8983,7 +8985,7 @@
           <p:cNvPr id="13" name="">
             <a:extLst xmlns:a="http://schemas.openxmlformats.org/drawingml/2006/main">
               <a:ext uri="{FF2B5EF4-FFF2-40B4-BE49-F238E27FC236}">
-                <a16:creationId xmlns:a16="http://schemas.microsoft.com/office/drawing/2014/main" id="{648ECC5E-F377-42A4-818E-4119F4DFC3AA}"/>
+                <a16:creationId xmlns:a16="http://schemas.microsoft.com/office/drawing/2014/main" id="{3AC64362-1818-4900-91B7-9EECC1D95DB7}"/>
               </a:ext>
             </a:extLst>
           </p:cNvPr>
@@ -9049,7 +9051,7 @@
           <p:cNvPr id="14" name="">
             <a:extLst xmlns:a="http://schemas.openxmlformats.org/drawingml/2006/main">
               <a:ext uri="{FF2B5EF4-FFF2-40B4-BE49-F238E27FC236}">
-                <a16:creationId xmlns:a16="http://schemas.microsoft.com/office/drawing/2014/main" id="{231ADC5A-E044-4B2E-8DFC-B7E094808688}"/>
+                <a16:creationId xmlns:a16="http://schemas.microsoft.com/office/drawing/2014/main" id="{D615B867-7D52-418C-9AEB-FEDB738CA40D}"/>
               </a:ext>
             </a:extLst>
           </p:cNvPr>
@@ -9115,7 +9117,7 @@
           <p:cNvPr id="15" name="">
             <a:extLst xmlns:a="http://schemas.openxmlformats.org/drawingml/2006/main">
               <a:ext uri="{FF2B5EF4-FFF2-40B4-BE49-F238E27FC236}">
-                <a16:creationId xmlns:a16="http://schemas.microsoft.com/office/drawing/2014/main" id="{7EFAD40D-F0C5-48C4-BA8B-FB19E0F0B5F3}"/>
+                <a16:creationId xmlns:a16="http://schemas.microsoft.com/office/drawing/2014/main" id="{5C27121D-0508-445E-B74E-939262C8EEC9}"/>
               </a:ext>
             </a:extLst>
           </p:cNvPr>
@@ -9181,7 +9183,7 @@
           <p:cNvPr id="16" name="">
             <a:extLst xmlns:a="http://schemas.openxmlformats.org/drawingml/2006/main">
               <a:ext uri="{FF2B5EF4-FFF2-40B4-BE49-F238E27FC236}">
-                <a16:creationId xmlns:a16="http://schemas.microsoft.com/office/drawing/2014/main" id="{9730292E-3FB7-4B11-8D59-EA90DF99A686}"/>
+                <a16:creationId xmlns:a16="http://schemas.microsoft.com/office/drawing/2014/main" id="{1DCFF251-1313-42A2-892A-E42E90DBE355}"/>
               </a:ext>
             </a:extLst>
           </p:cNvPr>
@@ -9245,7 +9247,7 @@
     </p:spTree>
     <p:extLst>
       <p:ext uri="{BB962C8B-B14F-4D97-AF65-F5344CB8AC3E}">
-        <p14:creationId xmlns:p14="http://schemas.microsoft.com/office/powerpoint/2010/main" val="413684272"/>
+        <p14:creationId xmlns:p14="http://schemas.microsoft.com/office/powerpoint/2010/main" val="231106695"/>
       </p:ext>
     </p:extLst>
   </p:cSld>
@@ -9276,7 +9278,7 @@
           <p:cNvPr id="8" name="">
             <a:extLst xmlns:a="http://schemas.openxmlformats.org/drawingml/2006/main">
               <a:ext uri="{FF2B5EF4-FFF2-40B4-BE49-F238E27FC236}">
-                <a16:creationId xmlns:a16="http://schemas.microsoft.com/office/drawing/2014/main" id="{0D295FAC-72E0-4B60-9722-0672012349E6}"/>
+                <a16:creationId xmlns:a16="http://schemas.microsoft.com/office/drawing/2014/main" id="{E3F3B6C5-7295-4C18-9660-FB786E11FF76}"/>
               </a:ext>
             </a:extLst>
           </p:cNvPr>
@@ -9342,7 +9344,7 @@
           <p:cNvPr id="2" name="">
             <a:extLst xmlns:a="http://schemas.openxmlformats.org/drawingml/2006/main">
               <a:ext uri="{FF2B5EF4-FFF2-40B4-BE49-F238E27FC236}">
-                <a16:creationId xmlns:a16="http://schemas.microsoft.com/office/drawing/2014/main" id="{38FA211D-877D-4CDE-B949-0A56F84B8A1D}"/>
+                <a16:creationId xmlns:a16="http://schemas.microsoft.com/office/drawing/2014/main" id="{D031ACB0-6F2F-40FE-9646-AABFD1A651DC}"/>
               </a:ext>
             </a:extLst>
           </p:cNvPr>
@@ -9408,7 +9410,7 @@
           <p:cNvPr id="3" name="">
             <a:extLst xmlns:a="http://schemas.openxmlformats.org/drawingml/2006/main">
               <a:ext uri="{FF2B5EF4-FFF2-40B4-BE49-F238E27FC236}">
-                <a16:creationId xmlns:a16="http://schemas.microsoft.com/office/drawing/2014/main" id="{747A528C-E292-47AF-8FFF-4DA2B078A868}"/>
+                <a16:creationId xmlns:a16="http://schemas.microsoft.com/office/drawing/2014/main" id="{A75FB5C5-8BF4-448B-B741-AC2C63F49139}"/>
               </a:ext>
             </a:extLst>
           </p:cNvPr>
@@ -9474,7 +9476,7 @@
           <p:cNvPr id="4" name="">
             <a:extLst xmlns:a="http://schemas.openxmlformats.org/drawingml/2006/main">
               <a:ext uri="{FF2B5EF4-FFF2-40B4-BE49-F238E27FC236}">
-                <a16:creationId xmlns:a16="http://schemas.microsoft.com/office/drawing/2014/main" id="{BB43E90E-EE24-4522-A752-FB389FE4A531}"/>
+                <a16:creationId xmlns:a16="http://schemas.microsoft.com/office/drawing/2014/main" id="{43945B5F-7CC3-482A-BE5C-CFE1D5AA0D35}"/>
               </a:ext>
             </a:extLst>
           </p:cNvPr>
@@ -9540,7 +9542,7 @@
           <p:cNvPr id="5" name="">
             <a:extLst xmlns:a="http://schemas.openxmlformats.org/drawingml/2006/main">
               <a:ext uri="{FF2B5EF4-FFF2-40B4-BE49-F238E27FC236}">
-                <a16:creationId xmlns:a16="http://schemas.microsoft.com/office/drawing/2014/main" id="{D3CF69DE-A157-475C-BCB1-DBCE891C2C45}"/>
+                <a16:creationId xmlns:a16="http://schemas.microsoft.com/office/drawing/2014/main" id="{DB7818BE-C48C-42A7-912F-7AE02B78308A}"/>
               </a:ext>
             </a:extLst>
           </p:cNvPr>
@@ -9698,7 +9700,7 @@
           <p:cNvPr id="6" name="">
             <a:extLst xmlns:a="http://schemas.openxmlformats.org/drawingml/2006/main">
               <a:ext uri="{FF2B5EF4-FFF2-40B4-BE49-F238E27FC236}">
-                <a16:creationId xmlns:a16="http://schemas.microsoft.com/office/drawing/2014/main" id="{062DD86C-4626-4FA8-94D4-6F181CEFCBF1}"/>
+                <a16:creationId xmlns:a16="http://schemas.microsoft.com/office/drawing/2014/main" id="{A2208D27-5A96-4D77-AEF2-0F35B642D073}"/>
               </a:ext>
             </a:extLst>
           </p:cNvPr>
@@ -9856,7 +9858,7 @@
           <p:cNvPr id="7" name="">
             <a:extLst xmlns:a="http://schemas.openxmlformats.org/drawingml/2006/main">
               <a:ext uri="{FF2B5EF4-FFF2-40B4-BE49-F238E27FC236}">
-                <a16:creationId xmlns:a16="http://schemas.microsoft.com/office/drawing/2014/main" id="{06582A97-C49B-48B5-87C4-8B91AD56BB29}"/>
+                <a16:creationId xmlns:a16="http://schemas.microsoft.com/office/drawing/2014/main" id="{6A2BA0B6-3BEC-43DF-BCE2-D141D19E4ABA}"/>
               </a:ext>
             </a:extLst>
           </p:cNvPr>
@@ -9920,7 +9922,7 @@
     </p:spTree>
     <p:extLst>
       <p:ext uri="{BB962C8B-B14F-4D97-AF65-F5344CB8AC3E}">
-        <p14:creationId xmlns:p14="http://schemas.microsoft.com/office/powerpoint/2010/main" val="1894826526"/>
+        <p14:creationId xmlns:p14="http://schemas.microsoft.com/office/powerpoint/2010/main" val="849775188"/>
       </p:ext>
     </p:extLst>
   </p:cSld>
@@ -9951,7 +9953,7 @@
           <p:cNvPr id="9" name="">
             <a:extLst xmlns:a="http://schemas.openxmlformats.org/drawingml/2006/main">
               <a:ext uri="{FF2B5EF4-FFF2-40B4-BE49-F238E27FC236}">
-                <a16:creationId xmlns:a16="http://schemas.microsoft.com/office/drawing/2014/main" id="{0C6B0993-AF14-4114-B0AC-022B49E68F9F}"/>
+                <a16:creationId xmlns:a16="http://schemas.microsoft.com/office/drawing/2014/main" id="{533CE642-363F-41C2-B51A-48551107EB76}"/>
               </a:ext>
             </a:extLst>
           </p:cNvPr>
@@ -10017,7 +10019,7 @@
           <p:cNvPr id="2" name="">
             <a:extLst xmlns:a="http://schemas.openxmlformats.org/drawingml/2006/main">
               <a:ext uri="{FF2B5EF4-FFF2-40B4-BE49-F238E27FC236}">
-                <a16:creationId xmlns:a16="http://schemas.microsoft.com/office/drawing/2014/main" id="{DBC742CA-B495-4F8D-A986-82ACD6F77A4B}"/>
+                <a16:creationId xmlns:a16="http://schemas.microsoft.com/office/drawing/2014/main" id="{5D3C71B5-1CBF-4221-98AD-3C8BBBE53140}"/>
               </a:ext>
             </a:extLst>
           </p:cNvPr>
@@ -10083,7 +10085,7 @@
           <p:cNvPr id="3" name="">
             <a:extLst xmlns:a="http://schemas.openxmlformats.org/drawingml/2006/main">
               <a:ext uri="{FF2B5EF4-FFF2-40B4-BE49-F238E27FC236}">
-                <a16:creationId xmlns:a16="http://schemas.microsoft.com/office/drawing/2014/main" id="{D4D7D111-6FEA-4567-91FE-D7AD7F4A7EF9}"/>
+                <a16:creationId xmlns:a16="http://schemas.microsoft.com/office/drawing/2014/main" id="{8422CBF2-00E3-4AF9-ADBE-70B854C710F2}"/>
               </a:ext>
             </a:extLst>
           </p:cNvPr>
@@ -10149,7 +10151,7 @@
           <p:cNvPr id="4" name="">
             <a:extLst xmlns:a="http://schemas.openxmlformats.org/drawingml/2006/main">
               <a:ext uri="{FF2B5EF4-FFF2-40B4-BE49-F238E27FC236}">
-                <a16:creationId xmlns:a16="http://schemas.microsoft.com/office/drawing/2014/main" id="{152F6FBF-D787-4111-91A7-FB839FB9C35F}"/>
+                <a16:creationId xmlns:a16="http://schemas.microsoft.com/office/drawing/2014/main" id="{55A85CF4-F745-4D65-AE39-C8F8EAE1A870}"/>
               </a:ext>
             </a:extLst>
           </p:cNvPr>
@@ -10215,7 +10217,7 @@
           <p:cNvPr id="5" name="">
             <a:extLst xmlns:a="http://schemas.openxmlformats.org/drawingml/2006/main">
               <a:ext uri="{FF2B5EF4-FFF2-40B4-BE49-F238E27FC236}">
-                <a16:creationId xmlns:a16="http://schemas.microsoft.com/office/drawing/2014/main" id="{B75BDF48-854A-4C6F-8DD0-671FFBD216DA}"/>
+                <a16:creationId xmlns:a16="http://schemas.microsoft.com/office/drawing/2014/main" id="{C4DFD651-C885-48FC-9092-84A1DE8AD306}"/>
               </a:ext>
             </a:extLst>
           </p:cNvPr>
@@ -10337,7 +10339,7 @@
           <p:cNvPr id="6" name="">
             <a:extLst xmlns:a="http://schemas.openxmlformats.org/drawingml/2006/main">
               <a:ext uri="{FF2B5EF4-FFF2-40B4-BE49-F238E27FC236}">
-                <a16:creationId xmlns:a16="http://schemas.microsoft.com/office/drawing/2014/main" id="{01BFDF2E-2710-43E5-8EAC-7DA89E565162}"/>
+                <a16:creationId xmlns:a16="http://schemas.microsoft.com/office/drawing/2014/main" id="{6859D21A-6643-4145-AED9-786207D36B78}"/>
               </a:ext>
             </a:extLst>
           </p:cNvPr>
@@ -10403,7 +10405,7 @@
           <p:cNvPr id="7" name="">
             <a:extLst xmlns:a="http://schemas.openxmlformats.org/drawingml/2006/main">
               <a:ext uri="{FF2B5EF4-FFF2-40B4-BE49-F238E27FC236}">
-                <a16:creationId xmlns:a16="http://schemas.microsoft.com/office/drawing/2014/main" id="{D210EED8-B593-499B-B89E-E1B8D6644BA0}"/>
+                <a16:creationId xmlns:a16="http://schemas.microsoft.com/office/drawing/2014/main" id="{AADB24E7-6DBB-4763-84EE-077D0433E510}"/>
               </a:ext>
             </a:extLst>
           </p:cNvPr>
@@ -10525,7 +10527,7 @@
           <p:cNvPr id="8" name="">
             <a:extLst xmlns:a="http://schemas.openxmlformats.org/drawingml/2006/main">
               <a:ext uri="{FF2B5EF4-FFF2-40B4-BE49-F238E27FC236}">
-                <a16:creationId xmlns:a16="http://schemas.microsoft.com/office/drawing/2014/main" id="{A5E870BC-A035-46AA-B296-898EDF110A0A}"/>
+                <a16:creationId xmlns:a16="http://schemas.microsoft.com/office/drawing/2014/main" id="{08DBC8BD-6E7E-4D36-8B11-152AAA230B8A}"/>
               </a:ext>
             </a:extLst>
           </p:cNvPr>
@@ -10589,7 +10591,7 @@
     </p:spTree>
     <p:extLst>
       <p:ext uri="{BB962C8B-B14F-4D97-AF65-F5344CB8AC3E}">
-        <p14:creationId xmlns:p14="http://schemas.microsoft.com/office/powerpoint/2010/main" val="852954804"/>
+        <p14:creationId xmlns:p14="http://schemas.microsoft.com/office/powerpoint/2010/main" val="1067060481"/>
       </p:ext>
     </p:extLst>
   </p:cSld>
@@ -10620,7 +10622,7 @@
           <p:cNvPr id="10" name="">
             <a:extLst xmlns:a="http://schemas.openxmlformats.org/drawingml/2006/main">
               <a:ext uri="{FF2B5EF4-FFF2-40B4-BE49-F238E27FC236}">
-                <a16:creationId xmlns:a16="http://schemas.microsoft.com/office/drawing/2014/main" id="{948B3E63-3351-49A4-A0B7-61029F2F3D69}"/>
+                <a16:creationId xmlns:a16="http://schemas.microsoft.com/office/drawing/2014/main" id="{4F98BBBA-E8D4-45D4-A1D9-FF1ED62B16BC}"/>
               </a:ext>
             </a:extLst>
           </p:cNvPr>
@@ -10686,7 +10688,7 @@
           <p:cNvPr id="2" name="">
             <a:extLst xmlns:a="http://schemas.openxmlformats.org/drawingml/2006/main">
               <a:ext uri="{FF2B5EF4-FFF2-40B4-BE49-F238E27FC236}">
-                <a16:creationId xmlns:a16="http://schemas.microsoft.com/office/drawing/2014/main" id="{625F2219-8AE5-4CDC-8695-A279E4BE48AF}"/>
+                <a16:creationId xmlns:a16="http://schemas.microsoft.com/office/drawing/2014/main" id="{3C1BD6E9-8F70-41C0-8E54-C9D77013C840}"/>
               </a:ext>
             </a:extLst>
           </p:cNvPr>
@@ -10752,7 +10754,7 @@
           <p:cNvPr id="3" name="">
             <a:extLst xmlns:a="http://schemas.openxmlformats.org/drawingml/2006/main">
               <a:ext uri="{FF2B5EF4-FFF2-40B4-BE49-F238E27FC236}">
-                <a16:creationId xmlns:a16="http://schemas.microsoft.com/office/drawing/2014/main" id="{EA133C32-3C14-4DF7-8A35-803151B2119A}"/>
+                <a16:creationId xmlns:a16="http://schemas.microsoft.com/office/drawing/2014/main" id="{F3F6095A-A619-4C1F-A690-D5276DC30916}"/>
               </a:ext>
             </a:extLst>
           </p:cNvPr>
@@ -10818,7 +10820,7 @@
           <p:cNvPr id="4" name="">
             <a:extLst xmlns:a="http://schemas.openxmlformats.org/drawingml/2006/main">
               <a:ext uri="{FF2B5EF4-FFF2-40B4-BE49-F238E27FC236}">
-                <a16:creationId xmlns:a16="http://schemas.microsoft.com/office/drawing/2014/main" id="{44A2B04B-BB9A-48E7-AA96-0BEDEDBEA2B8}"/>
+                <a16:creationId xmlns:a16="http://schemas.microsoft.com/office/drawing/2014/main" id="{709FDFE8-38FC-42C1-B37A-BABCB72B4980}"/>
               </a:ext>
             </a:extLst>
           </p:cNvPr>
@@ -10828,7 +10830,7 @@
           <p:nvPr/>
         </p:nvPicPr>
         <p:blipFill>
-          <a:blip xmlns:r="http://schemas.openxmlformats.org/officeDocument/2006/relationships" xmlns:a="http://schemas.openxmlformats.org/drawingml/2006/main" r:embed="R16ba947ac3d742e2"/>
+          <a:blip xmlns:r="http://schemas.openxmlformats.org/officeDocument/2006/relationships" xmlns:a="http://schemas.openxmlformats.org/drawingml/2006/main" r:embed="R116a9b6e60c041fa"/>
           <a:stretch xmlns:a="http://schemas.openxmlformats.org/drawingml/2006/main"/>
         </p:blipFill>
         <p:spPr>
@@ -10846,7 +10848,7 @@
           <p:cNvPr id="5" name="">
             <a:extLst xmlns:a="http://schemas.openxmlformats.org/drawingml/2006/main">
               <a:ext uri="{FF2B5EF4-FFF2-40B4-BE49-F238E27FC236}">
-                <a16:creationId xmlns:a16="http://schemas.microsoft.com/office/drawing/2014/main" id="{BEE110CE-CEEF-4331-A66A-C04CAE27CD5A}"/>
+                <a16:creationId xmlns:a16="http://schemas.microsoft.com/office/drawing/2014/main" id="{2EB2EB47-94E9-436D-9A7A-3C3FFEF1F216}"/>
               </a:ext>
             </a:extLst>
           </p:cNvPr>
@@ -10912,7 +10914,7 @@
           <p:cNvPr id="6" name="">
             <a:extLst xmlns:a="http://schemas.openxmlformats.org/drawingml/2006/main">
               <a:ext uri="{FF2B5EF4-FFF2-40B4-BE49-F238E27FC236}">
-                <a16:creationId xmlns:a16="http://schemas.microsoft.com/office/drawing/2014/main" id="{7D7BB751-3F8D-49D8-824A-666013975E8A}"/>
+                <a16:creationId xmlns:a16="http://schemas.microsoft.com/office/drawing/2014/main" id="{8E89A46A-0917-4958-9509-916B9B956E35}"/>
               </a:ext>
             </a:extLst>
           </p:cNvPr>
@@ -10978,7 +10980,7 @@
           <p:cNvPr id="7" name="">
             <a:extLst xmlns:a="http://schemas.openxmlformats.org/drawingml/2006/main">
               <a:ext uri="{FF2B5EF4-FFF2-40B4-BE49-F238E27FC236}">
-                <a16:creationId xmlns:a16="http://schemas.microsoft.com/office/drawing/2014/main" id="{333765B0-32FB-45B8-B58A-091769AF843D}"/>
+                <a16:creationId xmlns:a16="http://schemas.microsoft.com/office/drawing/2014/main" id="{EB5591A0-9738-40DF-8528-CB88079C7562}"/>
               </a:ext>
             </a:extLst>
           </p:cNvPr>
@@ -11044,7 +11046,7 @@
           <p:cNvPr id="8" name="">
             <a:extLst xmlns:a="http://schemas.openxmlformats.org/drawingml/2006/main">
               <a:ext uri="{FF2B5EF4-FFF2-40B4-BE49-F238E27FC236}">
-                <a16:creationId xmlns:a16="http://schemas.microsoft.com/office/drawing/2014/main" id="{2E640E5D-EF7C-4979-A847-DDF770F2A18A}"/>
+                <a16:creationId xmlns:a16="http://schemas.microsoft.com/office/drawing/2014/main" id="{A01DB692-00FC-4BAA-A6D1-AAC5411FD1A1}"/>
               </a:ext>
             </a:extLst>
           </p:cNvPr>
@@ -11110,7 +11112,7 @@
           <p:cNvPr id="9" name="">
             <a:extLst xmlns:a="http://schemas.openxmlformats.org/drawingml/2006/main">
               <a:ext uri="{FF2B5EF4-FFF2-40B4-BE49-F238E27FC236}">
-                <a16:creationId xmlns:a16="http://schemas.microsoft.com/office/drawing/2014/main" id="{0D347EF8-D80A-4BBE-8D78-09F9A884BD86}"/>
+                <a16:creationId xmlns:a16="http://schemas.microsoft.com/office/drawing/2014/main" id="{4C7947E4-209F-40FB-B599-69C4965726A9}"/>
               </a:ext>
             </a:extLst>
           </p:cNvPr>
@@ -11174,7 +11176,7 @@
     </p:spTree>
     <p:extLst>
       <p:ext uri="{BB962C8B-B14F-4D97-AF65-F5344CB8AC3E}">
-        <p14:creationId xmlns:p14="http://schemas.microsoft.com/office/powerpoint/2010/main" val="1730758473"/>
+        <p14:creationId xmlns:p14="http://schemas.microsoft.com/office/powerpoint/2010/main" val="1181490070"/>
       </p:ext>
     </p:extLst>
   </p:cSld>
@@ -11205,7 +11207,7 @@
           <p:cNvPr id="16" name="">
             <a:extLst xmlns:a="http://schemas.openxmlformats.org/drawingml/2006/main">
               <a:ext uri="{FF2B5EF4-FFF2-40B4-BE49-F238E27FC236}">
-                <a16:creationId xmlns:a16="http://schemas.microsoft.com/office/drawing/2014/main" id="{07C96444-7725-4D0E-B3BF-01B744231A35}"/>
+                <a16:creationId xmlns:a16="http://schemas.microsoft.com/office/drawing/2014/main" id="{1A1523F9-9CFF-4571-A0C6-F29F19FCB695}"/>
               </a:ext>
             </a:extLst>
           </p:cNvPr>
@@ -11271,7 +11273,7 @@
           <p:cNvPr id="2" name="">
             <a:extLst xmlns:a="http://schemas.openxmlformats.org/drawingml/2006/main">
               <a:ext uri="{FF2B5EF4-FFF2-40B4-BE49-F238E27FC236}">
-                <a16:creationId xmlns:a16="http://schemas.microsoft.com/office/drawing/2014/main" id="{E253CB9F-3337-4742-93D6-3D5C82E36A23}"/>
+                <a16:creationId xmlns:a16="http://schemas.microsoft.com/office/drawing/2014/main" id="{03E5DDEF-5205-476B-A0F3-AA5CFA7B95BB}"/>
               </a:ext>
             </a:extLst>
           </p:cNvPr>
@@ -11337,7 +11339,7 @@
           <p:cNvPr id="3" name="">
             <a:extLst xmlns:a="http://schemas.openxmlformats.org/drawingml/2006/main">
               <a:ext uri="{FF2B5EF4-FFF2-40B4-BE49-F238E27FC236}">
-                <a16:creationId xmlns:a16="http://schemas.microsoft.com/office/drawing/2014/main" id="{4B249506-E712-45CF-AB93-75ECF2E65D65}"/>
+                <a16:creationId xmlns:a16="http://schemas.microsoft.com/office/drawing/2014/main" id="{F274860D-AF1E-4804-9F4D-45CBB28C9A1B}"/>
               </a:ext>
             </a:extLst>
           </p:cNvPr>
@@ -11403,7 +11405,7 @@
           <p:cNvPr id="4" name="">
             <a:extLst xmlns:a="http://schemas.openxmlformats.org/drawingml/2006/main">
               <a:ext uri="{FF2B5EF4-FFF2-40B4-BE49-F238E27FC236}">
-                <a16:creationId xmlns:a16="http://schemas.microsoft.com/office/drawing/2014/main" id="{20606DA0-20E6-4AF1-B31D-3AB74880719D}"/>
+                <a16:creationId xmlns:a16="http://schemas.microsoft.com/office/drawing/2014/main" id="{EDFFFE67-743B-40E6-B71C-8B3AC21C858A}"/>
               </a:ext>
             </a:extLst>
           </p:cNvPr>
@@ -11469,7 +11471,7 @@
           <p:cNvPr id="5" name="">
             <a:extLst xmlns:a="http://schemas.openxmlformats.org/drawingml/2006/main">
               <a:ext uri="{FF2B5EF4-FFF2-40B4-BE49-F238E27FC236}">
-                <a16:creationId xmlns:a16="http://schemas.microsoft.com/office/drawing/2014/main" id="{2B67ECC5-91EF-49EA-8013-9731BAFE0122}"/>
+                <a16:creationId xmlns:a16="http://schemas.microsoft.com/office/drawing/2014/main" id="{73DAAA4E-F6C6-4BD4-93E9-D1BCAE56F7E5}"/>
               </a:ext>
             </a:extLst>
           </p:cNvPr>
@@ -11535,7 +11537,7 @@
           <p:cNvPr id="6" name="">
             <a:extLst xmlns:a="http://schemas.openxmlformats.org/drawingml/2006/main">
               <a:ext uri="{FF2B5EF4-FFF2-40B4-BE49-F238E27FC236}">
-                <a16:creationId xmlns:a16="http://schemas.microsoft.com/office/drawing/2014/main" id="{9A28FEAF-3546-459A-8890-90CA90DC4DF1}"/>
+                <a16:creationId xmlns:a16="http://schemas.microsoft.com/office/drawing/2014/main" id="{8601033C-900D-42AC-8CF4-A89F5B05CE96}"/>
               </a:ext>
             </a:extLst>
           </p:cNvPr>
@@ -11601,7 +11603,7 @@
           <p:cNvPr id="7" name="">
             <a:extLst xmlns:a="http://schemas.openxmlformats.org/drawingml/2006/main">
               <a:ext uri="{FF2B5EF4-FFF2-40B4-BE49-F238E27FC236}">
-                <a16:creationId xmlns:a16="http://schemas.microsoft.com/office/drawing/2014/main" id="{16DDED9B-005A-49FA-A1EC-D6BB4611A67C}"/>
+                <a16:creationId xmlns:a16="http://schemas.microsoft.com/office/drawing/2014/main" id="{4AF52E71-635B-4F72-AC1E-0127396682DE}"/>
               </a:ext>
             </a:extLst>
           </p:cNvPr>
@@ -11667,7 +11669,7 @@
           <p:cNvPr id="8" name="">
             <a:extLst xmlns:a="http://schemas.openxmlformats.org/drawingml/2006/main">
               <a:ext uri="{FF2B5EF4-FFF2-40B4-BE49-F238E27FC236}">
-                <a16:creationId xmlns:a16="http://schemas.microsoft.com/office/drawing/2014/main" id="{3E09385E-E1C3-4C6D-AF76-BD625F05C669}"/>
+                <a16:creationId xmlns:a16="http://schemas.microsoft.com/office/drawing/2014/main" id="{90995B83-2A86-4E39-BD9A-74140613A468}"/>
               </a:ext>
             </a:extLst>
           </p:cNvPr>
@@ -11733,7 +11735,7 @@
           <p:cNvPr id="9" name="">
             <a:extLst xmlns:a="http://schemas.openxmlformats.org/drawingml/2006/main">
               <a:ext uri="{FF2B5EF4-FFF2-40B4-BE49-F238E27FC236}">
-                <a16:creationId xmlns:a16="http://schemas.microsoft.com/office/drawing/2014/main" id="{F193E4FE-FE04-4B44-89C9-1769A7231B44}"/>
+                <a16:creationId xmlns:a16="http://schemas.microsoft.com/office/drawing/2014/main" id="{54AD4C86-8DF6-4AAC-9D4D-8B5FD09BDC10}"/>
               </a:ext>
             </a:extLst>
           </p:cNvPr>
@@ -11799,7 +11801,7 @@
           <p:cNvPr id="10" name="">
             <a:extLst xmlns:a="http://schemas.openxmlformats.org/drawingml/2006/main">
               <a:ext uri="{FF2B5EF4-FFF2-40B4-BE49-F238E27FC236}">
-                <a16:creationId xmlns:a16="http://schemas.microsoft.com/office/drawing/2014/main" id="{863A41D8-79A1-49E3-951A-B0E44751ED82}"/>
+                <a16:creationId xmlns:a16="http://schemas.microsoft.com/office/drawing/2014/main" id="{19A9FB67-DC60-4B21-84D4-7CB50FD8C8CA}"/>
               </a:ext>
             </a:extLst>
           </p:cNvPr>
@@ -11865,7 +11867,7 @@
           <p:cNvPr id="11" name="">
             <a:extLst xmlns:a="http://schemas.openxmlformats.org/drawingml/2006/main">
               <a:ext uri="{FF2B5EF4-FFF2-40B4-BE49-F238E27FC236}">
-                <a16:creationId xmlns:a16="http://schemas.microsoft.com/office/drawing/2014/main" id="{240F36C3-80FA-4631-83EC-3F936F213168}"/>
+                <a16:creationId xmlns:a16="http://schemas.microsoft.com/office/drawing/2014/main" id="{8EA6561F-24C2-4507-8038-2D71F7439438}"/>
               </a:ext>
             </a:extLst>
           </p:cNvPr>
@@ -11931,7 +11933,7 @@
           <p:cNvPr id="12" name="">
             <a:extLst xmlns:a="http://schemas.openxmlformats.org/drawingml/2006/main">
               <a:ext uri="{FF2B5EF4-FFF2-40B4-BE49-F238E27FC236}">
-                <a16:creationId xmlns:a16="http://schemas.microsoft.com/office/drawing/2014/main" id="{281DA35D-8005-467F-A67E-B2A7F2B0AC13}"/>
+                <a16:creationId xmlns:a16="http://schemas.microsoft.com/office/drawing/2014/main" id="{1AA47694-5ED9-433D-BB3E-1EFA53F75B4A}"/>
               </a:ext>
             </a:extLst>
           </p:cNvPr>
@@ -11997,7 +11999,7 @@
           <p:cNvPr id="13" name="">
             <a:extLst xmlns:a="http://schemas.openxmlformats.org/drawingml/2006/main">
               <a:ext uri="{FF2B5EF4-FFF2-40B4-BE49-F238E27FC236}">
-                <a16:creationId xmlns:a16="http://schemas.microsoft.com/office/drawing/2014/main" id="{319EEFB6-F8E9-4DC9-BC1C-36074015CCAF}"/>
+                <a16:creationId xmlns:a16="http://schemas.microsoft.com/office/drawing/2014/main" id="{A2BD2750-225D-44BE-9972-8F52C218A9AF}"/>
               </a:ext>
             </a:extLst>
           </p:cNvPr>
@@ -12063,7 +12065,7 @@
           <p:cNvPr id="14" name="">
             <a:extLst xmlns:a="http://schemas.openxmlformats.org/drawingml/2006/main">
               <a:ext uri="{FF2B5EF4-FFF2-40B4-BE49-F238E27FC236}">
-                <a16:creationId xmlns:a16="http://schemas.microsoft.com/office/drawing/2014/main" id="{A53F3723-FB91-4E19-9B63-0FFA6ED6AC0A}"/>
+                <a16:creationId xmlns:a16="http://schemas.microsoft.com/office/drawing/2014/main" id="{AC0E8B69-F4AB-4E86-BE2A-5A48ABB3B6F2}"/>
               </a:ext>
             </a:extLst>
           </p:cNvPr>
@@ -12129,7 +12131,7 @@
           <p:cNvPr id="15" name="">
             <a:extLst xmlns:a="http://schemas.openxmlformats.org/drawingml/2006/main">
               <a:ext uri="{FF2B5EF4-FFF2-40B4-BE49-F238E27FC236}">
-                <a16:creationId xmlns:a16="http://schemas.microsoft.com/office/drawing/2014/main" id="{91D9B62F-B6AD-4517-AC81-A79A2319250A}"/>
+                <a16:creationId xmlns:a16="http://schemas.microsoft.com/office/drawing/2014/main" id="{13A23F26-39B6-4BE3-97B7-E925DFF27E57}"/>
               </a:ext>
             </a:extLst>
           </p:cNvPr>
@@ -12193,7 +12195,7 @@
     </p:spTree>
     <p:extLst>
       <p:ext uri="{BB962C8B-B14F-4D97-AF65-F5344CB8AC3E}">
-        <p14:creationId xmlns:p14="http://schemas.microsoft.com/office/powerpoint/2010/main" val="944770522"/>
+        <p14:creationId xmlns:p14="http://schemas.microsoft.com/office/powerpoint/2010/main" val="1532861508"/>
       </p:ext>
     </p:extLst>
   </p:cSld>
@@ -12224,7 +12226,7 @@
           <p:cNvPr id="17" name="">
             <a:extLst xmlns:a="http://schemas.openxmlformats.org/drawingml/2006/main">
               <a:ext uri="{FF2B5EF4-FFF2-40B4-BE49-F238E27FC236}">
-                <a16:creationId xmlns:a16="http://schemas.microsoft.com/office/drawing/2014/main" id="{D400D42F-88A2-4272-9A77-C34EB42F1EF5}"/>
+                <a16:creationId xmlns:a16="http://schemas.microsoft.com/office/drawing/2014/main" id="{A5C4B266-10A2-4560-AF64-EA92F2B0C261}"/>
               </a:ext>
             </a:extLst>
           </p:cNvPr>
@@ -12290,7 +12292,7 @@
           <p:cNvPr id="2" name="">
             <a:extLst xmlns:a="http://schemas.openxmlformats.org/drawingml/2006/main">
               <a:ext uri="{FF2B5EF4-FFF2-40B4-BE49-F238E27FC236}">
-                <a16:creationId xmlns:a16="http://schemas.microsoft.com/office/drawing/2014/main" id="{78A5EB56-F962-4053-BF48-102B4812F616}"/>
+                <a16:creationId xmlns:a16="http://schemas.microsoft.com/office/drawing/2014/main" id="{555ED2C4-9A38-415C-8F56-9154B4B11359}"/>
               </a:ext>
             </a:extLst>
           </p:cNvPr>
@@ -12356,7 +12358,7 @@
           <p:cNvPr id="3" name="">
             <a:extLst xmlns:a="http://schemas.openxmlformats.org/drawingml/2006/main">
               <a:ext uri="{FF2B5EF4-FFF2-40B4-BE49-F238E27FC236}">
-                <a16:creationId xmlns:a16="http://schemas.microsoft.com/office/drawing/2014/main" id="{8C4A2155-C080-4393-89CB-655F43E4A4F5}"/>
+                <a16:creationId xmlns:a16="http://schemas.microsoft.com/office/drawing/2014/main" id="{30FBF512-923B-44E3-88C9-577278A35F84}"/>
               </a:ext>
             </a:extLst>
           </p:cNvPr>
@@ -12422,7 +12424,7 @@
           <p:cNvPr id="4" name="">
             <a:extLst xmlns:a="http://schemas.openxmlformats.org/drawingml/2006/main">
               <a:ext uri="{FF2B5EF4-FFF2-40B4-BE49-F238E27FC236}">
-                <a16:creationId xmlns:a16="http://schemas.microsoft.com/office/drawing/2014/main" id="{4454D696-6EDC-46B1-B859-0FF3A2982118}"/>
+                <a16:creationId xmlns:a16="http://schemas.microsoft.com/office/drawing/2014/main" id="{261AF5AB-B9AD-4C9D-B763-89F2D6590C1F}"/>
               </a:ext>
             </a:extLst>
           </p:cNvPr>
@@ -12488,7 +12490,7 @@
           <p:cNvPr id="5" name="">
             <a:extLst xmlns:a="http://schemas.openxmlformats.org/drawingml/2006/main">
               <a:ext uri="{FF2B5EF4-FFF2-40B4-BE49-F238E27FC236}">
-                <a16:creationId xmlns:a16="http://schemas.microsoft.com/office/drawing/2014/main" id="{0206DD72-3667-46DB-A106-E0E7BF14C1E9}"/>
+                <a16:creationId xmlns:a16="http://schemas.microsoft.com/office/drawing/2014/main" id="{B7235375-DEC6-48D2-AE58-62CC17230A35}"/>
               </a:ext>
             </a:extLst>
           </p:cNvPr>
@@ -12554,7 +12556,7 @@
           <p:cNvPr id="6" name="">
             <a:extLst xmlns:a="http://schemas.openxmlformats.org/drawingml/2006/main">
               <a:ext uri="{FF2B5EF4-FFF2-40B4-BE49-F238E27FC236}">
-                <a16:creationId xmlns:a16="http://schemas.microsoft.com/office/drawing/2014/main" id="{20799059-57DD-4E19-A5A2-4777AB86D467}"/>
+                <a16:creationId xmlns:a16="http://schemas.microsoft.com/office/drawing/2014/main" id="{F2234585-C377-4B0F-8776-C434E5E44386}"/>
               </a:ext>
             </a:extLst>
           </p:cNvPr>
@@ -12620,7 +12622,7 @@
           <p:cNvPr id="7" name="">
             <a:extLst xmlns:a="http://schemas.openxmlformats.org/drawingml/2006/main">
               <a:ext uri="{FF2B5EF4-FFF2-40B4-BE49-F238E27FC236}">
-                <a16:creationId xmlns:a16="http://schemas.microsoft.com/office/drawing/2014/main" id="{545246A1-2163-44AC-B97D-5E20D9D8DCF9}"/>
+                <a16:creationId xmlns:a16="http://schemas.microsoft.com/office/drawing/2014/main" id="{899A3EE8-0993-44EC-9C36-18A3B198A13F}"/>
               </a:ext>
             </a:extLst>
           </p:cNvPr>
@@ -12686,7 +12688,7 @@
           <p:cNvPr id="8" name="">
             <a:extLst xmlns:a="http://schemas.openxmlformats.org/drawingml/2006/main">
               <a:ext uri="{FF2B5EF4-FFF2-40B4-BE49-F238E27FC236}">
-                <a16:creationId xmlns:a16="http://schemas.microsoft.com/office/drawing/2014/main" id="{DF624878-D4D1-4220-B16D-33C62349F58D}"/>
+                <a16:creationId xmlns:a16="http://schemas.microsoft.com/office/drawing/2014/main" id="{6649C342-F382-4A82-A2C1-F56B705864C8}"/>
               </a:ext>
             </a:extLst>
           </p:cNvPr>
@@ -12752,7 +12754,7 @@
           <p:cNvPr id="9" name="">
             <a:extLst xmlns:a="http://schemas.openxmlformats.org/drawingml/2006/main">
               <a:ext uri="{FF2B5EF4-FFF2-40B4-BE49-F238E27FC236}">
-                <a16:creationId xmlns:a16="http://schemas.microsoft.com/office/drawing/2014/main" id="{56463E61-53DB-4BF6-9751-63D6B1B42578}"/>
+                <a16:creationId xmlns:a16="http://schemas.microsoft.com/office/drawing/2014/main" id="{07C2BDE8-0DCE-4037-BFE4-1BB4E6976A31}"/>
               </a:ext>
             </a:extLst>
           </p:cNvPr>
@@ -12818,7 +12820,7 @@
           <p:cNvPr id="10" name="">
             <a:extLst xmlns:a="http://schemas.openxmlformats.org/drawingml/2006/main">
               <a:ext uri="{FF2B5EF4-FFF2-40B4-BE49-F238E27FC236}">
-                <a16:creationId xmlns:a16="http://schemas.microsoft.com/office/drawing/2014/main" id="{C4929CB9-57CD-4916-B164-F8A6822795F3}"/>
+                <a16:creationId xmlns:a16="http://schemas.microsoft.com/office/drawing/2014/main" id="{327DEA05-B9AF-4D7A-8F02-232073BA1328}"/>
               </a:ext>
             </a:extLst>
           </p:cNvPr>
@@ -12884,7 +12886,7 @@
           <p:cNvPr id="11" name="">
             <a:extLst xmlns:a="http://schemas.openxmlformats.org/drawingml/2006/main">
               <a:ext uri="{FF2B5EF4-FFF2-40B4-BE49-F238E27FC236}">
-                <a16:creationId xmlns:a16="http://schemas.microsoft.com/office/drawing/2014/main" id="{BF2E58A9-A9CA-45B2-8D78-99E773230727}"/>
+                <a16:creationId xmlns:a16="http://schemas.microsoft.com/office/drawing/2014/main" id="{A5C35DE0-42B3-45AA-9A54-C4358E5DA15A}"/>
               </a:ext>
             </a:extLst>
           </p:cNvPr>
@@ -12950,7 +12952,7 @@
           <p:cNvPr id="12" name="">
             <a:extLst xmlns:a="http://schemas.openxmlformats.org/drawingml/2006/main">
               <a:ext uri="{FF2B5EF4-FFF2-40B4-BE49-F238E27FC236}">
-                <a16:creationId xmlns:a16="http://schemas.microsoft.com/office/drawing/2014/main" id="{D56BC98E-22FA-485C-BA6F-FD42D81E9FC2}"/>
+                <a16:creationId xmlns:a16="http://schemas.microsoft.com/office/drawing/2014/main" id="{7514E4A1-8ECB-4E5A-BE19-0E70CC7EE03B}"/>
               </a:ext>
             </a:extLst>
           </p:cNvPr>
@@ -13016,7 +13018,7 @@
           <p:cNvPr id="13" name="">
             <a:extLst xmlns:a="http://schemas.openxmlformats.org/drawingml/2006/main">
               <a:ext uri="{FF2B5EF4-FFF2-40B4-BE49-F238E27FC236}">
-                <a16:creationId xmlns:a16="http://schemas.microsoft.com/office/drawing/2014/main" id="{FA366088-97BC-4B2B-BE3F-DF875B3521F6}"/>
+                <a16:creationId xmlns:a16="http://schemas.microsoft.com/office/drawing/2014/main" id="{AA26BD4C-0A42-435A-8050-E2BBCE169876}"/>
               </a:ext>
             </a:extLst>
           </p:cNvPr>
@@ -13082,7 +13084,7 @@
           <p:cNvPr id="14" name="">
             <a:extLst xmlns:a="http://schemas.openxmlformats.org/drawingml/2006/main">
               <a:ext uri="{FF2B5EF4-FFF2-40B4-BE49-F238E27FC236}">
-                <a16:creationId xmlns:a16="http://schemas.microsoft.com/office/drawing/2014/main" id="{E720A513-53EB-4876-883D-3E011FE4C91D}"/>
+                <a16:creationId xmlns:a16="http://schemas.microsoft.com/office/drawing/2014/main" id="{B7862670-F946-4B78-B495-D460A9BE9F2F}"/>
               </a:ext>
             </a:extLst>
           </p:cNvPr>
@@ -13148,7 +13150,7 @@
           <p:cNvPr id="15" name="">
             <a:extLst xmlns:a="http://schemas.openxmlformats.org/drawingml/2006/main">
               <a:ext uri="{FF2B5EF4-FFF2-40B4-BE49-F238E27FC236}">
-                <a16:creationId xmlns:a16="http://schemas.microsoft.com/office/drawing/2014/main" id="{FDAFDB9B-9EA5-4DA6-B4B3-E06AE64CB39A}"/>
+                <a16:creationId xmlns:a16="http://schemas.microsoft.com/office/drawing/2014/main" id="{DD2B3E2B-2306-4060-9D4A-DAE646426520}"/>
               </a:ext>
             </a:extLst>
           </p:cNvPr>
@@ -13214,7 +13216,7 @@
           <p:cNvPr id="16" name="">
             <a:extLst xmlns:a="http://schemas.openxmlformats.org/drawingml/2006/main">
               <a:ext uri="{FF2B5EF4-FFF2-40B4-BE49-F238E27FC236}">
-                <a16:creationId xmlns:a16="http://schemas.microsoft.com/office/drawing/2014/main" id="{5EAF49C8-A88E-46EF-8DC5-00BEAE7AC166}"/>
+                <a16:creationId xmlns:a16="http://schemas.microsoft.com/office/drawing/2014/main" id="{00A4A0A4-BFFA-467A-BAF3-DCCE9D4F919E}"/>
               </a:ext>
             </a:extLst>
           </p:cNvPr>
@@ -13278,7 +13280,7 @@
     </p:spTree>
     <p:extLst>
       <p:ext uri="{BB962C8B-B14F-4D97-AF65-F5344CB8AC3E}">
-        <p14:creationId xmlns:p14="http://schemas.microsoft.com/office/powerpoint/2010/main" val="1899047003"/>
+        <p14:creationId xmlns:p14="http://schemas.microsoft.com/office/powerpoint/2010/main" val="2121408965"/>
       </p:ext>
     </p:extLst>
   </p:cSld>

</xml_diff>